<commit_message>
v1.0.0 final: video demo, fix cedula vacia p05, fix campos vacios Excel
</commit_message>
<xml_diff>
--- a/Documentacion/LUC-IA-PRESENTACION MASTER.pptx
+++ b/Documentacion/LUC-IA-PRESENTACION MASTER.pptx
@@ -142,7 +142,7 @@
   <pc:docChgLst>
     <pc:chgData name="Brayand Javier Gómez Plata" userId="c9c1396e-34a9-4a12-912a-8649ffb9a204" providerId="ADAL" clId="{27F4626A-F3D0-4E6C-A104-AEA19FA55BBA}"/>
     <pc:docChg chg="undo redo custSel addSld delSld modSld sldOrd">
-      <pc:chgData name="Brayand Javier Gómez Plata" userId="c9c1396e-34a9-4a12-912a-8649ffb9a204" providerId="ADAL" clId="{27F4626A-F3D0-4E6C-A104-AEA19FA55BBA}" dt="2026-07-03T16:31:37.208" v="5252" actId="1076"/>
+      <pc:chgData name="Brayand Javier Gómez Plata" userId="c9c1396e-34a9-4a12-912a-8649ffb9a204" providerId="ADAL" clId="{27F4626A-F3D0-4E6C-A104-AEA19FA55BBA}" dt="2026-07-04T16:29:24.468" v="5326" actId="1076"/>
       <pc:docMkLst>
         <pc:docMk/>
       </pc:docMkLst>
@@ -224,151 +224,23 @@
             <ac:picMk id="4" creationId="{3354447F-E468-5641-C634-C2869BFD73C5}"/>
           </ac:picMkLst>
         </pc:picChg>
-        <pc:picChg chg="add del mod">
-          <ac:chgData name="Brayand Javier Gómez Plata" userId="c9c1396e-34a9-4a12-912a-8649ffb9a204" providerId="ADAL" clId="{27F4626A-F3D0-4E6C-A104-AEA19FA55BBA}" dt="2026-07-02T20:37:39.796" v="3216" actId="478"/>
-          <ac:picMkLst>
-            <pc:docMk/>
-            <pc:sldMk cId="0" sldId="256"/>
-            <ac:picMk id="23" creationId="{D9CDE3F3-EAD8-2113-2B77-C79B222A0EA2}"/>
-          </ac:picMkLst>
-        </pc:picChg>
       </pc:sldChg>
       <pc:sldChg chg="addSp delSp modSp mod">
-        <pc:chgData name="Brayand Javier Gómez Plata" userId="c9c1396e-34a9-4a12-912a-8649ffb9a204" providerId="ADAL" clId="{27F4626A-F3D0-4E6C-A104-AEA19FA55BBA}" dt="2026-07-02T20:39:41.109" v="3229" actId="1076"/>
+        <pc:chgData name="Brayand Javier Gómez Plata" userId="c9c1396e-34a9-4a12-912a-8649ffb9a204" providerId="ADAL" clId="{27F4626A-F3D0-4E6C-A104-AEA19FA55BBA}" dt="2026-07-04T16:29:05.491" v="5322" actId="1076"/>
         <pc:sldMkLst>
           <pc:docMk/>
           <pc:sldMk cId="0" sldId="258"/>
         </pc:sldMkLst>
-        <pc:spChg chg="del mod">
-          <ac:chgData name="Brayand Javier Gómez Plata" userId="c9c1396e-34a9-4a12-912a-8649ffb9a204" providerId="ADAL" clId="{27F4626A-F3D0-4E6C-A104-AEA19FA55BBA}" dt="2026-07-02T19:14:40.485" v="2787" actId="478"/>
+        <pc:spChg chg="add del">
+          <ac:chgData name="Brayand Javier Gómez Plata" userId="c9c1396e-34a9-4a12-912a-8649ffb9a204" providerId="ADAL" clId="{27F4626A-F3D0-4E6C-A104-AEA19FA55BBA}" dt="2026-07-04T16:20:51.027" v="5272" actId="21"/>
           <ac:spMkLst>
             <pc:docMk/>
             <pc:sldMk cId="0" sldId="258"/>
-            <ac:spMk id="4" creationId="{00000000-0000-0000-0000-000000000000}"/>
+            <ac:spMk id="3" creationId="{98B8331A-6E4A-55B8-15AE-A0734AC49613}"/>
           </ac:spMkLst>
         </pc:spChg>
-        <pc:spChg chg="add del mod">
-          <ac:chgData name="Brayand Javier Gómez Plata" userId="c9c1396e-34a9-4a12-912a-8649ffb9a204" providerId="ADAL" clId="{27F4626A-F3D0-4E6C-A104-AEA19FA55BBA}" dt="2026-07-02T19:14:40.485" v="2787" actId="478"/>
-          <ac:spMkLst>
-            <pc:docMk/>
-            <pc:sldMk cId="0" sldId="258"/>
-            <ac:spMk id="7" creationId="{EB47CF5C-5966-C4FD-65BF-6B00D4FEAE6C}"/>
-          </ac:spMkLst>
-        </pc:spChg>
-        <pc:spChg chg="add del mod">
-          <ac:chgData name="Brayand Javier Gómez Plata" userId="c9c1396e-34a9-4a12-912a-8649ffb9a204" providerId="ADAL" clId="{27F4626A-F3D0-4E6C-A104-AEA19FA55BBA}" dt="2026-07-02T19:14:40.485" v="2787" actId="478"/>
-          <ac:spMkLst>
-            <pc:docMk/>
-            <pc:sldMk cId="0" sldId="258"/>
-            <ac:spMk id="29" creationId="{DB91C46E-4A9C-1564-A4C7-C931ACD545C1}"/>
-          </ac:spMkLst>
-        </pc:spChg>
-        <pc:spChg chg="add del mod">
-          <ac:chgData name="Brayand Javier Gómez Plata" userId="c9c1396e-34a9-4a12-912a-8649ffb9a204" providerId="ADAL" clId="{27F4626A-F3D0-4E6C-A104-AEA19FA55BBA}" dt="2026-07-02T19:14:40.485" v="2787" actId="478"/>
-          <ac:spMkLst>
-            <pc:docMk/>
-            <pc:sldMk cId="0" sldId="258"/>
-            <ac:spMk id="33" creationId="{ABEE9303-9A45-A653-E242-0B9A0E6F1C5D}"/>
-          </ac:spMkLst>
-        </pc:spChg>
-        <pc:spChg chg="mod">
-          <ac:chgData name="Brayand Javier Gómez Plata" userId="c9c1396e-34a9-4a12-912a-8649ffb9a204" providerId="ADAL" clId="{27F4626A-F3D0-4E6C-A104-AEA19FA55BBA}" dt="2026-07-02T19:02:30.816" v="2652" actId="790"/>
-          <ac:spMkLst>
-            <pc:docMk/>
-            <pc:sldMk cId="0" sldId="258"/>
-            <ac:spMk id="64" creationId="{12D58D21-BADF-458A-795F-8C0802AC75B6}"/>
-          </ac:spMkLst>
-        </pc:spChg>
-        <pc:spChg chg="mod">
-          <ac:chgData name="Brayand Javier Gómez Plata" userId="c9c1396e-34a9-4a12-912a-8649ffb9a204" providerId="ADAL" clId="{27F4626A-F3D0-4E6C-A104-AEA19FA55BBA}" dt="2026-07-02T19:02:30.816" v="2652" actId="790"/>
-          <ac:spMkLst>
-            <pc:docMk/>
-            <pc:sldMk cId="0" sldId="258"/>
-            <ac:spMk id="65" creationId="{178B164F-35BA-4975-64BC-BB8D150AE71B}"/>
-          </ac:spMkLst>
-        </pc:spChg>
-        <pc:spChg chg="mod">
-          <ac:chgData name="Brayand Javier Gómez Plata" userId="c9c1396e-34a9-4a12-912a-8649ffb9a204" providerId="ADAL" clId="{27F4626A-F3D0-4E6C-A104-AEA19FA55BBA}" dt="2026-07-02T19:02:30.816" v="2652" actId="790"/>
-          <ac:spMkLst>
-            <pc:docMk/>
-            <pc:sldMk cId="0" sldId="258"/>
-            <ac:spMk id="66" creationId="{77273385-1F48-FEEC-DA1C-196678FF6B5E}"/>
-          </ac:spMkLst>
-        </pc:spChg>
-        <pc:spChg chg="mod">
-          <ac:chgData name="Brayand Javier Gómez Plata" userId="c9c1396e-34a9-4a12-912a-8649ffb9a204" providerId="ADAL" clId="{27F4626A-F3D0-4E6C-A104-AEA19FA55BBA}" dt="2026-07-02T19:02:30.816" v="2652" actId="790"/>
-          <ac:spMkLst>
-            <pc:docMk/>
-            <pc:sldMk cId="0" sldId="258"/>
-            <ac:spMk id="67" creationId="{175C3D4A-735A-2213-CD9C-C5542F832BDB}"/>
-          </ac:spMkLst>
-        </pc:spChg>
-        <pc:spChg chg="mod">
-          <ac:chgData name="Brayand Javier Gómez Plata" userId="c9c1396e-34a9-4a12-912a-8649ffb9a204" providerId="ADAL" clId="{27F4626A-F3D0-4E6C-A104-AEA19FA55BBA}" dt="2026-07-02T19:02:30.816" v="2652" actId="790"/>
-          <ac:spMkLst>
-            <pc:docMk/>
-            <pc:sldMk cId="0" sldId="258"/>
-            <ac:spMk id="68" creationId="{48A19A2D-3E47-8290-03A6-C6C5FA1299E1}"/>
-          </ac:spMkLst>
-        </pc:spChg>
-        <pc:spChg chg="mod">
-          <ac:chgData name="Brayand Javier Gómez Plata" userId="c9c1396e-34a9-4a12-912a-8649ffb9a204" providerId="ADAL" clId="{27F4626A-F3D0-4E6C-A104-AEA19FA55BBA}" dt="2026-07-02T19:02:30.816" v="2652" actId="790"/>
-          <ac:spMkLst>
-            <pc:docMk/>
-            <pc:sldMk cId="0" sldId="258"/>
-            <ac:spMk id="69" creationId="{C606B78C-B543-3296-7B27-C99789399A2B}"/>
-          </ac:spMkLst>
-        </pc:spChg>
-        <pc:spChg chg="mod">
-          <ac:chgData name="Brayand Javier Gómez Plata" userId="c9c1396e-34a9-4a12-912a-8649ffb9a204" providerId="ADAL" clId="{27F4626A-F3D0-4E6C-A104-AEA19FA55BBA}" dt="2026-07-02T19:02:30.816" v="2652" actId="790"/>
-          <ac:spMkLst>
-            <pc:docMk/>
-            <pc:sldMk cId="0" sldId="258"/>
-            <ac:spMk id="71" creationId="{3D11540D-A500-F1BA-0DC3-B515791EF160}"/>
-          </ac:spMkLst>
-        </pc:spChg>
-        <pc:spChg chg="mod">
-          <ac:chgData name="Brayand Javier Gómez Plata" userId="c9c1396e-34a9-4a12-912a-8649ffb9a204" providerId="ADAL" clId="{27F4626A-F3D0-4E6C-A104-AEA19FA55BBA}" dt="2026-07-02T19:02:30.816" v="2652" actId="790"/>
-          <ac:spMkLst>
-            <pc:docMk/>
-            <pc:sldMk cId="0" sldId="258"/>
-            <ac:spMk id="79" creationId="{4C849E6F-1820-E338-6604-2D34CFF8E60B}"/>
-          </ac:spMkLst>
-        </pc:spChg>
-        <pc:spChg chg="add del mod">
-          <ac:chgData name="Brayand Javier Gómez Plata" userId="c9c1396e-34a9-4a12-912a-8649ffb9a204" providerId="ADAL" clId="{27F4626A-F3D0-4E6C-A104-AEA19FA55BBA}" dt="2026-07-02T19:08:08.524" v="2777" actId="478"/>
-          <ac:spMkLst>
-            <pc:docMk/>
-            <pc:sldMk cId="0" sldId="258"/>
-            <ac:spMk id="82" creationId="{71955D82-BE5E-DDE4-1288-A0D0ED849159}"/>
-          </ac:spMkLst>
-        </pc:spChg>
-        <pc:grpChg chg="add del mod">
-          <ac:chgData name="Brayand Javier Gómez Plata" userId="c9c1396e-34a9-4a12-912a-8649ffb9a204" providerId="ADAL" clId="{27F4626A-F3D0-4E6C-A104-AEA19FA55BBA}" dt="2026-07-02T19:14:40.485" v="2787" actId="478"/>
-          <ac:grpSpMkLst>
-            <pc:docMk/>
-            <pc:sldMk cId="0" sldId="258"/>
-            <ac:grpSpMk id="20" creationId="{8D8D2FB3-5585-5629-C3CD-B41824A723EA}"/>
-          </ac:grpSpMkLst>
-        </pc:grpChg>
-        <pc:grpChg chg="del mod">
-          <ac:chgData name="Brayand Javier Gómez Plata" userId="c9c1396e-34a9-4a12-912a-8649ffb9a204" providerId="ADAL" clId="{27F4626A-F3D0-4E6C-A104-AEA19FA55BBA}" dt="2026-07-02T19:14:40.485" v="2787" actId="478"/>
-          <ac:grpSpMkLst>
-            <pc:docMk/>
-            <pc:sldMk cId="0" sldId="258"/>
-            <ac:grpSpMk id="60" creationId="{A68487F1-8271-4163-85AC-50B7761A8AB6}"/>
-          </ac:grpSpMkLst>
-        </pc:grpChg>
-        <pc:picChg chg="add del mod">
-          <ac:chgData name="Brayand Javier Gómez Plata" userId="c9c1396e-34a9-4a12-912a-8649ffb9a204" providerId="ADAL" clId="{27F4626A-F3D0-4E6C-A104-AEA19FA55BBA}" dt="2026-07-02T20:39:29.134" v="3225" actId="478"/>
-          <ac:picMkLst>
-            <pc:docMk/>
-            <pc:sldMk cId="0" sldId="258"/>
-            <ac:picMk id="3" creationId="{83DD2C65-49AD-ACE3-FDC1-DC92217EA686}"/>
-          </ac:picMkLst>
-        </pc:picChg>
         <pc:picChg chg="add mod">
-          <ac:chgData name="Brayand Javier Gómez Plata" userId="c9c1396e-34a9-4a12-912a-8649ffb9a204" providerId="ADAL" clId="{27F4626A-F3D0-4E6C-A104-AEA19FA55BBA}" dt="2026-07-02T19:16:31.431" v="2792" actId="1076"/>
+          <ac:chgData name="Brayand Javier Gómez Plata" userId="c9c1396e-34a9-4a12-912a-8649ffb9a204" providerId="ADAL" clId="{27F4626A-F3D0-4E6C-A104-AEA19FA55BBA}" dt="2026-07-04T16:29:05.491" v="5322" actId="1076"/>
           <ac:picMkLst>
             <pc:docMk/>
             <pc:sldMk cId="0" sldId="258"/>
@@ -391,213 +263,6 @@
             <ac:picMk id="11" creationId="{5BA6BEC8-FD90-139F-46D0-AEA5CCB4B671}"/>
           </ac:picMkLst>
         </pc:picChg>
-        <pc:picChg chg="add del mod ord modCrop">
-          <ac:chgData name="Brayand Javier Gómez Plata" userId="c9c1396e-34a9-4a12-912a-8649ffb9a204" providerId="ADAL" clId="{27F4626A-F3D0-4E6C-A104-AEA19FA55BBA}" dt="2026-07-02T19:14:38.477" v="2786" actId="478"/>
-          <ac:picMkLst>
-            <pc:docMk/>
-            <pc:sldMk cId="0" sldId="258"/>
-            <ac:picMk id="19" creationId="{8FAED253-AAA2-AFBE-D01E-8E4E83B07640}"/>
-          </ac:picMkLst>
-        </pc:picChg>
-      </pc:sldChg>
-      <pc:sldChg chg="addSp delSp modSp add del mod ord">
-        <pc:chgData name="Brayand Javier Gómez Plata" userId="c9c1396e-34a9-4a12-912a-8649ffb9a204" providerId="ADAL" clId="{27F4626A-F3D0-4E6C-A104-AEA19FA55BBA}" dt="2026-07-02T20:52:55.986" v="3908" actId="2696"/>
-        <pc:sldMkLst>
-          <pc:docMk/>
-          <pc:sldMk cId="946057066" sldId="261"/>
-        </pc:sldMkLst>
-        <pc:spChg chg="add mod">
-          <ac:chgData name="Brayand Javier Gómez Plata" userId="c9c1396e-34a9-4a12-912a-8649ffb9a204" providerId="ADAL" clId="{27F4626A-F3D0-4E6C-A104-AEA19FA55BBA}" dt="2026-07-02T20:41:26.841" v="3298" actId="20577"/>
-          <ac:spMkLst>
-            <pc:docMk/>
-            <pc:sldMk cId="946057066" sldId="261"/>
-            <ac:spMk id="3" creationId="{55080569-108E-E229-051B-D1EE8D5D21C7}"/>
-          </ac:spMkLst>
-        </pc:spChg>
-        <pc:spChg chg="add mod">
-          <ac:chgData name="Brayand Javier Gómez Plata" userId="c9c1396e-34a9-4a12-912a-8649ffb9a204" providerId="ADAL" clId="{27F4626A-F3D0-4E6C-A104-AEA19FA55BBA}" dt="2026-07-02T20:41:07.058" v="3257" actId="1076"/>
-          <ac:spMkLst>
-            <pc:docMk/>
-            <pc:sldMk cId="946057066" sldId="261"/>
-            <ac:spMk id="5" creationId="{4AAE935B-DC3C-BF20-B1E3-7A8A792BCE3B}"/>
-          </ac:spMkLst>
-        </pc:spChg>
-        <pc:spChg chg="del mod">
-          <ac:chgData name="Brayand Javier Gómez Plata" userId="c9c1396e-34a9-4a12-912a-8649ffb9a204" providerId="ADAL" clId="{27F4626A-F3D0-4E6C-A104-AEA19FA55BBA}" dt="2026-07-02T20:41:35.552" v="3300" actId="478"/>
-          <ac:spMkLst>
-            <pc:docMk/>
-            <pc:sldMk cId="946057066" sldId="261"/>
-            <ac:spMk id="7" creationId="{DBBF4E5A-1957-ADC1-4D96-2404D1089DAD}"/>
-          </ac:spMkLst>
-        </pc:spChg>
-        <pc:spChg chg="add mod">
-          <ac:chgData name="Brayand Javier Gómez Plata" userId="c9c1396e-34a9-4a12-912a-8649ffb9a204" providerId="ADAL" clId="{27F4626A-F3D0-4E6C-A104-AEA19FA55BBA}" dt="2026-07-02T20:50:00.124" v="3784" actId="20577"/>
-          <ac:spMkLst>
-            <pc:docMk/>
-            <pc:sldMk cId="946057066" sldId="261"/>
-            <ac:spMk id="9" creationId="{97CB4FD8-B8CF-A871-FA43-3F5B6E03B5DE}"/>
-          </ac:spMkLst>
-        </pc:spChg>
-        <pc:spChg chg="del mod">
-          <ac:chgData name="Brayand Javier Gómez Plata" userId="c9c1396e-34a9-4a12-912a-8649ffb9a204" providerId="ADAL" clId="{27F4626A-F3D0-4E6C-A104-AEA19FA55BBA}" dt="2026-07-02T20:35:46.033" v="3214" actId="478"/>
-          <ac:spMkLst>
-            <pc:docMk/>
-            <pc:sldMk cId="946057066" sldId="261"/>
-            <ac:spMk id="13" creationId="{D4AC007B-EBF0-F0E1-CB27-CE03A82E6599}"/>
-          </ac:spMkLst>
-        </pc:spChg>
-        <pc:spChg chg="add mod">
-          <ac:chgData name="Brayand Javier Gómez Plata" userId="c9c1396e-34a9-4a12-912a-8649ffb9a204" providerId="ADAL" clId="{27F4626A-F3D0-4E6C-A104-AEA19FA55BBA}" dt="2026-07-02T20:50:33.245" v="3906" actId="20577"/>
-          <ac:spMkLst>
-            <pc:docMk/>
-            <pc:sldMk cId="946057066" sldId="261"/>
-            <ac:spMk id="14" creationId="{467A04AB-C04B-7C4E-09F2-E604A1FE37D8}"/>
-          </ac:spMkLst>
-        </pc:spChg>
-        <pc:spChg chg="del mod">
-          <ac:chgData name="Brayand Javier Gómez Plata" userId="c9c1396e-34a9-4a12-912a-8649ffb9a204" providerId="ADAL" clId="{27F4626A-F3D0-4E6C-A104-AEA19FA55BBA}" dt="2026-07-02T20:35:44.992" v="3213" actId="478"/>
-          <ac:spMkLst>
-            <pc:docMk/>
-            <pc:sldMk cId="946057066" sldId="261"/>
-            <ac:spMk id="15" creationId="{18C38570-FD58-A62F-1167-A522BD30BB94}"/>
-          </ac:spMkLst>
-        </pc:spChg>
-        <pc:spChg chg="add del mod">
-          <ac:chgData name="Brayand Javier Gómez Plata" userId="c9c1396e-34a9-4a12-912a-8649ffb9a204" providerId="ADAL" clId="{27F4626A-F3D0-4E6C-A104-AEA19FA55BBA}" dt="2026-07-02T20:41:34.537" v="3299" actId="478"/>
-          <ac:spMkLst>
-            <pc:docMk/>
-            <pc:sldMk cId="946057066" sldId="261"/>
-            <ac:spMk id="19" creationId="{70F32D6C-AF04-7C9D-8D2D-92F61BB821B5}"/>
-          </ac:spMkLst>
-        </pc:spChg>
-        <pc:spChg chg="add del mod">
-          <ac:chgData name="Brayand Javier Gómez Plata" userId="c9c1396e-34a9-4a12-912a-8649ffb9a204" providerId="ADAL" clId="{27F4626A-F3D0-4E6C-A104-AEA19FA55BBA}" dt="2026-07-02T20:41:38.160" v="3301" actId="478"/>
-          <ac:spMkLst>
-            <pc:docMk/>
-            <pc:sldMk cId="946057066" sldId="261"/>
-            <ac:spMk id="21" creationId="{3507D08B-879F-854E-3D69-045D63A0CCA8}"/>
-          </ac:spMkLst>
-        </pc:spChg>
-        <pc:spChg chg="add del mod">
-          <ac:chgData name="Brayand Javier Gómez Plata" userId="c9c1396e-34a9-4a12-912a-8649ffb9a204" providerId="ADAL" clId="{27F4626A-F3D0-4E6C-A104-AEA19FA55BBA}" dt="2026-07-02T20:41:39.113" v="3302" actId="478"/>
-          <ac:spMkLst>
-            <pc:docMk/>
-            <pc:sldMk cId="946057066" sldId="261"/>
-            <ac:spMk id="26" creationId="{A2A39C88-CD14-EE15-587B-2E1F430B0DEE}"/>
-          </ac:spMkLst>
-        </pc:spChg>
-        <pc:spChg chg="add del mod">
-          <ac:chgData name="Brayand Javier Gómez Plata" userId="c9c1396e-34a9-4a12-912a-8649ffb9a204" providerId="ADAL" clId="{27F4626A-F3D0-4E6C-A104-AEA19FA55BBA}" dt="2026-07-02T20:35:07.824" v="3212" actId="478"/>
-          <ac:spMkLst>
-            <pc:docMk/>
-            <pc:sldMk cId="946057066" sldId="261"/>
-            <ac:spMk id="51" creationId="{352D69EF-CBDE-13D3-FD04-09F7D7C04F44}"/>
-          </ac:spMkLst>
-        </pc:spChg>
-        <pc:spChg chg="add mod">
-          <ac:chgData name="Brayand Javier Gómez Plata" userId="c9c1396e-34a9-4a12-912a-8649ffb9a204" providerId="ADAL" clId="{27F4626A-F3D0-4E6C-A104-AEA19FA55BBA}" dt="2026-07-02T20:46:39.954" v="3635" actId="313"/>
-          <ac:spMkLst>
-            <pc:docMk/>
-            <pc:sldMk cId="946057066" sldId="261"/>
-            <ac:spMk id="320" creationId="{15F7E2EA-2D00-3F17-5839-BBC59B26A753}"/>
-          </ac:spMkLst>
-        </pc:spChg>
-        <pc:spChg chg="add mod">
-          <ac:chgData name="Brayand Javier Gómez Plata" userId="c9c1396e-34a9-4a12-912a-8649ffb9a204" providerId="ADAL" clId="{27F4626A-F3D0-4E6C-A104-AEA19FA55BBA}" dt="2026-07-02T20:46:42.720" v="3636" actId="20577"/>
-          <ac:spMkLst>
-            <pc:docMk/>
-            <pc:sldMk cId="946057066" sldId="261"/>
-            <ac:spMk id="323" creationId="{00000000-0000-0000-0000-000000000000}"/>
-          </ac:spMkLst>
-        </pc:spChg>
-        <pc:spChg chg="add mod">
-          <ac:chgData name="Brayand Javier Gómez Plata" userId="c9c1396e-34a9-4a12-912a-8649ffb9a204" providerId="ADAL" clId="{27F4626A-F3D0-4E6C-A104-AEA19FA55BBA}" dt="2026-07-02T20:44:02.316" v="3373" actId="255"/>
-          <ac:spMkLst>
-            <pc:docMk/>
-            <pc:sldMk cId="946057066" sldId="261"/>
-            <ac:spMk id="324" creationId="{4017121D-80FE-0B52-518E-4D74BF825E38}"/>
-          </ac:spMkLst>
-        </pc:spChg>
-        <pc:spChg chg="add mod">
-          <ac:chgData name="Brayand Javier Gómez Plata" userId="c9c1396e-34a9-4a12-912a-8649ffb9a204" providerId="ADAL" clId="{27F4626A-F3D0-4E6C-A104-AEA19FA55BBA}" dt="2026-07-02T20:46:38.039" v="3634" actId="1076"/>
-          <ac:spMkLst>
-            <pc:docMk/>
-            <pc:sldMk cId="946057066" sldId="261"/>
-            <ac:spMk id="327" creationId="{3A2EF9C9-F8C0-972A-91D0-F0927777CA44}"/>
-          </ac:spMkLst>
-        </pc:spChg>
-        <pc:spChg chg="add mod">
-          <ac:chgData name="Brayand Javier Gómez Plata" userId="c9c1396e-34a9-4a12-912a-8649ffb9a204" providerId="ADAL" clId="{27F4626A-F3D0-4E6C-A104-AEA19FA55BBA}" dt="2026-07-02T20:44:56.149" v="3442" actId="1076"/>
-          <ac:spMkLst>
-            <pc:docMk/>
-            <pc:sldMk cId="946057066" sldId="261"/>
-            <ac:spMk id="330" creationId="{DE3F1CC7-62F7-8785-9080-699CDDA481AD}"/>
-          </ac:spMkLst>
-        </pc:spChg>
-        <pc:spChg chg="add mod">
-          <ac:chgData name="Brayand Javier Gómez Plata" userId="c9c1396e-34a9-4a12-912a-8649ffb9a204" providerId="ADAL" clId="{27F4626A-F3D0-4E6C-A104-AEA19FA55BBA}" dt="2026-07-02T20:47:16.536" v="3638" actId="1076"/>
-          <ac:spMkLst>
-            <pc:docMk/>
-            <pc:sldMk cId="946057066" sldId="261"/>
-            <ac:spMk id="333" creationId="{00000000-0000-0000-0000-000000000000}"/>
-          </ac:spMkLst>
-        </pc:spChg>
-        <pc:spChg chg="add mod">
-          <ac:chgData name="Brayand Javier Gómez Plata" userId="c9c1396e-34a9-4a12-912a-8649ffb9a204" providerId="ADAL" clId="{27F4626A-F3D0-4E6C-A104-AEA19FA55BBA}" dt="2026-07-02T20:48:06.369" v="3705" actId="14100"/>
-          <ac:spMkLst>
-            <pc:docMk/>
-            <pc:sldMk cId="946057066" sldId="261"/>
-            <ac:spMk id="334" creationId="{E27F0C18-E053-7894-0832-D25921EC4FFC}"/>
-          </ac:spMkLst>
-        </pc:spChg>
-        <pc:spChg chg="add mod">
-          <ac:chgData name="Brayand Javier Gómez Plata" userId="c9c1396e-34a9-4a12-912a-8649ffb9a204" providerId="ADAL" clId="{27F4626A-F3D0-4E6C-A104-AEA19FA55BBA}" dt="2026-07-02T20:47:47.394" v="3655" actId="20577"/>
-          <ac:spMkLst>
-            <pc:docMk/>
-            <pc:sldMk cId="946057066" sldId="261"/>
-            <ac:spMk id="336" creationId="{EE4EF7E8-0C89-B690-F01F-EB83C27F81B5}"/>
-          </ac:spMkLst>
-        </pc:spChg>
-        <pc:spChg chg="add mod">
-          <ac:chgData name="Brayand Javier Gómez Plata" userId="c9c1396e-34a9-4a12-912a-8649ffb9a204" providerId="ADAL" clId="{27F4626A-F3D0-4E6C-A104-AEA19FA55BBA}" dt="2026-07-02T20:49:29.484" v="3741" actId="20577"/>
-          <ac:spMkLst>
-            <pc:docMk/>
-            <pc:sldMk cId="946057066" sldId="261"/>
-            <ac:spMk id="339" creationId="{2E3CEC0B-42AA-0CD3-8411-3C96D8A062A3}"/>
-          </ac:spMkLst>
-        </pc:spChg>
-        <pc:spChg chg="add mod">
-          <ac:chgData name="Brayand Javier Gómez Plata" userId="c9c1396e-34a9-4a12-912a-8649ffb9a204" providerId="ADAL" clId="{27F4626A-F3D0-4E6C-A104-AEA19FA55BBA}" dt="2026-07-02T20:49:39.364" v="3765" actId="20577"/>
-          <ac:spMkLst>
-            <pc:docMk/>
-            <pc:sldMk cId="946057066" sldId="261"/>
-            <ac:spMk id="342" creationId="{A347AFFF-4CA3-9DDD-3BE1-FC2BD09AA65B}"/>
-          </ac:spMkLst>
-        </pc:spChg>
-        <pc:picChg chg="add mod">
-          <ac:chgData name="Brayand Javier Gómez Plata" userId="c9c1396e-34a9-4a12-912a-8649ffb9a204" providerId="ADAL" clId="{27F4626A-F3D0-4E6C-A104-AEA19FA55BBA}" dt="2026-07-02T20:42:10.361" v="3309" actId="1076"/>
-          <ac:picMkLst>
-            <pc:docMk/>
-            <pc:sldMk cId="946057066" sldId="261"/>
-            <ac:picMk id="16" creationId="{E79D7A44-27E3-AD9C-6766-FCE507EC7E60}"/>
-          </ac:picMkLst>
-        </pc:picChg>
-        <pc:picChg chg="add mod">
-          <ac:chgData name="Brayand Javier Gómez Plata" userId="c9c1396e-34a9-4a12-912a-8649ffb9a204" providerId="ADAL" clId="{27F4626A-F3D0-4E6C-A104-AEA19FA55BBA}" dt="2026-07-02T20:47:08.840" v="3637" actId="1076"/>
-          <ac:picMkLst>
-            <pc:docMk/>
-            <pc:sldMk cId="946057066" sldId="261"/>
-            <ac:picMk id="18" creationId="{3C640FA1-B231-2251-AC79-97D844B83072}"/>
-          </ac:picMkLst>
-        </pc:picChg>
-        <pc:picChg chg="add mod">
-          <ac:chgData name="Brayand Javier Gómez Plata" userId="c9c1396e-34a9-4a12-912a-8649ffb9a204" providerId="ADAL" clId="{27F4626A-F3D0-4E6C-A104-AEA19FA55BBA}" dt="2026-07-02T20:36:08.040" v="3215" actId="14100"/>
-          <ac:picMkLst>
-            <pc:docMk/>
-            <pc:sldMk cId="946057066" sldId="261"/>
-            <ac:picMk id="337" creationId="{E7C64E55-D6C5-B95D-DDE1-FC4B3B70169A}"/>
-          </ac:picMkLst>
-        </pc:picChg>
       </pc:sldChg>
       <pc:sldChg chg="addSp delSp modSp add del mod">
         <pc:chgData name="Brayand Javier Gómez Plata" userId="c9c1396e-34a9-4a12-912a-8649ffb9a204" providerId="ADAL" clId="{27F4626A-F3D0-4E6C-A104-AEA19FA55BBA}" dt="2026-07-03T15:57:18.059" v="4705" actId="2696"/>
@@ -605,46 +270,6 @@
           <pc:docMk/>
           <pc:sldMk cId="3275985551" sldId="262"/>
         </pc:sldMkLst>
-        <pc:spChg chg="mod">
-          <ac:chgData name="Brayand Javier Gómez Plata" userId="c9c1396e-34a9-4a12-912a-8649ffb9a204" providerId="ADAL" clId="{27F4626A-F3D0-4E6C-A104-AEA19FA55BBA}" dt="2026-07-02T21:33:44.108" v="4643" actId="790"/>
-          <ac:spMkLst>
-            <pc:docMk/>
-            <pc:sldMk cId="3275985551" sldId="262"/>
-            <ac:spMk id="4" creationId="{D8F09C14-6ECC-3389-3926-55574CB9E04C}"/>
-          </ac:spMkLst>
-        </pc:spChg>
-        <pc:spChg chg="mod">
-          <ac:chgData name="Brayand Javier Gómez Plata" userId="c9c1396e-34a9-4a12-912a-8649ffb9a204" providerId="ADAL" clId="{27F4626A-F3D0-4E6C-A104-AEA19FA55BBA}" dt="2026-07-02T21:33:44.108" v="4643" actId="790"/>
-          <ac:spMkLst>
-            <pc:docMk/>
-            <pc:sldMk cId="3275985551" sldId="262"/>
-            <ac:spMk id="7" creationId="{DD921830-7A95-3BC4-A69D-A2DF6BB3CD2F}"/>
-          </ac:spMkLst>
-        </pc:spChg>
-        <pc:spChg chg="mod">
-          <ac:chgData name="Brayand Javier Gómez Plata" userId="c9c1396e-34a9-4a12-912a-8649ffb9a204" providerId="ADAL" clId="{27F4626A-F3D0-4E6C-A104-AEA19FA55BBA}" dt="2026-07-02T21:33:44.108" v="4643" actId="790"/>
-          <ac:spMkLst>
-            <pc:docMk/>
-            <pc:sldMk cId="3275985551" sldId="262"/>
-            <ac:spMk id="13" creationId="{A80A8012-5556-BD0D-C193-FD100C0120DB}"/>
-          </ac:spMkLst>
-        </pc:spChg>
-        <pc:spChg chg="mod">
-          <ac:chgData name="Brayand Javier Gómez Plata" userId="c9c1396e-34a9-4a12-912a-8649ffb9a204" providerId="ADAL" clId="{27F4626A-F3D0-4E6C-A104-AEA19FA55BBA}" dt="2026-07-02T21:33:44.108" v="4643" actId="790"/>
-          <ac:spMkLst>
-            <pc:docMk/>
-            <pc:sldMk cId="3275985551" sldId="262"/>
-            <ac:spMk id="15" creationId="{D63DC880-6C8B-64CC-32DE-70C6BB87210C}"/>
-          </ac:spMkLst>
-        </pc:spChg>
-        <pc:spChg chg="mod">
-          <ac:chgData name="Brayand Javier Gómez Plata" userId="c9c1396e-34a9-4a12-912a-8649ffb9a204" providerId="ADAL" clId="{27F4626A-F3D0-4E6C-A104-AEA19FA55BBA}" dt="2026-07-02T21:33:44.108" v="4643" actId="790"/>
-          <ac:spMkLst>
-            <pc:docMk/>
-            <pc:sldMk cId="3275985551" sldId="262"/>
-            <ac:spMk id="37" creationId="{2714FC74-256F-8D22-0021-8D9D7D935245}"/>
-          </ac:spMkLst>
-        </pc:spChg>
       </pc:sldChg>
       <pc:sldChg chg="addSp delSp modSp add del mod">
         <pc:chgData name="Brayand Javier Gómez Plata" userId="c9c1396e-34a9-4a12-912a-8649ffb9a204" providerId="ADAL" clId="{27F4626A-F3D0-4E6C-A104-AEA19FA55BBA}" dt="2026-07-03T15:57:12.687" v="4704" actId="2696"/>
@@ -652,30 +277,6 @@
           <pc:docMk/>
           <pc:sldMk cId="1749824020" sldId="263"/>
         </pc:sldMkLst>
-        <pc:spChg chg="mod">
-          <ac:chgData name="Brayand Javier Gómez Plata" userId="c9c1396e-34a9-4a12-912a-8649ffb9a204" providerId="ADAL" clId="{27F4626A-F3D0-4E6C-A104-AEA19FA55BBA}" dt="2026-07-02T21:33:44.108" v="4643" actId="790"/>
-          <ac:spMkLst>
-            <pc:docMk/>
-            <pc:sldMk cId="1749824020" sldId="263"/>
-            <ac:spMk id="4" creationId="{8C776193-D375-EA5F-03B1-274E380E3206}"/>
-          </ac:spMkLst>
-        </pc:spChg>
-        <pc:spChg chg="mod">
-          <ac:chgData name="Brayand Javier Gómez Plata" userId="c9c1396e-34a9-4a12-912a-8649ffb9a204" providerId="ADAL" clId="{27F4626A-F3D0-4E6C-A104-AEA19FA55BBA}" dt="2026-07-02T21:33:44.108" v="4643" actId="790"/>
-          <ac:spMkLst>
-            <pc:docMk/>
-            <pc:sldMk cId="1749824020" sldId="263"/>
-            <ac:spMk id="7" creationId="{84F6D5A0-B343-107C-34FD-D5B5FDC8FEB7}"/>
-          </ac:spMkLst>
-        </pc:spChg>
-        <pc:spChg chg="mod">
-          <ac:chgData name="Brayand Javier Gómez Plata" userId="c9c1396e-34a9-4a12-912a-8649ffb9a204" providerId="ADAL" clId="{27F4626A-F3D0-4E6C-A104-AEA19FA55BBA}" dt="2026-07-02T21:33:44.108" v="4643" actId="790"/>
-          <ac:spMkLst>
-            <pc:docMk/>
-            <pc:sldMk cId="1749824020" sldId="263"/>
-            <ac:spMk id="37" creationId="{E553B523-D26D-6404-C0AD-70B3CD92D5C6}"/>
-          </ac:spMkLst>
-        </pc:spChg>
       </pc:sldChg>
       <pc:sldChg chg="addSp delSp modSp add del mod ord">
         <pc:chgData name="Brayand Javier Gómez Plata" userId="c9c1396e-34a9-4a12-912a-8649ffb9a204" providerId="ADAL" clId="{27F4626A-F3D0-4E6C-A104-AEA19FA55BBA}" dt="2026-07-03T15:57:21.267" v="4706" actId="2696"/>
@@ -683,14 +284,6 @@
           <pc:docMk/>
           <pc:sldMk cId="1092014754" sldId="264"/>
         </pc:sldMkLst>
-        <pc:spChg chg="mod">
-          <ac:chgData name="Brayand Javier Gómez Plata" userId="c9c1396e-34a9-4a12-912a-8649ffb9a204" providerId="ADAL" clId="{27F4626A-F3D0-4E6C-A104-AEA19FA55BBA}" dt="2026-07-02T21:33:44.108" v="4643" actId="790"/>
-          <ac:spMkLst>
-            <pc:docMk/>
-            <pc:sldMk cId="1092014754" sldId="264"/>
-            <ac:spMk id="13" creationId="{583F0D3F-3794-6F25-121D-C370C61CBF22}"/>
-          </ac:spMkLst>
-        </pc:spChg>
       </pc:sldChg>
       <pc:sldChg chg="addSp delSp modSp add del mod ord">
         <pc:chgData name="Brayand Javier Gómez Plata" userId="c9c1396e-34a9-4a12-912a-8649ffb9a204" providerId="ADAL" clId="{27F4626A-F3D0-4E6C-A104-AEA19FA55BBA}" dt="2026-07-03T16:28:10.336" v="5010" actId="790"/>
@@ -785,86 +378,6 @@
           <pc:docMk/>
           <pc:sldMk cId="1952337374" sldId="266"/>
         </pc:sldMkLst>
-        <pc:spChg chg="mod">
-          <ac:chgData name="Brayand Javier Gómez Plata" userId="c9c1396e-34a9-4a12-912a-8649ffb9a204" providerId="ADAL" clId="{27F4626A-F3D0-4E6C-A104-AEA19FA55BBA}" dt="2026-07-02T21:33:44.108" v="4643" actId="790"/>
-          <ac:spMkLst>
-            <pc:docMk/>
-            <pc:sldMk cId="1952337374" sldId="266"/>
-            <ac:spMk id="3" creationId="{BD575290-4D84-5295-5E76-77704D61C08E}"/>
-          </ac:spMkLst>
-        </pc:spChg>
-        <pc:spChg chg="mod">
-          <ac:chgData name="Brayand Javier Gómez Plata" userId="c9c1396e-34a9-4a12-912a-8649ffb9a204" providerId="ADAL" clId="{27F4626A-F3D0-4E6C-A104-AEA19FA55BBA}" dt="2026-07-02T21:33:44.108" v="4643" actId="790"/>
-          <ac:spMkLst>
-            <pc:docMk/>
-            <pc:sldMk cId="1952337374" sldId="266"/>
-            <ac:spMk id="4" creationId="{C7960CA5-9763-3939-6EB2-FB73475B96FF}"/>
-          </ac:spMkLst>
-        </pc:spChg>
-        <pc:spChg chg="mod">
-          <ac:chgData name="Brayand Javier Gómez Plata" userId="c9c1396e-34a9-4a12-912a-8649ffb9a204" providerId="ADAL" clId="{27F4626A-F3D0-4E6C-A104-AEA19FA55BBA}" dt="2026-07-02T21:33:44.108" v="4643" actId="790"/>
-          <ac:spMkLst>
-            <pc:docMk/>
-            <pc:sldMk cId="1952337374" sldId="266"/>
-            <ac:spMk id="5" creationId="{3F5C655B-96AC-F1B9-BF27-EF0F5B34615B}"/>
-          </ac:spMkLst>
-        </pc:spChg>
-        <pc:spChg chg="mod">
-          <ac:chgData name="Brayand Javier Gómez Plata" userId="c9c1396e-34a9-4a12-912a-8649ffb9a204" providerId="ADAL" clId="{27F4626A-F3D0-4E6C-A104-AEA19FA55BBA}" dt="2026-07-02T21:33:44.108" v="4643" actId="790"/>
-          <ac:spMkLst>
-            <pc:docMk/>
-            <pc:sldMk cId="1952337374" sldId="266"/>
-            <ac:spMk id="7" creationId="{D652979A-6569-74FE-4042-360CA2682D5E}"/>
-          </ac:spMkLst>
-        </pc:spChg>
-        <pc:spChg chg="mod">
-          <ac:chgData name="Brayand Javier Gómez Plata" userId="c9c1396e-34a9-4a12-912a-8649ffb9a204" providerId="ADAL" clId="{27F4626A-F3D0-4E6C-A104-AEA19FA55BBA}" dt="2026-07-02T21:33:44.108" v="4643" actId="790"/>
-          <ac:spMkLst>
-            <pc:docMk/>
-            <pc:sldMk cId="1952337374" sldId="266"/>
-            <ac:spMk id="12" creationId="{5FF00875-A942-7F12-B1BB-780AA7763299}"/>
-          </ac:spMkLst>
-        </pc:spChg>
-        <pc:spChg chg="mod">
-          <ac:chgData name="Brayand Javier Gómez Plata" userId="c9c1396e-34a9-4a12-912a-8649ffb9a204" providerId="ADAL" clId="{27F4626A-F3D0-4E6C-A104-AEA19FA55BBA}" dt="2026-07-02T21:33:44.108" v="4643" actId="790"/>
-          <ac:spMkLst>
-            <pc:docMk/>
-            <pc:sldMk cId="1952337374" sldId="266"/>
-            <ac:spMk id="13" creationId="{4DB3DA04-6AD4-61D0-8CB6-F860EF0FF9D3}"/>
-          </ac:spMkLst>
-        </pc:spChg>
-        <pc:spChg chg="mod">
-          <ac:chgData name="Brayand Javier Gómez Plata" userId="c9c1396e-34a9-4a12-912a-8649ffb9a204" providerId="ADAL" clId="{27F4626A-F3D0-4E6C-A104-AEA19FA55BBA}" dt="2026-07-02T21:33:44.108" v="4643" actId="790"/>
-          <ac:spMkLst>
-            <pc:docMk/>
-            <pc:sldMk cId="1952337374" sldId="266"/>
-            <ac:spMk id="14" creationId="{545C2CE2-5DA7-3F8E-D4C3-13779E247E72}"/>
-          </ac:spMkLst>
-        </pc:spChg>
-        <pc:spChg chg="mod">
-          <ac:chgData name="Brayand Javier Gómez Plata" userId="c9c1396e-34a9-4a12-912a-8649ffb9a204" providerId="ADAL" clId="{27F4626A-F3D0-4E6C-A104-AEA19FA55BBA}" dt="2026-07-02T21:33:44.108" v="4643" actId="790"/>
-          <ac:spMkLst>
-            <pc:docMk/>
-            <pc:sldMk cId="1952337374" sldId="266"/>
-            <ac:spMk id="15" creationId="{022C083E-28D2-9EBA-5AFC-D28123001064}"/>
-          </ac:spMkLst>
-        </pc:spChg>
-        <pc:spChg chg="mod">
-          <ac:chgData name="Brayand Javier Gómez Plata" userId="c9c1396e-34a9-4a12-912a-8649ffb9a204" providerId="ADAL" clId="{27F4626A-F3D0-4E6C-A104-AEA19FA55BBA}" dt="2026-07-02T21:33:44.108" v="4643" actId="790"/>
-          <ac:spMkLst>
-            <pc:docMk/>
-            <pc:sldMk cId="1952337374" sldId="266"/>
-            <ac:spMk id="22" creationId="{ACC2B473-BF69-92F3-3147-093C88698CE9}"/>
-          </ac:spMkLst>
-        </pc:spChg>
-        <pc:spChg chg="mod">
-          <ac:chgData name="Brayand Javier Gómez Plata" userId="c9c1396e-34a9-4a12-912a-8649ffb9a204" providerId="ADAL" clId="{27F4626A-F3D0-4E6C-A104-AEA19FA55BBA}" dt="2026-07-02T21:33:44.108" v="4643" actId="790"/>
-          <ac:spMkLst>
-            <pc:docMk/>
-            <pc:sldMk cId="1952337374" sldId="266"/>
-            <ac:spMk id="51" creationId="{FBBC45DA-4926-C065-7CC5-2717E599A99A}"/>
-          </ac:spMkLst>
-        </pc:spChg>
       </pc:sldChg>
       <pc:sldChg chg="addSp delSp modSp add del mod ord">
         <pc:chgData name="Brayand Javier Gómez Plata" userId="c9c1396e-34a9-4a12-912a-8649ffb9a204" providerId="ADAL" clId="{27F4626A-F3D0-4E6C-A104-AEA19FA55BBA}" dt="2026-07-03T16:06:46.483" v="4721" actId="47"/>
@@ -872,86 +385,6 @@
           <pc:docMk/>
           <pc:sldMk cId="1936048205" sldId="267"/>
         </pc:sldMkLst>
-        <pc:spChg chg="mod">
-          <ac:chgData name="Brayand Javier Gómez Plata" userId="c9c1396e-34a9-4a12-912a-8649ffb9a204" providerId="ADAL" clId="{27F4626A-F3D0-4E6C-A104-AEA19FA55BBA}" dt="2026-07-02T21:33:44.108" v="4643" actId="790"/>
-          <ac:spMkLst>
-            <pc:docMk/>
-            <pc:sldMk cId="1936048205" sldId="267"/>
-            <ac:spMk id="4" creationId="{F30A04A3-BE72-5639-D155-520D361090FA}"/>
-          </ac:spMkLst>
-        </pc:spChg>
-        <pc:spChg chg="mod">
-          <ac:chgData name="Brayand Javier Gómez Plata" userId="c9c1396e-34a9-4a12-912a-8649ffb9a204" providerId="ADAL" clId="{27F4626A-F3D0-4E6C-A104-AEA19FA55BBA}" dt="2026-07-02T21:33:44.108" v="4643" actId="790"/>
-          <ac:spMkLst>
-            <pc:docMk/>
-            <pc:sldMk cId="1936048205" sldId="267"/>
-            <ac:spMk id="7" creationId="{2A77180B-F674-FF80-7555-77B799B8B9C7}"/>
-          </ac:spMkLst>
-        </pc:spChg>
-        <pc:spChg chg="add mod">
-          <ac:chgData name="Brayand Javier Gómez Plata" userId="c9c1396e-34a9-4a12-912a-8649ffb9a204" providerId="ADAL" clId="{27F4626A-F3D0-4E6C-A104-AEA19FA55BBA}" dt="2026-07-02T21:33:44.108" v="4643" actId="790"/>
-          <ac:spMkLst>
-            <pc:docMk/>
-            <pc:sldMk cId="1936048205" sldId="267"/>
-            <ac:spMk id="14" creationId="{6BF7C366-7E83-E0DF-9A1C-B51ED8D454BD}"/>
-          </ac:spMkLst>
-        </pc:spChg>
-        <pc:spChg chg="add mod">
-          <ac:chgData name="Brayand Javier Gómez Plata" userId="c9c1396e-34a9-4a12-912a-8649ffb9a204" providerId="ADAL" clId="{27F4626A-F3D0-4E6C-A104-AEA19FA55BBA}" dt="2026-07-02T21:33:44.108" v="4643" actId="790"/>
-          <ac:spMkLst>
-            <pc:docMk/>
-            <pc:sldMk cId="1936048205" sldId="267"/>
-            <ac:spMk id="17" creationId="{E29D75B1-E63C-8DBF-02C4-AD6F43F52A16}"/>
-          </ac:spMkLst>
-        </pc:spChg>
-        <pc:spChg chg="add mod">
-          <ac:chgData name="Brayand Javier Gómez Plata" userId="c9c1396e-34a9-4a12-912a-8649ffb9a204" providerId="ADAL" clId="{27F4626A-F3D0-4E6C-A104-AEA19FA55BBA}" dt="2026-07-02T21:33:44.108" v="4643" actId="790"/>
-          <ac:spMkLst>
-            <pc:docMk/>
-            <pc:sldMk cId="1936048205" sldId="267"/>
-            <ac:spMk id="20" creationId="{A5AC65FA-0F18-8247-DBB5-9DD133C81331}"/>
-          </ac:spMkLst>
-        </pc:spChg>
-        <pc:spChg chg="add del mod">
-          <ac:chgData name="Brayand Javier Gómez Plata" userId="c9c1396e-34a9-4a12-912a-8649ffb9a204" providerId="ADAL" clId="{27F4626A-F3D0-4E6C-A104-AEA19FA55BBA}" dt="2026-07-02T21:33:44.108" v="4643" actId="790"/>
-          <ac:spMkLst>
-            <pc:docMk/>
-            <pc:sldMk cId="1936048205" sldId="267"/>
-            <ac:spMk id="22" creationId="{77676393-FDF7-C0C9-A9B7-815EE2DD2AB5}"/>
-          </ac:spMkLst>
-        </pc:spChg>
-        <pc:spChg chg="add mod">
-          <ac:chgData name="Brayand Javier Gómez Plata" userId="c9c1396e-34a9-4a12-912a-8649ffb9a204" providerId="ADAL" clId="{27F4626A-F3D0-4E6C-A104-AEA19FA55BBA}" dt="2026-07-02T21:33:44.108" v="4643" actId="790"/>
-          <ac:spMkLst>
-            <pc:docMk/>
-            <pc:sldMk cId="1936048205" sldId="267"/>
-            <ac:spMk id="24" creationId="{75C6084E-1FB7-C647-A949-0DBCC6E48F56}"/>
-          </ac:spMkLst>
-        </pc:spChg>
-        <pc:spChg chg="add mod">
-          <ac:chgData name="Brayand Javier Gómez Plata" userId="c9c1396e-34a9-4a12-912a-8649ffb9a204" providerId="ADAL" clId="{27F4626A-F3D0-4E6C-A104-AEA19FA55BBA}" dt="2026-07-02T21:33:44.108" v="4643" actId="790"/>
-          <ac:spMkLst>
-            <pc:docMk/>
-            <pc:sldMk cId="1936048205" sldId="267"/>
-            <ac:spMk id="26" creationId="{90FB16BC-B1A1-89C5-88B1-81218AA50697}"/>
-          </ac:spMkLst>
-        </pc:spChg>
-        <pc:spChg chg="add mod">
-          <ac:chgData name="Brayand Javier Gómez Plata" userId="c9c1396e-34a9-4a12-912a-8649ffb9a204" providerId="ADAL" clId="{27F4626A-F3D0-4E6C-A104-AEA19FA55BBA}" dt="2026-07-02T21:33:44.108" v="4643" actId="790"/>
-          <ac:spMkLst>
-            <pc:docMk/>
-            <pc:sldMk cId="1936048205" sldId="267"/>
-            <ac:spMk id="32" creationId="{790335D7-197F-5A0E-38D2-4F2A4E4E8902}"/>
-          </ac:spMkLst>
-        </pc:spChg>
-        <pc:spChg chg="add mod">
-          <ac:chgData name="Brayand Javier Gómez Plata" userId="c9c1396e-34a9-4a12-912a-8649ffb9a204" providerId="ADAL" clId="{27F4626A-F3D0-4E6C-A104-AEA19FA55BBA}" dt="2026-07-02T21:33:44.108" v="4643" actId="790"/>
-          <ac:spMkLst>
-            <pc:docMk/>
-            <pc:sldMk cId="1936048205" sldId="267"/>
-            <ac:spMk id="34" creationId="{67AE9410-343A-A0F8-38B4-9ACC60690D89}"/>
-          </ac:spMkLst>
-        </pc:spChg>
       </pc:sldChg>
       <pc:sldChg chg="addSp delSp modSp add del mod">
         <pc:chgData name="Brayand Javier Gómez Plata" userId="c9c1396e-34a9-4a12-912a-8649ffb9a204" providerId="ADAL" clId="{27F4626A-F3D0-4E6C-A104-AEA19FA55BBA}" dt="2026-07-03T16:06:44" v="4720" actId="2696"/>
@@ -959,46 +392,6 @@
           <pc:docMk/>
           <pc:sldMk cId="1836713519" sldId="268"/>
         </pc:sldMkLst>
-        <pc:spChg chg="mod">
-          <ac:chgData name="Brayand Javier Gómez Plata" userId="c9c1396e-34a9-4a12-912a-8649ffb9a204" providerId="ADAL" clId="{27F4626A-F3D0-4E6C-A104-AEA19FA55BBA}" dt="2026-07-02T21:33:44.108" v="4643" actId="790"/>
-          <ac:spMkLst>
-            <pc:docMk/>
-            <pc:sldMk cId="1836713519" sldId="268"/>
-            <ac:spMk id="4" creationId="{BF043A64-1677-BBC3-2BE4-561662CDD4A4}"/>
-          </ac:spMkLst>
-        </pc:spChg>
-        <pc:spChg chg="mod">
-          <ac:chgData name="Brayand Javier Gómez Plata" userId="c9c1396e-34a9-4a12-912a-8649ffb9a204" providerId="ADAL" clId="{27F4626A-F3D0-4E6C-A104-AEA19FA55BBA}" dt="2026-07-02T21:33:44.108" v="4643" actId="790"/>
-          <ac:spMkLst>
-            <pc:docMk/>
-            <pc:sldMk cId="1836713519" sldId="268"/>
-            <ac:spMk id="7" creationId="{638CA9CA-EF9A-BB31-DA3E-F50B8C29B3C5}"/>
-          </ac:spMkLst>
-        </pc:spChg>
-        <pc:spChg chg="mod">
-          <ac:chgData name="Brayand Javier Gómez Plata" userId="c9c1396e-34a9-4a12-912a-8649ffb9a204" providerId="ADAL" clId="{27F4626A-F3D0-4E6C-A104-AEA19FA55BBA}" dt="2026-07-02T21:33:44.108" v="4643" actId="790"/>
-          <ac:spMkLst>
-            <pc:docMk/>
-            <pc:sldMk cId="1836713519" sldId="268"/>
-            <ac:spMk id="13" creationId="{C622838B-AA53-99C2-F890-584585AEBC8D}"/>
-          </ac:spMkLst>
-        </pc:spChg>
-        <pc:spChg chg="mod">
-          <ac:chgData name="Brayand Javier Gómez Plata" userId="c9c1396e-34a9-4a12-912a-8649ffb9a204" providerId="ADAL" clId="{27F4626A-F3D0-4E6C-A104-AEA19FA55BBA}" dt="2026-07-02T21:33:44.108" v="4643" actId="790"/>
-          <ac:spMkLst>
-            <pc:docMk/>
-            <pc:sldMk cId="1836713519" sldId="268"/>
-            <ac:spMk id="15" creationId="{8116B71A-9C1D-5C57-F249-F67672614EB0}"/>
-          </ac:spMkLst>
-        </pc:spChg>
-        <pc:spChg chg="mod">
-          <ac:chgData name="Brayand Javier Gómez Plata" userId="c9c1396e-34a9-4a12-912a-8649ffb9a204" providerId="ADAL" clId="{27F4626A-F3D0-4E6C-A104-AEA19FA55BBA}" dt="2026-07-02T21:33:44.108" v="4643" actId="790"/>
-          <ac:spMkLst>
-            <pc:docMk/>
-            <pc:sldMk cId="1836713519" sldId="268"/>
-            <ac:spMk id="51" creationId="{0025E714-95AF-8442-6C6D-7F32F4733A72}"/>
-          </ac:spMkLst>
-        </pc:spChg>
       </pc:sldChg>
       <pc:sldChg chg="addSp delSp modSp add del mod">
         <pc:chgData name="Brayand Javier Gómez Plata" userId="c9c1396e-34a9-4a12-912a-8649ffb9a204" providerId="ADAL" clId="{27F4626A-F3D0-4E6C-A104-AEA19FA55BBA}" dt="2026-07-03T16:06:51.552" v="4724" actId="47"/>
@@ -1006,70 +399,6 @@
           <pc:docMk/>
           <pc:sldMk cId="1981738347" sldId="269"/>
         </pc:sldMkLst>
-        <pc:spChg chg="add mod">
-          <ac:chgData name="Brayand Javier Gómez Plata" userId="c9c1396e-34a9-4a12-912a-8649ffb9a204" providerId="ADAL" clId="{27F4626A-F3D0-4E6C-A104-AEA19FA55BBA}" dt="2026-07-02T21:33:44.108" v="4643" actId="790"/>
-          <ac:spMkLst>
-            <pc:docMk/>
-            <pc:sldMk cId="1981738347" sldId="269"/>
-            <ac:spMk id="3" creationId="{8F5CD7BD-54AF-0ED1-10B1-626B082B6550}"/>
-          </ac:spMkLst>
-        </pc:spChg>
-        <pc:spChg chg="mod">
-          <ac:chgData name="Brayand Javier Gómez Plata" userId="c9c1396e-34a9-4a12-912a-8649ffb9a204" providerId="ADAL" clId="{27F4626A-F3D0-4E6C-A104-AEA19FA55BBA}" dt="2026-07-02T21:33:44.108" v="4643" actId="790"/>
-          <ac:spMkLst>
-            <pc:docMk/>
-            <pc:sldMk cId="1981738347" sldId="269"/>
-            <ac:spMk id="4" creationId="{0C1CD632-DF7E-3B5A-3AEE-F612C569D8CB}"/>
-          </ac:spMkLst>
-        </pc:spChg>
-        <pc:spChg chg="add mod">
-          <ac:chgData name="Brayand Javier Gómez Plata" userId="c9c1396e-34a9-4a12-912a-8649ffb9a204" providerId="ADAL" clId="{27F4626A-F3D0-4E6C-A104-AEA19FA55BBA}" dt="2026-07-02T21:33:44.108" v="4643" actId="790"/>
-          <ac:spMkLst>
-            <pc:docMk/>
-            <pc:sldMk cId="1981738347" sldId="269"/>
-            <ac:spMk id="6" creationId="{CEF93A4C-9EAF-06A2-3C0F-6B65CDAB0FBC}"/>
-          </ac:spMkLst>
-        </pc:spChg>
-        <pc:spChg chg="mod">
-          <ac:chgData name="Brayand Javier Gómez Plata" userId="c9c1396e-34a9-4a12-912a-8649ffb9a204" providerId="ADAL" clId="{27F4626A-F3D0-4E6C-A104-AEA19FA55BBA}" dt="2026-07-02T21:33:44.108" v="4643" actId="790"/>
-          <ac:spMkLst>
-            <pc:docMk/>
-            <pc:sldMk cId="1981738347" sldId="269"/>
-            <ac:spMk id="7" creationId="{A1E8F56B-20A4-1ADF-154D-CC596905F6DF}"/>
-          </ac:spMkLst>
-        </pc:spChg>
-        <pc:spChg chg="add mod">
-          <ac:chgData name="Brayand Javier Gómez Plata" userId="c9c1396e-34a9-4a12-912a-8649ffb9a204" providerId="ADAL" clId="{27F4626A-F3D0-4E6C-A104-AEA19FA55BBA}" dt="2026-07-02T21:33:44.108" v="4643" actId="790"/>
-          <ac:spMkLst>
-            <pc:docMk/>
-            <pc:sldMk cId="1981738347" sldId="269"/>
-            <ac:spMk id="10" creationId="{2A4DDB2F-1A2C-4F17-E60D-733D00F27E36}"/>
-          </ac:spMkLst>
-        </pc:spChg>
-        <pc:spChg chg="mod">
-          <ac:chgData name="Brayand Javier Gómez Plata" userId="c9c1396e-34a9-4a12-912a-8649ffb9a204" providerId="ADAL" clId="{27F4626A-F3D0-4E6C-A104-AEA19FA55BBA}" dt="2026-07-02T21:33:44.108" v="4643" actId="790"/>
-          <ac:spMkLst>
-            <pc:docMk/>
-            <pc:sldMk cId="1981738347" sldId="269"/>
-            <ac:spMk id="13" creationId="{07C8747C-0A9F-D314-213A-4CF77BD5DF05}"/>
-          </ac:spMkLst>
-        </pc:spChg>
-        <pc:spChg chg="mod">
-          <ac:chgData name="Brayand Javier Gómez Plata" userId="c9c1396e-34a9-4a12-912a-8649ffb9a204" providerId="ADAL" clId="{27F4626A-F3D0-4E6C-A104-AEA19FA55BBA}" dt="2026-07-02T21:33:44.108" v="4643" actId="790"/>
-          <ac:spMkLst>
-            <pc:docMk/>
-            <pc:sldMk cId="1981738347" sldId="269"/>
-            <ac:spMk id="15" creationId="{598B7DFB-63DE-7943-FEF3-605A8131816E}"/>
-          </ac:spMkLst>
-        </pc:spChg>
-        <pc:spChg chg="mod">
-          <ac:chgData name="Brayand Javier Gómez Plata" userId="c9c1396e-34a9-4a12-912a-8649ffb9a204" providerId="ADAL" clId="{27F4626A-F3D0-4E6C-A104-AEA19FA55BBA}" dt="2026-07-02T21:33:44.108" v="4643" actId="790"/>
-          <ac:spMkLst>
-            <pc:docMk/>
-            <pc:sldMk cId="1981738347" sldId="269"/>
-            <ac:spMk id="51" creationId="{CD3CF8F3-3E25-7E9A-F9F9-2EBB08E8B35F}"/>
-          </ac:spMkLst>
-        </pc:spChg>
       </pc:sldChg>
       <pc:sldChg chg="addSp delSp modSp add del mod ord">
         <pc:chgData name="Brayand Javier Gómez Plata" userId="c9c1396e-34a9-4a12-912a-8649ffb9a204" providerId="ADAL" clId="{27F4626A-F3D0-4E6C-A104-AEA19FA55BBA}" dt="2026-07-03T16:06:50.459" v="4723" actId="47"/>
@@ -1077,86 +406,6 @@
           <pc:docMk/>
           <pc:sldMk cId="3788628433" sldId="270"/>
         </pc:sldMkLst>
-        <pc:spChg chg="mod">
-          <ac:chgData name="Brayand Javier Gómez Plata" userId="c9c1396e-34a9-4a12-912a-8649ffb9a204" providerId="ADAL" clId="{27F4626A-F3D0-4E6C-A104-AEA19FA55BBA}" dt="2026-07-02T21:33:44.108" v="4643" actId="790"/>
-          <ac:spMkLst>
-            <pc:docMk/>
-            <pc:sldMk cId="3788628433" sldId="270"/>
-            <ac:spMk id="7" creationId="{EB510F10-9446-BB1E-6210-3F5BC25E38B2}"/>
-          </ac:spMkLst>
-        </pc:spChg>
-        <pc:spChg chg="add mod">
-          <ac:chgData name="Brayand Javier Gómez Plata" userId="c9c1396e-34a9-4a12-912a-8649ffb9a204" providerId="ADAL" clId="{27F4626A-F3D0-4E6C-A104-AEA19FA55BBA}" dt="2026-07-02T21:33:44.108" v="4643" actId="790"/>
-          <ac:spMkLst>
-            <pc:docMk/>
-            <pc:sldMk cId="3788628433" sldId="270"/>
-            <ac:spMk id="17" creationId="{6D63994B-6A2D-BE59-4D4E-A814B2F8AE5B}"/>
-          </ac:spMkLst>
-        </pc:spChg>
-        <pc:spChg chg="mod">
-          <ac:chgData name="Brayand Javier Gómez Plata" userId="c9c1396e-34a9-4a12-912a-8649ffb9a204" providerId="ADAL" clId="{27F4626A-F3D0-4E6C-A104-AEA19FA55BBA}" dt="2026-07-02T21:33:44.108" v="4643" actId="790"/>
-          <ac:spMkLst>
-            <pc:docMk/>
-            <pc:sldMk cId="3788628433" sldId="270"/>
-            <ac:spMk id="21" creationId="{B240B673-1855-2A34-A234-E10FDDFD396C}"/>
-          </ac:spMkLst>
-        </pc:spChg>
-        <pc:spChg chg="mod">
-          <ac:chgData name="Brayand Javier Gómez Plata" userId="c9c1396e-34a9-4a12-912a-8649ffb9a204" providerId="ADAL" clId="{27F4626A-F3D0-4E6C-A104-AEA19FA55BBA}" dt="2026-07-02T21:33:44.108" v="4643" actId="790"/>
-          <ac:spMkLst>
-            <pc:docMk/>
-            <pc:sldMk cId="3788628433" sldId="270"/>
-            <ac:spMk id="33" creationId="{68483B0D-BAC5-278D-ABFD-0B1FD6E4B46A}"/>
-          </ac:spMkLst>
-        </pc:spChg>
-        <pc:spChg chg="mod">
-          <ac:chgData name="Brayand Javier Gómez Plata" userId="c9c1396e-34a9-4a12-912a-8649ffb9a204" providerId="ADAL" clId="{27F4626A-F3D0-4E6C-A104-AEA19FA55BBA}" dt="2026-07-02T21:33:44.108" v="4643" actId="790"/>
-          <ac:spMkLst>
-            <pc:docMk/>
-            <pc:sldMk cId="3788628433" sldId="270"/>
-            <ac:spMk id="35" creationId="{4DA3935D-AC96-E3C5-CD98-A741ECCEB975}"/>
-          </ac:spMkLst>
-        </pc:spChg>
-        <pc:spChg chg="mod">
-          <ac:chgData name="Brayand Javier Gómez Plata" userId="c9c1396e-34a9-4a12-912a-8649ffb9a204" providerId="ADAL" clId="{27F4626A-F3D0-4E6C-A104-AEA19FA55BBA}" dt="2026-07-02T21:33:44.108" v="4643" actId="790"/>
-          <ac:spMkLst>
-            <pc:docMk/>
-            <pc:sldMk cId="3788628433" sldId="270"/>
-            <ac:spMk id="41" creationId="{AC2D0A0A-641D-A396-35DD-E82600FA2DC6}"/>
-          </ac:spMkLst>
-        </pc:spChg>
-        <pc:spChg chg="mod">
-          <ac:chgData name="Brayand Javier Gómez Plata" userId="c9c1396e-34a9-4a12-912a-8649ffb9a204" providerId="ADAL" clId="{27F4626A-F3D0-4E6C-A104-AEA19FA55BBA}" dt="2026-07-02T21:33:44.108" v="4643" actId="790"/>
-          <ac:spMkLst>
-            <pc:docMk/>
-            <pc:sldMk cId="3788628433" sldId="270"/>
-            <ac:spMk id="52" creationId="{2FD5804A-6F33-AF1E-A8E5-27B4A2B99F89}"/>
-          </ac:spMkLst>
-        </pc:spChg>
-        <pc:spChg chg="add mod">
-          <ac:chgData name="Brayand Javier Gómez Plata" userId="c9c1396e-34a9-4a12-912a-8649ffb9a204" providerId="ADAL" clId="{27F4626A-F3D0-4E6C-A104-AEA19FA55BBA}" dt="2026-07-02T21:33:44.108" v="4643" actId="790"/>
-          <ac:spMkLst>
-            <pc:docMk/>
-            <pc:sldMk cId="3788628433" sldId="270"/>
-            <ac:spMk id="54" creationId="{6E615205-7567-F8E6-B2F7-E57C2AD94DC8}"/>
-          </ac:spMkLst>
-        </pc:spChg>
-        <pc:spChg chg="add mod">
-          <ac:chgData name="Brayand Javier Gómez Plata" userId="c9c1396e-34a9-4a12-912a-8649ffb9a204" providerId="ADAL" clId="{27F4626A-F3D0-4E6C-A104-AEA19FA55BBA}" dt="2026-07-02T21:33:44.108" v="4643" actId="790"/>
-          <ac:spMkLst>
-            <pc:docMk/>
-            <pc:sldMk cId="3788628433" sldId="270"/>
-            <ac:spMk id="58" creationId="{95258273-6EC8-A898-6079-64C9855CA783}"/>
-          </ac:spMkLst>
-        </pc:spChg>
-        <pc:spChg chg="add mod">
-          <ac:chgData name="Brayand Javier Gómez Plata" userId="c9c1396e-34a9-4a12-912a-8649ffb9a204" providerId="ADAL" clId="{27F4626A-F3D0-4E6C-A104-AEA19FA55BBA}" dt="2026-07-02T21:33:44.108" v="4643" actId="790"/>
-          <ac:spMkLst>
-            <pc:docMk/>
-            <pc:sldMk cId="3788628433" sldId="270"/>
-            <ac:spMk id="66" creationId="{6C742B5C-8E81-8425-B74D-58DAC7827C41}"/>
-          </ac:spMkLst>
-        </pc:spChg>
       </pc:sldChg>
       <pc:sldChg chg="addSp delSp modSp add del mod ord">
         <pc:chgData name="Brayand Javier Gómez Plata" userId="c9c1396e-34a9-4a12-912a-8649ffb9a204" providerId="ADAL" clId="{27F4626A-F3D0-4E6C-A104-AEA19FA55BBA}" dt="2026-07-03T16:06:48.393" v="4722" actId="47"/>
@@ -1164,38 +413,6 @@
           <pc:docMk/>
           <pc:sldMk cId="1513769012" sldId="272"/>
         </pc:sldMkLst>
-        <pc:spChg chg="add mod">
-          <ac:chgData name="Brayand Javier Gómez Plata" userId="c9c1396e-34a9-4a12-912a-8649ffb9a204" providerId="ADAL" clId="{27F4626A-F3D0-4E6C-A104-AEA19FA55BBA}" dt="2026-07-02T21:33:44.108" v="4643" actId="790"/>
-          <ac:spMkLst>
-            <pc:docMk/>
-            <pc:sldMk cId="1513769012" sldId="272"/>
-            <ac:spMk id="3" creationId="{445DDE38-0632-95CC-C24D-30199231C150}"/>
-          </ac:spMkLst>
-        </pc:spChg>
-        <pc:spChg chg="mod">
-          <ac:chgData name="Brayand Javier Gómez Plata" userId="c9c1396e-34a9-4a12-912a-8649ffb9a204" providerId="ADAL" clId="{27F4626A-F3D0-4E6C-A104-AEA19FA55BBA}" dt="2026-07-02T21:33:44.108" v="4643" actId="790"/>
-          <ac:spMkLst>
-            <pc:docMk/>
-            <pc:sldMk cId="1513769012" sldId="272"/>
-            <ac:spMk id="4" creationId="{720811E5-D502-A833-3D1F-2F873381B7D6}"/>
-          </ac:spMkLst>
-        </pc:spChg>
-        <pc:spChg chg="mod">
-          <ac:chgData name="Brayand Javier Gómez Plata" userId="c9c1396e-34a9-4a12-912a-8649ffb9a204" providerId="ADAL" clId="{27F4626A-F3D0-4E6C-A104-AEA19FA55BBA}" dt="2026-07-02T21:33:44.108" v="4643" actId="790"/>
-          <ac:spMkLst>
-            <pc:docMk/>
-            <pc:sldMk cId="1513769012" sldId="272"/>
-            <ac:spMk id="7" creationId="{26D3F928-0724-AC0E-E52F-208ADD9EA70D}"/>
-          </ac:spMkLst>
-        </pc:spChg>
-        <pc:spChg chg="mod">
-          <ac:chgData name="Brayand Javier Gómez Plata" userId="c9c1396e-34a9-4a12-912a-8649ffb9a204" providerId="ADAL" clId="{27F4626A-F3D0-4E6C-A104-AEA19FA55BBA}" dt="2026-07-02T21:33:44.108" v="4643" actId="790"/>
-          <ac:spMkLst>
-            <pc:docMk/>
-            <pc:sldMk cId="1513769012" sldId="272"/>
-            <ac:spMk id="37" creationId="{C84E9B0E-3059-FC32-4029-050875B06516}"/>
-          </ac:spMkLst>
-        </pc:spChg>
       </pc:sldChg>
       <pc:sldChg chg="addSp delSp modSp add del mod setBg">
         <pc:chgData name="Brayand Javier Gómez Plata" userId="c9c1396e-34a9-4a12-912a-8649ffb9a204" providerId="ADAL" clId="{27F4626A-F3D0-4E6C-A104-AEA19FA55BBA}" dt="2026-07-03T16:18:21.398" v="4880" actId="2696"/>
@@ -1225,62 +442,6 @@
             <pc:docMk/>
             <pc:sldMk cId="0" sldId="274"/>
             <ac:spMk id="6" creationId="{00000000-0000-0000-0000-000000000000}"/>
-          </ac:spMkLst>
-        </pc:spChg>
-        <pc:spChg chg="mod">
-          <ac:chgData name="Brayand Javier Gómez Plata" userId="c9c1396e-34a9-4a12-912a-8649ffb9a204" providerId="ADAL" clId="{27F4626A-F3D0-4E6C-A104-AEA19FA55BBA}" dt="2026-07-02T21:33:44.108" v="4643" actId="790"/>
-          <ac:spMkLst>
-            <pc:docMk/>
-            <pc:sldMk cId="0" sldId="274"/>
-            <ac:spMk id="9" creationId="{00000000-0000-0000-0000-000000000000}"/>
-          </ac:spMkLst>
-        </pc:spChg>
-        <pc:spChg chg="mod">
-          <ac:chgData name="Brayand Javier Gómez Plata" userId="c9c1396e-34a9-4a12-912a-8649ffb9a204" providerId="ADAL" clId="{27F4626A-F3D0-4E6C-A104-AEA19FA55BBA}" dt="2026-07-02T21:33:44.108" v="4643" actId="790"/>
-          <ac:spMkLst>
-            <pc:docMk/>
-            <pc:sldMk cId="0" sldId="274"/>
-            <ac:spMk id="11" creationId="{00000000-0000-0000-0000-000000000000}"/>
-          </ac:spMkLst>
-        </pc:spChg>
-        <pc:spChg chg="mod">
-          <ac:chgData name="Brayand Javier Gómez Plata" userId="c9c1396e-34a9-4a12-912a-8649ffb9a204" providerId="ADAL" clId="{27F4626A-F3D0-4E6C-A104-AEA19FA55BBA}" dt="2026-07-02T21:33:44.108" v="4643" actId="790"/>
-          <ac:spMkLst>
-            <pc:docMk/>
-            <pc:sldMk cId="0" sldId="274"/>
-            <ac:spMk id="12" creationId="{00000000-0000-0000-0000-000000000000}"/>
-          </ac:spMkLst>
-        </pc:spChg>
-        <pc:spChg chg="mod">
-          <ac:chgData name="Brayand Javier Gómez Plata" userId="c9c1396e-34a9-4a12-912a-8649ffb9a204" providerId="ADAL" clId="{27F4626A-F3D0-4E6C-A104-AEA19FA55BBA}" dt="2026-07-02T21:33:44.108" v="4643" actId="790"/>
-          <ac:spMkLst>
-            <pc:docMk/>
-            <pc:sldMk cId="0" sldId="274"/>
-            <ac:spMk id="13" creationId="{00000000-0000-0000-0000-000000000000}"/>
-          </ac:spMkLst>
-        </pc:spChg>
-        <pc:spChg chg="mod">
-          <ac:chgData name="Brayand Javier Gómez Plata" userId="c9c1396e-34a9-4a12-912a-8649ffb9a204" providerId="ADAL" clId="{27F4626A-F3D0-4E6C-A104-AEA19FA55BBA}" dt="2026-07-02T21:33:44.108" v="4643" actId="790"/>
-          <ac:spMkLst>
-            <pc:docMk/>
-            <pc:sldMk cId="0" sldId="274"/>
-            <ac:spMk id="14" creationId="{00000000-0000-0000-0000-000000000000}"/>
-          </ac:spMkLst>
-        </pc:spChg>
-        <pc:spChg chg="mod">
-          <ac:chgData name="Brayand Javier Gómez Plata" userId="c9c1396e-34a9-4a12-912a-8649ffb9a204" providerId="ADAL" clId="{27F4626A-F3D0-4E6C-A104-AEA19FA55BBA}" dt="2026-07-02T21:33:44.108" v="4643" actId="790"/>
-          <ac:spMkLst>
-            <pc:docMk/>
-            <pc:sldMk cId="0" sldId="274"/>
-            <ac:spMk id="18" creationId="{00000000-0000-0000-0000-000000000000}"/>
-          </ac:spMkLst>
-        </pc:spChg>
-        <pc:spChg chg="mod">
-          <ac:chgData name="Brayand Javier Gómez Plata" userId="c9c1396e-34a9-4a12-912a-8649ffb9a204" providerId="ADAL" clId="{27F4626A-F3D0-4E6C-A104-AEA19FA55BBA}" dt="2026-07-02T21:33:44.108" v="4643" actId="790"/>
-          <ac:spMkLst>
-            <pc:docMk/>
-            <pc:sldMk cId="0" sldId="274"/>
-            <ac:spMk id="21" creationId="{00000000-0000-0000-0000-000000000000}"/>
           </ac:spMkLst>
         </pc:spChg>
         <pc:spChg chg="add del mod">
@@ -1771,111 +932,8 @@
           </ac:grpSpMkLst>
         </pc:grpChg>
       </pc:sldChg>
-      <pc:sldChg chg="addSp delSp modSp new del mod">
-        <pc:chgData name="Brayand Javier Gómez Plata" userId="c9c1396e-34a9-4a12-912a-8649ffb9a204" providerId="ADAL" clId="{27F4626A-F3D0-4E6C-A104-AEA19FA55BBA}" dt="2026-07-02T19:05:46.807" v="2680" actId="2696"/>
-        <pc:sldMkLst>
-          <pc:docMk/>
-          <pc:sldMk cId="2083100885" sldId="276"/>
-        </pc:sldMkLst>
-        <pc:spChg chg="add del mod">
-          <ac:chgData name="Brayand Javier Gómez Plata" userId="c9c1396e-34a9-4a12-912a-8649ffb9a204" providerId="ADAL" clId="{27F4626A-F3D0-4E6C-A104-AEA19FA55BBA}" dt="2026-07-02T19:00:58.266" v="2563" actId="478"/>
-          <ac:spMkLst>
-            <pc:docMk/>
-            <pc:sldMk cId="2083100885" sldId="276"/>
-            <ac:spMk id="3" creationId="{18E0FC83-BD0A-A33A-EE49-DD594520F795}"/>
-          </ac:spMkLst>
-        </pc:spChg>
-        <pc:spChg chg="add mod ord">
-          <ac:chgData name="Brayand Javier Gómez Plata" userId="c9c1396e-34a9-4a12-912a-8649ffb9a204" providerId="ADAL" clId="{27F4626A-F3D0-4E6C-A104-AEA19FA55BBA}" dt="2026-07-02T19:05:23.350" v="2676" actId="164"/>
-          <ac:spMkLst>
-            <pc:docMk/>
-            <pc:sldMk cId="2083100885" sldId="276"/>
-            <ac:spMk id="5" creationId="{F0B981DC-4965-C874-1096-D7906A04EFB8}"/>
-          </ac:spMkLst>
-        </pc:spChg>
-        <pc:spChg chg="add mod ord">
-          <ac:chgData name="Brayand Javier Gómez Plata" userId="c9c1396e-34a9-4a12-912a-8649ffb9a204" providerId="ADAL" clId="{27F4626A-F3D0-4E6C-A104-AEA19FA55BBA}" dt="2026-07-02T19:05:23.350" v="2676" actId="164"/>
-          <ac:spMkLst>
-            <pc:docMk/>
-            <pc:sldMk cId="2083100885" sldId="276"/>
-            <ac:spMk id="7" creationId="{05569960-0A73-688B-D9FF-B82C18C5811B}"/>
-          </ac:spMkLst>
-        </pc:spChg>
-        <pc:spChg chg="add mod ord">
-          <ac:chgData name="Brayand Javier Gómez Plata" userId="c9c1396e-34a9-4a12-912a-8649ffb9a204" providerId="ADAL" clId="{27F4626A-F3D0-4E6C-A104-AEA19FA55BBA}" dt="2026-07-02T19:05:23.350" v="2676" actId="164"/>
-          <ac:spMkLst>
-            <pc:docMk/>
-            <pc:sldMk cId="2083100885" sldId="276"/>
-            <ac:spMk id="9" creationId="{DAE3D3AC-9A15-C37B-B47D-77CF1580E9C8}"/>
-          </ac:spMkLst>
-        </pc:spChg>
-        <pc:spChg chg="add mod ord">
-          <ac:chgData name="Brayand Javier Gómez Plata" userId="c9c1396e-34a9-4a12-912a-8649ffb9a204" providerId="ADAL" clId="{27F4626A-F3D0-4E6C-A104-AEA19FA55BBA}" dt="2026-07-02T19:05:23.350" v="2676" actId="164"/>
-          <ac:spMkLst>
-            <pc:docMk/>
-            <pc:sldMk cId="2083100885" sldId="276"/>
-            <ac:spMk id="11" creationId="{4621DA70-C13C-21B4-D221-0C67865BF4EF}"/>
-          </ac:spMkLst>
-        </pc:spChg>
-        <pc:spChg chg="add mod ord">
-          <ac:chgData name="Brayand Javier Gómez Plata" userId="c9c1396e-34a9-4a12-912a-8649ffb9a204" providerId="ADAL" clId="{27F4626A-F3D0-4E6C-A104-AEA19FA55BBA}" dt="2026-07-02T19:05:23.350" v="2676" actId="164"/>
-          <ac:spMkLst>
-            <pc:docMk/>
-            <pc:sldMk cId="2083100885" sldId="276"/>
-            <ac:spMk id="13" creationId="{D6F999E4-D7A1-AF93-8398-44FE9C8E6D46}"/>
-          </ac:spMkLst>
-        </pc:spChg>
-        <pc:spChg chg="add mod ord">
-          <ac:chgData name="Brayand Javier Gómez Plata" userId="c9c1396e-34a9-4a12-912a-8649ffb9a204" providerId="ADAL" clId="{27F4626A-F3D0-4E6C-A104-AEA19FA55BBA}" dt="2026-07-02T19:05:23.350" v="2676" actId="164"/>
-          <ac:spMkLst>
-            <pc:docMk/>
-            <pc:sldMk cId="2083100885" sldId="276"/>
-            <ac:spMk id="15" creationId="{1528D361-0B29-0079-B2A8-27572ABBCCF3}"/>
-          </ac:spMkLst>
-        </pc:spChg>
-        <pc:spChg chg="add mod ord">
-          <ac:chgData name="Brayand Javier Gómez Plata" userId="c9c1396e-34a9-4a12-912a-8649ffb9a204" providerId="ADAL" clId="{27F4626A-F3D0-4E6C-A104-AEA19FA55BBA}" dt="2026-07-02T19:05:23.350" v="2676" actId="164"/>
-          <ac:spMkLst>
-            <pc:docMk/>
-            <pc:sldMk cId="2083100885" sldId="276"/>
-            <ac:spMk id="17" creationId="{A3948E83-D54F-01D8-12F6-DADF2847EE05}"/>
-          </ac:spMkLst>
-        </pc:spChg>
-        <pc:spChg chg="add mod ord">
-          <ac:chgData name="Brayand Javier Gómez Plata" userId="c9c1396e-34a9-4a12-912a-8649ffb9a204" providerId="ADAL" clId="{27F4626A-F3D0-4E6C-A104-AEA19FA55BBA}" dt="2026-07-02T19:05:23.350" v="2676" actId="164"/>
-          <ac:spMkLst>
-            <pc:docMk/>
-            <pc:sldMk cId="2083100885" sldId="276"/>
-            <ac:spMk id="19" creationId="{237FCF3C-79D0-78F5-E4F8-2434D56DA728}"/>
-          </ac:spMkLst>
-        </pc:spChg>
-        <pc:spChg chg="add mod ord">
-          <ac:chgData name="Brayand Javier Gómez Plata" userId="c9c1396e-34a9-4a12-912a-8649ffb9a204" providerId="ADAL" clId="{27F4626A-F3D0-4E6C-A104-AEA19FA55BBA}" dt="2026-07-02T19:05:23.350" v="2676" actId="164"/>
-          <ac:spMkLst>
-            <pc:docMk/>
-            <pc:sldMk cId="2083100885" sldId="276"/>
-            <ac:spMk id="23" creationId="{95F59235-1C7E-5C38-32F2-358E2E751657}"/>
-          </ac:spMkLst>
-        </pc:spChg>
-        <pc:spChg chg="add mod ord">
-          <ac:chgData name="Brayand Javier Gómez Plata" userId="c9c1396e-34a9-4a12-912a-8649ffb9a204" providerId="ADAL" clId="{27F4626A-F3D0-4E6C-A104-AEA19FA55BBA}" dt="2026-07-02T19:05:23.350" v="2676" actId="164"/>
-          <ac:spMkLst>
-            <pc:docMk/>
-            <pc:sldMk cId="2083100885" sldId="276"/>
-            <ac:spMk id="25" creationId="{A6300736-CC65-DB24-D601-4A97F161FF88}"/>
-          </ac:spMkLst>
-        </pc:spChg>
-        <pc:grpChg chg="mod">
-          <ac:chgData name="Brayand Javier Gómez Plata" userId="c9c1396e-34a9-4a12-912a-8649ffb9a204" providerId="ADAL" clId="{27F4626A-F3D0-4E6C-A104-AEA19FA55BBA}" dt="2026-07-02T19:05:28.840" v="2677" actId="14100"/>
-          <ac:grpSpMkLst>
-            <pc:docMk/>
-            <pc:sldMk cId="2083100885" sldId="276"/>
-            <ac:grpSpMk id="28" creationId="{D9B9D567-9EDF-A6C2-020F-7A687653739F}"/>
-          </ac:grpSpMkLst>
-        </pc:grpChg>
-      </pc:sldChg>
       <pc:sldChg chg="addSp delSp modSp add mod">
-        <pc:chgData name="Brayand Javier Gómez Plata" userId="c9c1396e-34a9-4a12-912a-8649ffb9a204" providerId="ADAL" clId="{27F4626A-F3D0-4E6C-A104-AEA19FA55BBA}" dt="2026-07-03T16:28:10.336" v="5010" actId="790"/>
+        <pc:chgData name="Brayand Javier Gómez Plata" userId="c9c1396e-34a9-4a12-912a-8649ffb9a204" providerId="ADAL" clId="{27F4626A-F3D0-4E6C-A104-AEA19FA55BBA}" dt="2026-07-04T16:29:14.651" v="5324" actId="1076"/>
         <pc:sldMkLst>
           <pc:docMk/>
           <pc:sldMk cId="1753996103" sldId="277"/>
@@ -1992,6 +1050,14 @@
             <ac:spMk id="16" creationId="{1A98AFA6-9D5A-586E-DA35-542E91FF55F6}"/>
           </ac:spMkLst>
         </pc:spChg>
+        <pc:spChg chg="add del mod">
+          <ac:chgData name="Brayand Javier Gómez Plata" userId="c9c1396e-34a9-4a12-912a-8649ffb9a204" providerId="ADAL" clId="{27F4626A-F3D0-4E6C-A104-AEA19FA55BBA}" dt="2026-07-04T16:20:20.739" v="5263" actId="21"/>
+          <ac:spMkLst>
+            <pc:docMk/>
+            <pc:sldMk cId="1753996103" sldId="277"/>
+            <ac:spMk id="18" creationId="{695269FD-99AC-6FEB-90CF-C7587CD4A7A3}"/>
+          </ac:spMkLst>
+        </pc:spChg>
         <pc:spChg chg="mod">
           <ac:chgData name="Brayand Javier Gómez Plata" userId="c9c1396e-34a9-4a12-912a-8649ffb9a204" providerId="ADAL" clId="{27F4626A-F3D0-4E6C-A104-AEA19FA55BBA}" dt="2026-07-02T21:33:44.108" v="4643" actId="790"/>
           <ac:spMkLst>
@@ -2016,72 +1082,8 @@
             <ac:spMk id="33" creationId="{A9848880-97B8-2C9C-AFFD-39F4429EE4D6}"/>
           </ac:spMkLst>
         </pc:spChg>
-        <pc:spChg chg="mod">
-          <ac:chgData name="Brayand Javier Gómez Plata" userId="c9c1396e-34a9-4a12-912a-8649ffb9a204" providerId="ADAL" clId="{27F4626A-F3D0-4E6C-A104-AEA19FA55BBA}" dt="2026-07-02T18:59:27.970" v="2558" actId="790"/>
-          <ac:spMkLst>
-            <pc:docMk/>
-            <pc:sldMk cId="1753996103" sldId="277"/>
-            <ac:spMk id="61" creationId="{5A50E14A-C81A-FE4D-9D9B-A43633C802F4}"/>
-          </ac:spMkLst>
-        </pc:spChg>
-        <pc:spChg chg="mod">
-          <ac:chgData name="Brayand Javier Gómez Plata" userId="c9c1396e-34a9-4a12-912a-8649ffb9a204" providerId="ADAL" clId="{27F4626A-F3D0-4E6C-A104-AEA19FA55BBA}" dt="2026-07-02T18:59:27.970" v="2558" actId="790"/>
-          <ac:spMkLst>
-            <pc:docMk/>
-            <pc:sldMk cId="1753996103" sldId="277"/>
-            <ac:spMk id="62" creationId="{126642F5-4ABD-1758-F3EE-66DCC930F4A8}"/>
-          </ac:spMkLst>
-        </pc:spChg>
-        <pc:spChg chg="mod">
-          <ac:chgData name="Brayand Javier Gómez Plata" userId="c9c1396e-34a9-4a12-912a-8649ffb9a204" providerId="ADAL" clId="{27F4626A-F3D0-4E6C-A104-AEA19FA55BBA}" dt="2026-07-02T18:59:27.970" v="2558" actId="790"/>
-          <ac:spMkLst>
-            <pc:docMk/>
-            <pc:sldMk cId="1753996103" sldId="277"/>
-            <ac:spMk id="70" creationId="{06DA79FE-B236-98CC-0FBA-4402183F30A0}"/>
-          </ac:spMkLst>
-        </pc:spChg>
-        <pc:spChg chg="mod">
-          <ac:chgData name="Brayand Javier Gómez Plata" userId="c9c1396e-34a9-4a12-912a-8649ffb9a204" providerId="ADAL" clId="{27F4626A-F3D0-4E6C-A104-AEA19FA55BBA}" dt="2026-07-02T18:59:27.970" v="2558" actId="790"/>
-          <ac:spMkLst>
-            <pc:docMk/>
-            <pc:sldMk cId="1753996103" sldId="277"/>
-            <ac:spMk id="71" creationId="{7B04E2A6-8D97-C518-8D40-29B3DD0669FF}"/>
-          </ac:spMkLst>
-        </pc:spChg>
-        <pc:spChg chg="mod">
-          <ac:chgData name="Brayand Javier Gómez Plata" userId="c9c1396e-34a9-4a12-912a-8649ffb9a204" providerId="ADAL" clId="{27F4626A-F3D0-4E6C-A104-AEA19FA55BBA}" dt="2026-07-02T18:59:27.970" v="2558" actId="790"/>
-          <ac:spMkLst>
-            <pc:docMk/>
-            <pc:sldMk cId="1753996103" sldId="277"/>
-            <ac:spMk id="75" creationId="{FD2A7986-B88E-56A7-6C05-E0E22B40A317}"/>
-          </ac:spMkLst>
-        </pc:spChg>
-        <pc:spChg chg="mod">
-          <ac:chgData name="Brayand Javier Gómez Plata" userId="c9c1396e-34a9-4a12-912a-8649ffb9a204" providerId="ADAL" clId="{27F4626A-F3D0-4E6C-A104-AEA19FA55BBA}" dt="2026-07-02T18:59:27.970" v="2558" actId="790"/>
-          <ac:spMkLst>
-            <pc:docMk/>
-            <pc:sldMk cId="1753996103" sldId="277"/>
-            <ac:spMk id="76" creationId="{E21225A2-A27F-7783-3B83-17CFE10D13E2}"/>
-          </ac:spMkLst>
-        </pc:spChg>
-        <pc:spChg chg="mod">
-          <ac:chgData name="Brayand Javier Gómez Plata" userId="c9c1396e-34a9-4a12-912a-8649ffb9a204" providerId="ADAL" clId="{27F4626A-F3D0-4E6C-A104-AEA19FA55BBA}" dt="2026-07-02T18:59:27.970" v="2558" actId="790"/>
-          <ac:spMkLst>
-            <pc:docMk/>
-            <pc:sldMk cId="1753996103" sldId="277"/>
-            <ac:spMk id="77" creationId="{1A99891D-A1CB-9857-826A-A59314E6163A}"/>
-          </ac:spMkLst>
-        </pc:spChg>
-        <pc:spChg chg="mod">
-          <ac:chgData name="Brayand Javier Gómez Plata" userId="c9c1396e-34a9-4a12-912a-8649ffb9a204" providerId="ADAL" clId="{27F4626A-F3D0-4E6C-A104-AEA19FA55BBA}" dt="2026-07-02T18:59:27.970" v="2558" actId="790"/>
-          <ac:spMkLst>
-            <pc:docMk/>
-            <pc:sldMk cId="1753996103" sldId="277"/>
-            <ac:spMk id="79" creationId="{5A7D7104-BCC5-3FBD-FFB3-35C2A46ED2E0}"/>
-          </ac:spMkLst>
-        </pc:spChg>
         <pc:grpChg chg="mod">
-          <ac:chgData name="Brayand Javier Gómez Plata" userId="c9c1396e-34a9-4a12-912a-8649ffb9a204" providerId="ADAL" clId="{27F4626A-F3D0-4E6C-A104-AEA19FA55BBA}" dt="2026-07-02T19:05:35.832" v="2679" actId="1076"/>
+          <ac:chgData name="Brayand Javier Gómez Plata" userId="c9c1396e-34a9-4a12-912a-8649ffb9a204" providerId="ADAL" clId="{27F4626A-F3D0-4E6C-A104-AEA19FA55BBA}" dt="2026-07-04T16:29:14.651" v="5324" actId="1076"/>
           <ac:grpSpMkLst>
             <pc:docMk/>
             <pc:sldMk cId="1753996103" sldId="277"/>
@@ -2096,22 +1098,6 @@
             <ac:grpSpMk id="20" creationId="{9D8BAE04-53A9-BA43-F39E-A20309A6A9D8}"/>
           </ac:grpSpMkLst>
         </pc:grpChg>
-        <pc:grpChg chg="del">
-          <ac:chgData name="Brayand Javier Gómez Plata" userId="c9c1396e-34a9-4a12-912a-8649ffb9a204" providerId="ADAL" clId="{27F4626A-F3D0-4E6C-A104-AEA19FA55BBA}" dt="2026-07-02T19:00:52.337" v="2560" actId="478"/>
-          <ac:grpSpMkLst>
-            <pc:docMk/>
-            <pc:sldMk cId="1753996103" sldId="277"/>
-            <ac:grpSpMk id="60" creationId="{0E70F3B9-273F-E910-C0F0-891BD1ABD4D5}"/>
-          </ac:grpSpMkLst>
-        </pc:grpChg>
-        <pc:picChg chg="add del">
-          <ac:chgData name="Brayand Javier Gómez Plata" userId="c9c1396e-34a9-4a12-912a-8649ffb9a204" providerId="ADAL" clId="{27F4626A-F3D0-4E6C-A104-AEA19FA55BBA}" dt="2026-07-02T20:39:53.614" v="3232" actId="478"/>
-          <ac:picMkLst>
-            <pc:docMk/>
-            <pc:sldMk cId="1753996103" sldId="277"/>
-            <ac:picMk id="18" creationId="{5AC272C7-97C7-69AF-4C1D-DC79640628C0}"/>
-          </ac:picMkLst>
-        </pc:picChg>
         <pc:picChg chg="add">
           <ac:chgData name="Brayand Javier Gómez Plata" userId="c9c1396e-34a9-4a12-912a-8649ffb9a204" providerId="ADAL" clId="{27F4626A-F3D0-4E6C-A104-AEA19FA55BBA}" dt="2026-07-02T20:39:53.821" v="3233" actId="22"/>
           <ac:picMkLst>
@@ -2122,11 +1108,19 @@
         </pc:picChg>
       </pc:sldChg>
       <pc:sldChg chg="addSp delSp modSp add mod">
-        <pc:chgData name="Brayand Javier Gómez Plata" userId="c9c1396e-34a9-4a12-912a-8649ffb9a204" providerId="ADAL" clId="{27F4626A-F3D0-4E6C-A104-AEA19FA55BBA}" dt="2026-07-03T16:28:10.336" v="5010" actId="790"/>
+        <pc:chgData name="Brayand Javier Gómez Plata" userId="c9c1396e-34a9-4a12-912a-8649ffb9a204" providerId="ADAL" clId="{27F4626A-F3D0-4E6C-A104-AEA19FA55BBA}" dt="2026-07-04T16:29:20.500" v="5325" actId="1076"/>
         <pc:sldMkLst>
           <pc:docMk/>
           <pc:sldMk cId="1676381019" sldId="278"/>
         </pc:sldMkLst>
+        <pc:spChg chg="add del">
+          <ac:chgData name="Brayand Javier Gómez Plata" userId="c9c1396e-34a9-4a12-912a-8649ffb9a204" providerId="ADAL" clId="{27F4626A-F3D0-4E6C-A104-AEA19FA55BBA}" dt="2026-07-04T16:21:06.219" v="5275" actId="21"/>
+          <ac:spMkLst>
+            <pc:docMk/>
+            <pc:sldMk cId="1676381019" sldId="278"/>
+            <ac:spMk id="3" creationId="{06C1CB6F-C849-F55C-C14C-3C3201F30633}"/>
+          </ac:spMkLst>
+        </pc:spChg>
         <pc:spChg chg="mod">
           <ac:chgData name="Brayand Javier Gómez Plata" userId="c9c1396e-34a9-4a12-912a-8649ffb9a204" providerId="ADAL" clId="{27F4626A-F3D0-4E6C-A104-AEA19FA55BBA}" dt="2026-07-02T21:33:44.108" v="4643" actId="790"/>
           <ac:spMkLst>
@@ -2175,28 +1169,12 @@
             <ac:spMk id="27" creationId="{F2536808-2E6D-785E-8059-11AAA321524B}"/>
           </ac:spMkLst>
         </pc:spChg>
-        <pc:spChg chg="del">
-          <ac:chgData name="Brayand Javier Gómez Plata" userId="c9c1396e-34a9-4a12-912a-8649ffb9a204" providerId="ADAL" clId="{27F4626A-F3D0-4E6C-A104-AEA19FA55BBA}" dt="2026-07-02T19:06:57.378" v="2757" actId="478"/>
-          <ac:spMkLst>
-            <pc:docMk/>
-            <pc:sldMk cId="1676381019" sldId="278"/>
-            <ac:spMk id="29" creationId="{76F372B7-8C0E-662A-F7C7-8C9B99D9F9A5}"/>
-          </ac:spMkLst>
-        </pc:spChg>
         <pc:spChg chg="mod">
           <ac:chgData name="Brayand Javier Gómez Plata" userId="c9c1396e-34a9-4a12-912a-8649ffb9a204" providerId="ADAL" clId="{27F4626A-F3D0-4E6C-A104-AEA19FA55BBA}" dt="2026-07-03T16:28:10.336" v="5010" actId="790"/>
           <ac:spMkLst>
             <pc:docMk/>
             <pc:sldMk cId="1676381019" sldId="278"/>
             <ac:spMk id="32" creationId="{B9364D2C-96D6-BDD8-40AA-5A8EA8582302}"/>
-          </ac:spMkLst>
-        </pc:spChg>
-        <pc:spChg chg="del">
-          <ac:chgData name="Brayand Javier Gómez Plata" userId="c9c1396e-34a9-4a12-912a-8649ffb9a204" providerId="ADAL" clId="{27F4626A-F3D0-4E6C-A104-AEA19FA55BBA}" dt="2026-07-02T19:06:53.018" v="2756" actId="478"/>
-          <ac:spMkLst>
-            <pc:docMk/>
-            <pc:sldMk cId="1676381019" sldId="278"/>
-            <ac:spMk id="33" creationId="{34CAE5FA-5DD6-91FF-2F30-4BA991AEE6AB}"/>
           </ac:spMkLst>
         </pc:spChg>
         <pc:spChg chg="mod">
@@ -2271,52 +1249,20 @@
             <ac:spMk id="66" creationId="{A3D08185-B016-2940-AFB0-1FC86948796B}"/>
           </ac:spMkLst>
         </pc:spChg>
-        <pc:grpChg chg="del">
-          <ac:chgData name="Brayand Javier Gómez Plata" userId="c9c1396e-34a9-4a12-912a-8649ffb9a204" providerId="ADAL" clId="{27F4626A-F3D0-4E6C-A104-AEA19FA55BBA}" dt="2026-07-02T19:06:58.874" v="2758" actId="478"/>
-          <ac:grpSpMkLst>
-            <pc:docMk/>
-            <pc:sldMk cId="1676381019" sldId="278"/>
-            <ac:grpSpMk id="2" creationId="{ED7DD5AF-DFDC-9A92-0E18-41E104B6B403}"/>
-          </ac:grpSpMkLst>
-        </pc:grpChg>
-        <pc:grpChg chg="del">
-          <ac:chgData name="Brayand Javier Gómez Plata" userId="c9c1396e-34a9-4a12-912a-8649ffb9a204" providerId="ADAL" clId="{27F4626A-F3D0-4E6C-A104-AEA19FA55BBA}" dt="2026-07-02T19:06:52.010" v="2755" actId="478"/>
-          <ac:grpSpMkLst>
-            <pc:docMk/>
-            <pc:sldMk cId="1676381019" sldId="278"/>
-            <ac:grpSpMk id="20" creationId="{5BBF1874-D774-DF84-CFCA-629DA05A5AC7}"/>
-          </ac:grpSpMkLst>
-        </pc:grpChg>
         <pc:grpChg chg="mod">
-          <ac:chgData name="Brayand Javier Gómez Plata" userId="c9c1396e-34a9-4a12-912a-8649ffb9a204" providerId="ADAL" clId="{27F4626A-F3D0-4E6C-A104-AEA19FA55BBA}" dt="2026-07-02T19:07:49.955" v="2771" actId="1076"/>
+          <ac:chgData name="Brayand Javier Gómez Plata" userId="c9c1396e-34a9-4a12-912a-8649ffb9a204" providerId="ADAL" clId="{27F4626A-F3D0-4E6C-A104-AEA19FA55BBA}" dt="2026-07-04T16:29:20.500" v="5325" actId="1076"/>
           <ac:grpSpMkLst>
             <pc:docMk/>
             <pc:sldMk cId="1676381019" sldId="278"/>
             <ac:grpSpMk id="67" creationId="{661294F4-5B20-ECFA-96FA-0B9D90BB7399}"/>
           </ac:grpSpMkLst>
         </pc:grpChg>
-        <pc:picChg chg="del">
-          <ac:chgData name="Brayand Javier Gómez Plata" userId="c9c1396e-34a9-4a12-912a-8649ffb9a204" providerId="ADAL" clId="{27F4626A-F3D0-4E6C-A104-AEA19FA55BBA}" dt="2026-07-02T19:07:29.747" v="2766" actId="478"/>
-          <ac:picMkLst>
-            <pc:docMk/>
-            <pc:sldMk cId="1676381019" sldId="278"/>
-            <ac:picMk id="19" creationId="{E6351710-C949-8149-8D01-E73155D521D3}"/>
-          </ac:picMkLst>
-        </pc:picChg>
         <pc:picChg chg="add ord">
           <ac:chgData name="Brayand Javier Gómez Plata" userId="c9c1396e-34a9-4a12-912a-8649ffb9a204" providerId="ADAL" clId="{27F4626A-F3D0-4E6C-A104-AEA19FA55BBA}" dt="2026-07-02T19:07:41.145" v="2769" actId="167"/>
           <ac:picMkLst>
             <pc:docMk/>
             <pc:sldMk cId="1676381019" sldId="278"/>
             <ac:picMk id="43" creationId="{476F1985-BB8E-3999-9FDB-8F7CDC5D61E7}"/>
-          </ac:picMkLst>
-        </pc:picChg>
-        <pc:picChg chg="add del">
-          <ac:chgData name="Brayand Javier Gómez Plata" userId="c9c1396e-34a9-4a12-912a-8649ffb9a204" providerId="ADAL" clId="{27F4626A-F3D0-4E6C-A104-AEA19FA55BBA}" dt="2026-07-02T20:40:01.214" v="3234" actId="478"/>
-          <ac:picMkLst>
-            <pc:docMk/>
-            <pc:sldMk cId="1676381019" sldId="278"/>
-            <ac:picMk id="47" creationId="{636D159B-8D25-605B-893C-D1A9E1CDA8AA}"/>
           </ac:picMkLst>
         </pc:picChg>
         <pc:picChg chg="add">
@@ -2329,11 +1275,19 @@
         </pc:picChg>
       </pc:sldChg>
       <pc:sldChg chg="addSp delSp modSp add mod">
-        <pc:chgData name="Brayand Javier Gómez Plata" userId="c9c1396e-34a9-4a12-912a-8649ffb9a204" providerId="ADAL" clId="{27F4626A-F3D0-4E6C-A104-AEA19FA55BBA}" dt="2026-07-03T16:28:10.336" v="5010" actId="790"/>
+        <pc:chgData name="Brayand Javier Gómez Plata" userId="c9c1396e-34a9-4a12-912a-8649ffb9a204" providerId="ADAL" clId="{27F4626A-F3D0-4E6C-A104-AEA19FA55BBA}" dt="2026-07-04T16:29:09.348" v="5323" actId="1076"/>
         <pc:sldMkLst>
           <pc:docMk/>
           <pc:sldMk cId="1313839407" sldId="279"/>
         </pc:sldMkLst>
+        <pc:spChg chg="add del">
+          <ac:chgData name="Brayand Javier Gómez Plata" userId="c9c1396e-34a9-4a12-912a-8649ffb9a204" providerId="ADAL" clId="{27F4626A-F3D0-4E6C-A104-AEA19FA55BBA}" dt="2026-07-04T16:20:34.178" v="5269" actId="21"/>
+          <ac:spMkLst>
+            <pc:docMk/>
+            <pc:sldMk cId="1313839407" sldId="279"/>
+            <ac:spMk id="3" creationId="{20D217BA-E376-33EE-5202-6C0934C3F339}"/>
+          </ac:spMkLst>
+        </pc:spChg>
         <pc:spChg chg="mod">
           <ac:chgData name="Brayand Javier Gómez Plata" userId="c9c1396e-34a9-4a12-912a-8649ffb9a204" providerId="ADAL" clId="{27F4626A-F3D0-4E6C-A104-AEA19FA55BBA}" dt="2026-07-03T16:28:10.336" v="5010" actId="790"/>
           <ac:spMkLst>
@@ -2479,21 +1433,13 @@
           </ac:spMkLst>
         </pc:spChg>
         <pc:grpChg chg="mod">
-          <ac:chgData name="Brayand Javier Gómez Plata" userId="c9c1396e-34a9-4a12-912a-8649ffb9a204" providerId="ADAL" clId="{27F4626A-F3D0-4E6C-A104-AEA19FA55BBA}" dt="2026-07-02T21:44:31.419" v="4694" actId="14100"/>
+          <ac:chgData name="Brayand Javier Gómez Plata" userId="c9c1396e-34a9-4a12-912a-8649ffb9a204" providerId="ADAL" clId="{27F4626A-F3D0-4E6C-A104-AEA19FA55BBA}" dt="2026-07-04T16:29:09.348" v="5323" actId="1076"/>
           <ac:grpSpMkLst>
             <pc:docMk/>
             <pc:sldMk cId="1313839407" sldId="279"/>
             <ac:grpSpMk id="60" creationId="{6D9B70D1-6611-6E7A-F9E4-96D923D8108B}"/>
           </ac:grpSpMkLst>
         </pc:grpChg>
-        <pc:picChg chg="del">
-          <ac:chgData name="Brayand Javier Gómez Plata" userId="c9c1396e-34a9-4a12-912a-8649ffb9a204" providerId="ADAL" clId="{27F4626A-F3D0-4E6C-A104-AEA19FA55BBA}" dt="2026-07-02T20:39:45.510" v="3230" actId="478"/>
-          <ac:picMkLst>
-            <pc:docMk/>
-            <pc:sldMk cId="1313839407" sldId="279"/>
-            <ac:picMk id="3" creationId="{99767197-65AB-863B-6E13-D2C9A830172B}"/>
-          </ac:picMkLst>
-        </pc:picChg>
         <pc:picChg chg="add">
           <ac:chgData name="Brayand Javier Gómez Plata" userId="c9c1396e-34a9-4a12-912a-8649ffb9a204" providerId="ADAL" clId="{27F4626A-F3D0-4E6C-A104-AEA19FA55BBA}" dt="2026-07-02T20:39:45.749" v="3231" actId="22"/>
           <ac:picMkLst>
@@ -2502,119 +1448,17 @@
             <ac:picMk id="5" creationId="{108A0D2A-1FE7-A5C4-7ECC-8D922103D2F9}"/>
           </ac:picMkLst>
         </pc:picChg>
-      </pc:sldChg>
-      <pc:sldChg chg="addSp delSp modSp add del mod">
-        <pc:chgData name="Brayand Javier Gómez Plata" userId="c9c1396e-34a9-4a12-912a-8649ffb9a204" providerId="ADAL" clId="{27F4626A-F3D0-4E6C-A104-AEA19FA55BBA}" dt="2026-07-02T19:07:44.542" v="2770" actId="47"/>
-        <pc:sldMkLst>
-          <pc:docMk/>
-          <pc:sldMk cId="4283523547" sldId="279"/>
-        </pc:sldMkLst>
-        <pc:spChg chg="add mod">
-          <ac:chgData name="Brayand Javier Gómez Plata" userId="c9c1396e-34a9-4a12-912a-8649ffb9a204" providerId="ADAL" clId="{27F4626A-F3D0-4E6C-A104-AEA19FA55BBA}" dt="2026-07-02T19:07:14.624" v="2761" actId="164"/>
-          <ac:spMkLst>
-            <pc:docMk/>
-            <pc:sldMk cId="4283523547" sldId="279"/>
-            <ac:spMk id="9" creationId="{78DE7E4C-73A5-3853-20A8-FC2F8F404B5C}"/>
-          </ac:spMkLst>
-        </pc:spChg>
-        <pc:spChg chg="add mod">
-          <ac:chgData name="Brayand Javier Gómez Plata" userId="c9c1396e-34a9-4a12-912a-8649ffb9a204" providerId="ADAL" clId="{27F4626A-F3D0-4E6C-A104-AEA19FA55BBA}" dt="2026-07-02T19:07:14.624" v="2761" actId="164"/>
-          <ac:spMkLst>
-            <pc:docMk/>
-            <pc:sldMk cId="4283523547" sldId="279"/>
-            <ac:spMk id="15" creationId="{71B78833-9F4A-5FAC-C0D3-8380EEB28ACD}"/>
-          </ac:spMkLst>
-        </pc:spChg>
-        <pc:spChg chg="add mod">
-          <ac:chgData name="Brayand Javier Gómez Plata" userId="c9c1396e-34a9-4a12-912a-8649ffb9a204" providerId="ADAL" clId="{27F4626A-F3D0-4E6C-A104-AEA19FA55BBA}" dt="2026-07-02T19:07:14.624" v="2761" actId="164"/>
-          <ac:spMkLst>
-            <pc:docMk/>
-            <pc:sldMk cId="4283523547" sldId="279"/>
-            <ac:spMk id="24" creationId="{4759715A-6585-8B2F-AC9A-04B6FC3E45B8}"/>
-          </ac:spMkLst>
-        </pc:spChg>
-        <pc:spChg chg="add mod">
-          <ac:chgData name="Brayand Javier Gómez Plata" userId="c9c1396e-34a9-4a12-912a-8649ffb9a204" providerId="ADAL" clId="{27F4626A-F3D0-4E6C-A104-AEA19FA55BBA}" dt="2026-07-02T19:07:14.624" v="2761" actId="164"/>
-          <ac:spMkLst>
-            <pc:docMk/>
-            <pc:sldMk cId="4283523547" sldId="279"/>
-            <ac:spMk id="36" creationId="{8366EC77-9DDF-1AFD-D138-3B76407D0F79}"/>
-          </ac:spMkLst>
-        </pc:spChg>
-        <pc:spChg chg="add mod">
-          <ac:chgData name="Brayand Javier Gómez Plata" userId="c9c1396e-34a9-4a12-912a-8649ffb9a204" providerId="ADAL" clId="{27F4626A-F3D0-4E6C-A104-AEA19FA55BBA}" dt="2026-07-02T19:07:14.624" v="2761" actId="164"/>
-          <ac:spMkLst>
-            <pc:docMk/>
-            <pc:sldMk cId="4283523547" sldId="279"/>
-            <ac:spMk id="38" creationId="{45377697-1F71-14EE-29C0-2F0F14050234}"/>
-          </ac:spMkLst>
-        </pc:spChg>
-        <pc:spChg chg="add mod">
-          <ac:chgData name="Brayand Javier Gómez Plata" userId="c9c1396e-34a9-4a12-912a-8649ffb9a204" providerId="ADAL" clId="{27F4626A-F3D0-4E6C-A104-AEA19FA55BBA}" dt="2026-07-02T19:07:14.624" v="2761" actId="164"/>
-          <ac:spMkLst>
-            <pc:docMk/>
-            <pc:sldMk cId="4283523547" sldId="279"/>
-            <ac:spMk id="40" creationId="{532CC3A9-BDC0-4BBA-856F-22158C09A919}"/>
-          </ac:spMkLst>
-        </pc:spChg>
-        <pc:spChg chg="add mod">
-          <ac:chgData name="Brayand Javier Gómez Plata" userId="c9c1396e-34a9-4a12-912a-8649ffb9a204" providerId="ADAL" clId="{27F4626A-F3D0-4E6C-A104-AEA19FA55BBA}" dt="2026-07-02T19:07:14.624" v="2761" actId="164"/>
-          <ac:spMkLst>
-            <pc:docMk/>
-            <pc:sldMk cId="4283523547" sldId="279"/>
-            <ac:spMk id="42" creationId="{59E6E193-690D-F563-5BC3-1B81E98375E7}"/>
-          </ac:spMkLst>
-        </pc:spChg>
-        <pc:spChg chg="add mod">
-          <ac:chgData name="Brayand Javier Gómez Plata" userId="c9c1396e-34a9-4a12-912a-8649ffb9a204" providerId="ADAL" clId="{27F4626A-F3D0-4E6C-A104-AEA19FA55BBA}" dt="2026-07-02T19:07:14.624" v="2761" actId="164"/>
-          <ac:spMkLst>
-            <pc:docMk/>
-            <pc:sldMk cId="4283523547" sldId="279"/>
-            <ac:spMk id="44" creationId="{E26F5D32-E23E-EAA9-CAA6-C29E71ABB538}"/>
-          </ac:spMkLst>
-        </pc:spChg>
-        <pc:spChg chg="add mod">
-          <ac:chgData name="Brayand Javier Gómez Plata" userId="c9c1396e-34a9-4a12-912a-8649ffb9a204" providerId="ADAL" clId="{27F4626A-F3D0-4E6C-A104-AEA19FA55BBA}" dt="2026-07-02T19:07:14.624" v="2761" actId="164"/>
-          <ac:spMkLst>
-            <pc:docMk/>
-            <pc:sldMk cId="4283523547" sldId="279"/>
-            <ac:spMk id="50" creationId="{54982850-F5E9-9A1B-293F-142EB3C12928}"/>
-          </ac:spMkLst>
-        </pc:spChg>
-        <pc:spChg chg="add mod">
-          <ac:chgData name="Brayand Javier Gómez Plata" userId="c9c1396e-34a9-4a12-912a-8649ffb9a204" providerId="ADAL" clId="{27F4626A-F3D0-4E6C-A104-AEA19FA55BBA}" dt="2026-07-02T19:07:14.624" v="2761" actId="164"/>
-          <ac:spMkLst>
-            <pc:docMk/>
-            <pc:sldMk cId="4283523547" sldId="279"/>
-            <ac:spMk id="66" creationId="{A3D08185-B016-2940-AFB0-1FC86948796B}"/>
-          </ac:spMkLst>
-        </pc:spChg>
-        <pc:grpChg chg="del mod">
-          <ac:chgData name="Brayand Javier Gómez Plata" userId="c9c1396e-34a9-4a12-912a-8649ffb9a204" providerId="ADAL" clId="{27F4626A-F3D0-4E6C-A104-AEA19FA55BBA}" dt="2026-07-02T19:07:21.094" v="2764" actId="21"/>
-          <ac:grpSpMkLst>
-            <pc:docMk/>
-            <pc:sldMk cId="4283523547" sldId="279"/>
-            <ac:grpSpMk id="67" creationId="{661294F4-5B20-ECFA-96FA-0B9D90BB7399}"/>
-          </ac:grpSpMkLst>
-        </pc:grpChg>
-        <pc:picChg chg="add">
-          <ac:chgData name="Brayand Javier Gómez Plata" userId="c9c1396e-34a9-4a12-912a-8649ffb9a204" providerId="ADAL" clId="{27F4626A-F3D0-4E6C-A104-AEA19FA55BBA}" dt="2026-07-02T19:07:35.530" v="2767" actId="22"/>
+        <pc:picChg chg="mod">
+          <ac:chgData name="Brayand Javier Gómez Plata" userId="c9c1396e-34a9-4a12-912a-8649ffb9a204" providerId="ADAL" clId="{27F4626A-F3D0-4E6C-A104-AEA19FA55BBA}" dt="2026-07-04T16:20:28.251" v="5267" actId="1076"/>
           <ac:picMkLst>
             <pc:docMk/>
-            <pc:sldMk cId="4283523547" sldId="279"/>
-            <ac:picMk id="69" creationId="{EBF68B6E-B601-CA5E-BB39-A8C94CF0ACBB}"/>
+            <pc:sldMk cId="1313839407" sldId="279"/>
+            <ac:picMk id="19" creationId="{92DDF9BD-4F55-F61C-41B9-817077D05C05}"/>
           </ac:picMkLst>
         </pc:picChg>
       </pc:sldChg>
-      <pc:sldChg chg="add del">
-        <pc:chgData name="Brayand Javier Gómez Plata" userId="c9c1396e-34a9-4a12-912a-8649ffb9a204" providerId="ADAL" clId="{27F4626A-F3D0-4E6C-A104-AEA19FA55BBA}" dt="2026-07-02T19:10:05.835" v="2783" actId="2696"/>
-        <pc:sldMkLst>
-          <pc:docMk/>
-          <pc:sldMk cId="4286397150" sldId="279"/>
-        </pc:sldMkLst>
-      </pc:sldChg>
       <pc:sldChg chg="addSp delSp modSp add mod ord">
-        <pc:chgData name="Brayand Javier Gómez Plata" userId="c9c1396e-34a9-4a12-912a-8649ffb9a204" providerId="ADAL" clId="{27F4626A-F3D0-4E6C-A104-AEA19FA55BBA}" dt="2026-07-03T16:28:10.336" v="5010" actId="790"/>
+        <pc:chgData name="Brayand Javier Gómez Plata" userId="c9c1396e-34a9-4a12-912a-8649ffb9a204" providerId="ADAL" clId="{27F4626A-F3D0-4E6C-A104-AEA19FA55BBA}" dt="2026-07-04T16:24:26.991" v="5317" actId="22"/>
         <pc:sldMkLst>
           <pc:docMk/>
           <pc:sldMk cId="1486866337" sldId="280"/>
@@ -2627,6 +1471,14 @@
             <ac:spMk id="4" creationId="{F395F823-4998-FF30-98C4-C3F4CBE49122}"/>
           </ac:spMkLst>
         </pc:spChg>
+        <pc:spChg chg="add del">
+          <ac:chgData name="Brayand Javier Gómez Plata" userId="c9c1396e-34a9-4a12-912a-8649ffb9a204" providerId="ADAL" clId="{27F4626A-F3D0-4E6C-A104-AEA19FA55BBA}" dt="2026-07-04T16:24:26.991" v="5317" actId="22"/>
+          <ac:spMkLst>
+            <pc:docMk/>
+            <pc:sldMk cId="1486866337" sldId="280"/>
+            <ac:spMk id="5" creationId="{DB890804-6B22-7E47-9F52-6DB63CA6D31E}"/>
+          </ac:spMkLst>
+        </pc:spChg>
         <pc:spChg chg="mod">
           <ac:chgData name="Brayand Javier Gómez Plata" userId="c9c1396e-34a9-4a12-912a-8649ffb9a204" providerId="ADAL" clId="{27F4626A-F3D0-4E6C-A104-AEA19FA55BBA}" dt="2026-07-03T16:28:10.336" v="5010" actId="790"/>
           <ac:spMkLst>
@@ -2635,108 +1487,12 @@
             <ac:spMk id="7" creationId="{A97CA187-8888-B04A-23E5-0257C6F94CE6}"/>
           </ac:spMkLst>
         </pc:spChg>
-        <pc:spChg chg="add del">
-          <ac:chgData name="Brayand Javier Gómez Plata" userId="c9c1396e-34a9-4a12-912a-8649ffb9a204" providerId="ADAL" clId="{27F4626A-F3D0-4E6C-A104-AEA19FA55BBA}" dt="2026-07-02T20:11:44.345" v="2924" actId="22"/>
-          <ac:spMkLst>
-            <pc:docMk/>
-            <pc:sldMk cId="1486866337" sldId="280"/>
-            <ac:spMk id="9" creationId="{B799A369-2868-7B89-C98B-93CB4DAEC21F}"/>
-          </ac:spMkLst>
-        </pc:spChg>
-        <pc:spChg chg="add del">
-          <ac:chgData name="Brayand Javier Gómez Plata" userId="c9c1396e-34a9-4a12-912a-8649ffb9a204" providerId="ADAL" clId="{27F4626A-F3D0-4E6C-A104-AEA19FA55BBA}" dt="2026-07-02T20:11:44.345" v="2924" actId="22"/>
-          <ac:spMkLst>
-            <pc:docMk/>
-            <pc:sldMk cId="1486866337" sldId="280"/>
-            <ac:spMk id="13" creationId="{57322011-0D01-6958-BB79-2DCE05D1390D}"/>
-          </ac:spMkLst>
-        </pc:spChg>
-        <pc:spChg chg="add del">
-          <ac:chgData name="Brayand Javier Gómez Plata" userId="c9c1396e-34a9-4a12-912a-8649ffb9a204" providerId="ADAL" clId="{27F4626A-F3D0-4E6C-A104-AEA19FA55BBA}" dt="2026-07-02T20:11:44.345" v="2924" actId="22"/>
-          <ac:spMkLst>
-            <pc:docMk/>
-            <pc:sldMk cId="1486866337" sldId="280"/>
-            <ac:spMk id="49" creationId="{A1AF0A68-C168-C6E4-1E37-ADB2BA55669D}"/>
-          </ac:spMkLst>
-        </pc:spChg>
-        <pc:spChg chg="add del">
-          <ac:chgData name="Brayand Javier Gómez Plata" userId="c9c1396e-34a9-4a12-912a-8649ffb9a204" providerId="ADAL" clId="{27F4626A-F3D0-4E6C-A104-AEA19FA55BBA}" dt="2026-07-02T20:11:44.345" v="2924" actId="22"/>
-          <ac:spMkLst>
-            <pc:docMk/>
-            <pc:sldMk cId="1486866337" sldId="280"/>
-            <ac:spMk id="69" creationId="{822C0580-27E8-EB4A-5D68-48FB5EAD7702}"/>
-          </ac:spMkLst>
-        </pc:spChg>
-        <pc:spChg chg="add del">
-          <ac:chgData name="Brayand Javier Gómez Plata" userId="c9c1396e-34a9-4a12-912a-8649ffb9a204" providerId="ADAL" clId="{27F4626A-F3D0-4E6C-A104-AEA19FA55BBA}" dt="2026-07-02T20:11:44.345" v="2924" actId="22"/>
-          <ac:spMkLst>
-            <pc:docMk/>
-            <pc:sldMk cId="1486866337" sldId="280"/>
-            <ac:spMk id="71" creationId="{E774311B-4A93-A937-FEAF-843044CF5F61}"/>
-          </ac:spMkLst>
-        </pc:spChg>
-        <pc:spChg chg="add del">
-          <ac:chgData name="Brayand Javier Gómez Plata" userId="c9c1396e-34a9-4a12-912a-8649ffb9a204" providerId="ADAL" clId="{27F4626A-F3D0-4E6C-A104-AEA19FA55BBA}" dt="2026-07-02T20:11:44.345" v="2924" actId="22"/>
-          <ac:spMkLst>
-            <pc:docMk/>
-            <pc:sldMk cId="1486866337" sldId="280"/>
-            <ac:spMk id="73" creationId="{F80A3D7B-9645-9DCC-53BD-B9A5BDA99582}"/>
-          </ac:spMkLst>
-        </pc:spChg>
-        <pc:spChg chg="add del">
-          <ac:chgData name="Brayand Javier Gómez Plata" userId="c9c1396e-34a9-4a12-912a-8649ffb9a204" providerId="ADAL" clId="{27F4626A-F3D0-4E6C-A104-AEA19FA55BBA}" dt="2026-07-02T20:11:44.345" v="2924" actId="22"/>
-          <ac:spMkLst>
-            <pc:docMk/>
-            <pc:sldMk cId="1486866337" sldId="280"/>
-            <ac:spMk id="79" creationId="{63135CD2-CBC8-DFA2-FBBA-95F13C5707BA}"/>
-          </ac:spMkLst>
-        </pc:spChg>
-        <pc:spChg chg="add del">
-          <ac:chgData name="Brayand Javier Gómez Plata" userId="c9c1396e-34a9-4a12-912a-8649ffb9a204" providerId="ADAL" clId="{27F4626A-F3D0-4E6C-A104-AEA19FA55BBA}" dt="2026-07-02T20:11:44.345" v="2924" actId="22"/>
-          <ac:spMkLst>
-            <pc:docMk/>
-            <pc:sldMk cId="1486866337" sldId="280"/>
-            <ac:spMk id="81" creationId="{4D118D6D-EA97-7D2B-9FD0-FCDE825B2FBB}"/>
-          </ac:spMkLst>
-        </pc:spChg>
-        <pc:spChg chg="add del">
-          <ac:chgData name="Brayand Javier Gómez Plata" userId="c9c1396e-34a9-4a12-912a-8649ffb9a204" providerId="ADAL" clId="{27F4626A-F3D0-4E6C-A104-AEA19FA55BBA}" dt="2026-07-02T20:11:44.345" v="2924" actId="22"/>
-          <ac:spMkLst>
-            <pc:docMk/>
-            <pc:sldMk cId="1486866337" sldId="280"/>
-            <ac:spMk id="87" creationId="{AE100785-3842-62DE-758B-19C56FA03525}"/>
-          </ac:spMkLst>
-        </pc:spChg>
-        <pc:spChg chg="add del">
-          <ac:chgData name="Brayand Javier Gómez Plata" userId="c9c1396e-34a9-4a12-912a-8649ffb9a204" providerId="ADAL" clId="{27F4626A-F3D0-4E6C-A104-AEA19FA55BBA}" dt="2026-07-02T20:11:44.345" v="2924" actId="22"/>
-          <ac:spMkLst>
-            <pc:docMk/>
-            <pc:sldMk cId="1486866337" sldId="280"/>
-            <ac:spMk id="91" creationId="{70C2A5B7-CC7F-7A10-8BEA-10523862A8F6}"/>
-          </ac:spMkLst>
-        </pc:spChg>
-        <pc:grpChg chg="del">
-          <ac:chgData name="Brayand Javier Gómez Plata" userId="c9c1396e-34a9-4a12-912a-8649ffb9a204" providerId="ADAL" clId="{27F4626A-F3D0-4E6C-A104-AEA19FA55BBA}" dt="2026-07-02T20:05:52.591" v="2823" actId="478"/>
-          <ac:grpSpMkLst>
-            <pc:docMk/>
-            <pc:sldMk cId="1486866337" sldId="280"/>
-            <ac:grpSpMk id="67" creationId="{EA5299C6-15F8-FB29-CA0B-4D9E3AB5E4B3}"/>
-          </ac:grpSpMkLst>
-        </pc:grpChg>
         <pc:picChg chg="add mod">
-          <ac:chgData name="Brayand Javier Gómez Plata" userId="c9c1396e-34a9-4a12-912a-8649ffb9a204" providerId="ADAL" clId="{27F4626A-F3D0-4E6C-A104-AEA19FA55BBA}" dt="2026-07-02T20:07:38.208" v="2826" actId="1076"/>
+          <ac:chgData name="Brayand Javier Gómez Plata" userId="c9c1396e-34a9-4a12-912a-8649ffb9a204" providerId="ADAL" clId="{27F4626A-F3D0-4E6C-A104-AEA19FA55BBA}" dt="2026-07-04T16:24:26.774" v="5316" actId="14100"/>
           <ac:picMkLst>
             <pc:docMk/>
             <pc:sldMk cId="1486866337" sldId="280"/>
             <ac:picMk id="3" creationId="{6453A2D2-D340-13D9-40C6-D7927FB469AF}"/>
-          </ac:picMkLst>
-        </pc:picChg>
-        <pc:picChg chg="del">
-          <ac:chgData name="Brayand Javier Gómez Plata" userId="c9c1396e-34a9-4a12-912a-8649ffb9a204" providerId="ADAL" clId="{27F4626A-F3D0-4E6C-A104-AEA19FA55BBA}" dt="2026-07-02T20:40:11.352" v="3238" actId="478"/>
-          <ac:picMkLst>
-            <pc:docMk/>
-            <pc:sldMk cId="1486866337" sldId="280"/>
-            <ac:picMk id="47" creationId="{567A70F1-A12B-DA7F-213A-772CF281E939}"/>
           </ac:picMkLst>
         </pc:picChg>
         <pc:picChg chg="add mod ord">
@@ -2748,15 +1504,8 @@
           </ac:picMkLst>
         </pc:picChg>
       </pc:sldChg>
-      <pc:sldChg chg="add del">
-        <pc:chgData name="Brayand Javier Gómez Plata" userId="c9c1396e-34a9-4a12-912a-8649ffb9a204" providerId="ADAL" clId="{27F4626A-F3D0-4E6C-A104-AEA19FA55BBA}" dt="2026-07-02T19:10:11.443" v="2784" actId="2696"/>
-        <pc:sldMkLst>
-          <pc:docMk/>
-          <pc:sldMk cId="1955688678" sldId="280"/>
-        </pc:sldMkLst>
-      </pc:sldChg>
       <pc:sldChg chg="addSp delSp modSp add mod">
-        <pc:chgData name="Brayand Javier Gómez Plata" userId="c9c1396e-34a9-4a12-912a-8649ffb9a204" providerId="ADAL" clId="{27F4626A-F3D0-4E6C-A104-AEA19FA55BBA}" dt="2026-07-03T16:28:10.336" v="5010" actId="790"/>
+        <pc:chgData name="Brayand Javier Gómez Plata" userId="c9c1396e-34a9-4a12-912a-8649ffb9a204" providerId="ADAL" clId="{27F4626A-F3D0-4E6C-A104-AEA19FA55BBA}" dt="2026-07-04T16:29:24.468" v="5326" actId="1076"/>
         <pc:sldMkLst>
           <pc:docMk/>
           <pc:sldMk cId="3571458388" sldId="281"/>
@@ -2775,6 +1524,14 @@
             <pc:docMk/>
             <pc:sldMk cId="3571458388" sldId="281"/>
             <ac:spMk id="4" creationId="{1A993AB3-0838-E7F0-3A18-50B23EE96BC1}"/>
+          </ac:spMkLst>
+        </pc:spChg>
+        <pc:spChg chg="add del">
+          <ac:chgData name="Brayand Javier Gómez Plata" userId="c9c1396e-34a9-4a12-912a-8649ffb9a204" providerId="ADAL" clId="{27F4626A-F3D0-4E6C-A104-AEA19FA55BBA}" dt="2026-07-04T16:24:31.189" v="5320" actId="478"/>
+          <ac:spMkLst>
+            <pc:docMk/>
+            <pc:sldMk cId="3571458388" sldId="281"/>
+            <ac:spMk id="5" creationId="{D8B5BD7A-5F28-DC27-BA17-82AE12C2ED1F}"/>
           </ac:spMkLst>
         </pc:spChg>
         <pc:spChg chg="add mod">
@@ -2913,30 +1670,14 @@
             <ac:spMk id="97" creationId="{5C4414F5-BB69-B250-048A-4729642AD30D}"/>
           </ac:spMkLst>
         </pc:spChg>
-        <pc:grpChg chg="del">
-          <ac:chgData name="Brayand Javier Gómez Plata" userId="c9c1396e-34a9-4a12-912a-8649ffb9a204" providerId="ADAL" clId="{27F4626A-F3D0-4E6C-A104-AEA19FA55BBA}" dt="2026-07-02T20:10:21.269" v="2919" actId="478"/>
-          <ac:grpSpMkLst>
-            <pc:docMk/>
-            <pc:sldMk cId="3571458388" sldId="281"/>
-            <ac:grpSpMk id="67" creationId="{F4DADAA7-9069-D0A3-93F0-EE6EE85B5AF9}"/>
-          </ac:grpSpMkLst>
-        </pc:grpChg>
         <pc:grpChg chg="mod">
-          <ac:chgData name="Brayand Javier Gómez Plata" userId="c9c1396e-34a9-4a12-912a-8649ffb9a204" providerId="ADAL" clId="{27F4626A-F3D0-4E6C-A104-AEA19FA55BBA}" dt="2026-07-02T20:10:35.757" v="2922" actId="14100"/>
+          <ac:chgData name="Brayand Javier Gómez Plata" userId="c9c1396e-34a9-4a12-912a-8649ffb9a204" providerId="ADAL" clId="{27F4626A-F3D0-4E6C-A104-AEA19FA55BBA}" dt="2026-07-04T16:29:24.468" v="5326" actId="1076"/>
           <ac:grpSpMkLst>
             <pc:docMk/>
             <pc:sldMk cId="3571458388" sldId="281"/>
             <ac:grpSpMk id="102" creationId="{2ACADB14-BB10-32ED-53F3-810E6D39F20F}"/>
           </ac:grpSpMkLst>
         </pc:grpChg>
-        <pc:picChg chg="del">
-          <ac:chgData name="Brayand Javier Gómez Plata" userId="c9c1396e-34a9-4a12-912a-8649ffb9a204" providerId="ADAL" clId="{27F4626A-F3D0-4E6C-A104-AEA19FA55BBA}" dt="2026-07-02T20:40:07.503" v="3236" actId="478"/>
-          <ac:picMkLst>
-            <pc:docMk/>
-            <pc:sldMk cId="3571458388" sldId="281"/>
-            <ac:picMk id="47" creationId="{755B36A1-4717-AC48-5067-BEE33FD57E59}"/>
-          </ac:picMkLst>
-        </pc:picChg>
         <pc:picChg chg="add">
           <ac:chgData name="Brayand Javier Gómez Plata" userId="c9c1396e-34a9-4a12-912a-8649ffb9a204" providerId="ADAL" clId="{27F4626A-F3D0-4E6C-A104-AEA19FA55BBA}" dt="2026-07-02T20:40:07.701" v="3237" actId="22"/>
           <ac:picMkLst>
@@ -2946,19 +1687,20 @@
           </ac:picMkLst>
         </pc:picChg>
       </pc:sldChg>
-      <pc:sldChg chg="add del">
-        <pc:chgData name="Brayand Javier Gómez Plata" userId="c9c1396e-34a9-4a12-912a-8649ffb9a204" providerId="ADAL" clId="{27F4626A-F3D0-4E6C-A104-AEA19FA55BBA}" dt="2026-07-02T20:08:57.685" v="2851" actId="2696"/>
-        <pc:sldMkLst>
-          <pc:docMk/>
-          <pc:sldMk cId="3751655904" sldId="281"/>
-        </pc:sldMkLst>
-      </pc:sldChg>
       <pc:sldChg chg="addSp delSp modSp add mod setBg">
-        <pc:chgData name="Brayand Javier Gómez Plata" userId="c9c1396e-34a9-4a12-912a-8649ffb9a204" providerId="ADAL" clId="{27F4626A-F3D0-4E6C-A104-AEA19FA55BBA}" dt="2026-07-03T16:28:10.336" v="5010" actId="790"/>
+        <pc:chgData name="Brayand Javier Gómez Plata" userId="c9c1396e-34a9-4a12-912a-8649ffb9a204" providerId="ADAL" clId="{27F4626A-F3D0-4E6C-A104-AEA19FA55BBA}" dt="2026-07-04T16:24:25.935" v="5313" actId="22"/>
         <pc:sldMkLst>
           <pc:docMk/>
           <pc:sldMk cId="3604946481" sldId="282"/>
         </pc:sldMkLst>
+        <pc:spChg chg="add del">
+          <ac:chgData name="Brayand Javier Gómez Plata" userId="c9c1396e-34a9-4a12-912a-8649ffb9a204" providerId="ADAL" clId="{27F4626A-F3D0-4E6C-A104-AEA19FA55BBA}" dt="2026-07-04T16:24:25.935" v="5313" actId="22"/>
+          <ac:spMkLst>
+            <pc:docMk/>
+            <pc:sldMk cId="3604946481" sldId="282"/>
+            <ac:spMk id="3" creationId="{58A64104-79EB-36CD-232B-6E1C8959613F}"/>
+          </ac:spMkLst>
+        </pc:spChg>
         <pc:spChg chg="mod">
           <ac:chgData name="Brayand Javier Gómez Plata" userId="c9c1396e-34a9-4a12-912a-8649ffb9a204" providerId="ADAL" clId="{27F4626A-F3D0-4E6C-A104-AEA19FA55BBA}" dt="2026-07-02T21:33:44.108" v="4643" actId="790"/>
           <ac:spMkLst>
@@ -3111,38 +1853,6 @@
             <ac:spMk id="108" creationId="{9A9440D3-0CB8-F1C8-D03F-4EEDB808EDB9}"/>
           </ac:spMkLst>
         </pc:spChg>
-        <pc:spChg chg="add del">
-          <ac:chgData name="Brayand Javier Gómez Plata" userId="c9c1396e-34a9-4a12-912a-8649ffb9a204" providerId="ADAL" clId="{27F4626A-F3D0-4E6C-A104-AEA19FA55BBA}" dt="2026-07-02T20:14:03.888" v="2961" actId="22"/>
-          <ac:spMkLst>
-            <pc:docMk/>
-            <pc:sldMk cId="3604946481" sldId="282"/>
-            <ac:spMk id="116" creationId="{9A34C1C9-5540-4886-CF2E-873FEA4319AE}"/>
-          </ac:spMkLst>
-        </pc:spChg>
-        <pc:picChg chg="del">
-          <ac:chgData name="Brayand Javier Gómez Plata" userId="c9c1396e-34a9-4a12-912a-8649ffb9a204" providerId="ADAL" clId="{27F4626A-F3D0-4E6C-A104-AEA19FA55BBA}" dt="2026-07-02T20:12:57.088" v="2926" actId="478"/>
-          <ac:picMkLst>
-            <pc:docMk/>
-            <pc:sldMk cId="3604946481" sldId="282"/>
-            <ac:picMk id="3" creationId="{136B59E8-497A-649F-4776-418331AD45DA}"/>
-          </ac:picMkLst>
-        </pc:picChg>
-        <pc:picChg chg="del">
-          <ac:chgData name="Brayand Javier Gómez Plata" userId="c9c1396e-34a9-4a12-912a-8649ffb9a204" providerId="ADAL" clId="{27F4626A-F3D0-4E6C-A104-AEA19FA55BBA}" dt="2026-07-02T20:40:32.503" v="3245" actId="478"/>
-          <ac:picMkLst>
-            <pc:docMk/>
-            <pc:sldMk cId="3604946481" sldId="282"/>
-            <ac:picMk id="47" creationId="{17C87CE0-AC38-556F-04FA-026F186381C5}"/>
-          </ac:picMkLst>
-        </pc:picChg>
-        <pc:picChg chg="add del mod modCrop">
-          <ac:chgData name="Brayand Javier Gómez Plata" userId="c9c1396e-34a9-4a12-912a-8649ffb9a204" providerId="ADAL" clId="{27F4626A-F3D0-4E6C-A104-AEA19FA55BBA}" dt="2026-07-02T20:15:28.483" v="2966" actId="478"/>
-          <ac:picMkLst>
-            <pc:docMk/>
-            <pc:sldMk cId="3604946481" sldId="282"/>
-            <ac:picMk id="118" creationId="{2B5DF07B-619A-AAB5-D274-6BD7455CD71E}"/>
-          </ac:picMkLst>
-        </pc:picChg>
         <pc:picChg chg="add mod">
           <ac:chgData name="Brayand Javier Gómez Plata" userId="c9c1396e-34a9-4a12-912a-8649ffb9a204" providerId="ADAL" clId="{27F4626A-F3D0-4E6C-A104-AEA19FA55BBA}" dt="2026-07-02T20:40:35.064" v="3247" actId="14100"/>
           <ac:picMkLst>
@@ -3153,7 +1863,7 @@
         </pc:picChg>
       </pc:sldChg>
       <pc:sldChg chg="addSp delSp modSp add mod">
-        <pc:chgData name="Brayand Javier Gómez Plata" userId="c9c1396e-34a9-4a12-912a-8649ffb9a204" providerId="ADAL" clId="{27F4626A-F3D0-4E6C-A104-AEA19FA55BBA}" dt="2026-07-03T16:28:10.336" v="5010" actId="790"/>
+        <pc:chgData name="Brayand Javier Gómez Plata" userId="c9c1396e-34a9-4a12-912a-8649ffb9a204" providerId="ADAL" clId="{27F4626A-F3D0-4E6C-A104-AEA19FA55BBA}" dt="2026-07-04T16:24:25.566" v="5311" actId="22"/>
         <pc:sldMkLst>
           <pc:docMk/>
           <pc:sldMk cId="3843665657" sldId="283"/>
@@ -3164,6 +1874,14 @@
             <pc:docMk/>
             <pc:sldMk cId="3843665657" sldId="283"/>
             <ac:spMk id="4" creationId="{85EE39A7-DFFB-73B8-F1DA-29986939A6FB}"/>
+          </ac:spMkLst>
+        </pc:spChg>
+        <pc:spChg chg="add del">
+          <ac:chgData name="Brayand Javier Gómez Plata" userId="c9c1396e-34a9-4a12-912a-8649ffb9a204" providerId="ADAL" clId="{27F4626A-F3D0-4E6C-A104-AEA19FA55BBA}" dt="2026-07-04T16:24:25.566" v="5311" actId="22"/>
+          <ac:spMkLst>
+            <pc:docMk/>
+            <pc:sldMk cId="3843665657" sldId="283"/>
+            <ac:spMk id="5" creationId="{373AA4FA-AD24-5E53-847F-422DD871B57C}"/>
           </ac:spMkLst>
         </pc:spChg>
         <pc:spChg chg="mod">
@@ -3206,14 +1924,6 @@
             <ac:spMk id="29" creationId="{B6592662-4AF1-A995-C8D2-B61395318248}"/>
           </ac:spMkLst>
         </pc:spChg>
-        <pc:spChg chg="del">
-          <ac:chgData name="Brayand Javier Gómez Plata" userId="c9c1396e-34a9-4a12-912a-8649ffb9a204" providerId="ADAL" clId="{27F4626A-F3D0-4E6C-A104-AEA19FA55BBA}" dt="2026-07-02T20:16:32.181" v="3063" actId="478"/>
-          <ac:spMkLst>
-            <pc:docMk/>
-            <pc:sldMk cId="3843665657" sldId="283"/>
-            <ac:spMk id="30" creationId="{1414568D-320C-BAEA-7432-FC0D51BEE101}"/>
-          </ac:spMkLst>
-        </pc:spChg>
         <pc:spChg chg="mod">
           <ac:chgData name="Brayand Javier Gómez Plata" userId="c9c1396e-34a9-4a12-912a-8649ffb9a204" providerId="ADAL" clId="{27F4626A-F3D0-4E6C-A104-AEA19FA55BBA}" dt="2026-07-03T16:28:10.336" v="5010" actId="790"/>
           <ac:spMkLst>
@@ -3228,14 +1938,6 @@
             <pc:docMk/>
             <pc:sldMk cId="3843665657" sldId="283"/>
             <ac:spMk id="37" creationId="{16B1CD61-8FA4-CDCB-F992-4F39CFA0D1CA}"/>
-          </ac:spMkLst>
-        </pc:spChg>
-        <pc:spChg chg="del">
-          <ac:chgData name="Brayand Javier Gómez Plata" userId="c9c1396e-34a9-4a12-912a-8649ffb9a204" providerId="ADAL" clId="{27F4626A-F3D0-4E6C-A104-AEA19FA55BBA}" dt="2026-07-02T20:16:32.181" v="3063" actId="478"/>
-          <ac:spMkLst>
-            <pc:docMk/>
-            <pc:sldMk cId="3843665657" sldId="283"/>
-            <ac:spMk id="42" creationId="{517E3E69-5DDA-7D9C-411E-F84CCC3B2878}"/>
           </ac:spMkLst>
         </pc:spChg>
         <pc:spChg chg="add mod">
@@ -3262,28 +1964,12 @@
             <ac:spMk id="59" creationId="{3259C946-13C9-9CFF-720D-0376B3575D2D}"/>
           </ac:spMkLst>
         </pc:spChg>
-        <pc:spChg chg="del">
-          <ac:chgData name="Brayand Javier Gómez Plata" userId="c9c1396e-34a9-4a12-912a-8649ffb9a204" providerId="ADAL" clId="{27F4626A-F3D0-4E6C-A104-AEA19FA55BBA}" dt="2026-07-02T20:16:32.181" v="3063" actId="478"/>
-          <ac:spMkLst>
-            <pc:docMk/>
-            <pc:sldMk cId="3843665657" sldId="283"/>
-            <ac:spMk id="62" creationId="{A05B7CC1-D268-6C70-6043-A76FD5CE0670}"/>
-          </ac:spMkLst>
-        </pc:spChg>
         <pc:spChg chg="add mod">
           <ac:chgData name="Brayand Javier Gómez Plata" userId="c9c1396e-34a9-4a12-912a-8649ffb9a204" providerId="ADAL" clId="{27F4626A-F3D0-4E6C-A104-AEA19FA55BBA}" dt="2026-07-02T21:45:25.577" v="4699" actId="2711"/>
           <ac:spMkLst>
             <pc:docMk/>
             <pc:sldMk cId="3843665657" sldId="283"/>
             <ac:spMk id="71" creationId="{3DDC1D9A-3D12-B4CC-C3EE-03086B996C7E}"/>
-          </ac:spMkLst>
-        </pc:spChg>
-        <pc:spChg chg="del">
-          <ac:chgData name="Brayand Javier Gómez Plata" userId="c9c1396e-34a9-4a12-912a-8649ffb9a204" providerId="ADAL" clId="{27F4626A-F3D0-4E6C-A104-AEA19FA55BBA}" dt="2026-07-02T20:16:32.181" v="3063" actId="478"/>
-          <ac:spMkLst>
-            <pc:docMk/>
-            <pc:sldMk cId="3843665657" sldId="283"/>
-            <ac:spMk id="72" creationId="{E17C6BB7-C619-4499-DFF3-0BBBBFA5479D}"/>
           </ac:spMkLst>
         </pc:spChg>
         <pc:spChg chg="add mod">
@@ -3294,36 +1980,12 @@
             <ac:spMk id="75" creationId="{A1F979BB-BEAA-8096-0E23-0E0A7B967615}"/>
           </ac:spMkLst>
         </pc:spChg>
-        <pc:spChg chg="del">
-          <ac:chgData name="Brayand Javier Gómez Plata" userId="c9c1396e-34a9-4a12-912a-8649ffb9a204" providerId="ADAL" clId="{27F4626A-F3D0-4E6C-A104-AEA19FA55BBA}" dt="2026-07-02T20:16:32.181" v="3063" actId="478"/>
-          <ac:spMkLst>
-            <pc:docMk/>
-            <pc:sldMk cId="3843665657" sldId="283"/>
-            <ac:spMk id="78" creationId="{409F967E-377F-4D0B-1EAE-1A112FF240C0}"/>
-          </ac:spMkLst>
-        </pc:spChg>
-        <pc:spChg chg="del">
-          <ac:chgData name="Brayand Javier Gómez Plata" userId="c9c1396e-34a9-4a12-912a-8649ffb9a204" providerId="ADAL" clId="{27F4626A-F3D0-4E6C-A104-AEA19FA55BBA}" dt="2026-07-02T20:16:32.181" v="3063" actId="478"/>
-          <ac:spMkLst>
-            <pc:docMk/>
-            <pc:sldMk cId="3843665657" sldId="283"/>
-            <ac:spMk id="82" creationId="{94FCB4D8-197A-7358-46A9-B0A2A77CE45F}"/>
-          </ac:spMkLst>
-        </pc:spChg>
         <pc:spChg chg="add mod">
           <ac:chgData name="Brayand Javier Gómez Plata" userId="c9c1396e-34a9-4a12-912a-8649ffb9a204" providerId="ADAL" clId="{27F4626A-F3D0-4E6C-A104-AEA19FA55BBA}" dt="2026-07-03T16:28:10.336" v="5010" actId="790"/>
           <ac:spMkLst>
             <pc:docMk/>
             <pc:sldMk cId="3843665657" sldId="283"/>
             <ac:spMk id="83" creationId="{7E7575B6-E00C-DC46-6351-1A29CD72F32F}"/>
-          </ac:spMkLst>
-        </pc:spChg>
-        <pc:spChg chg="del">
-          <ac:chgData name="Brayand Javier Gómez Plata" userId="c9c1396e-34a9-4a12-912a-8649ffb9a204" providerId="ADAL" clId="{27F4626A-F3D0-4E6C-A104-AEA19FA55BBA}" dt="2026-07-02T20:16:32.181" v="3063" actId="478"/>
-          <ac:spMkLst>
-            <pc:docMk/>
-            <pc:sldMk cId="3843665657" sldId="283"/>
-            <ac:spMk id="84" creationId="{7FE3F7E8-3B0D-D4C2-F244-D5FAF572E13D}"/>
           </ac:spMkLst>
         </pc:spChg>
         <pc:spChg chg="mod">
@@ -3342,46 +2004,14 @@
             <ac:spMk id="91" creationId="{63A071B2-944A-DB4A-F39F-EBF457C7F4E5}"/>
           </ac:spMkLst>
         </pc:spChg>
-        <pc:spChg chg="del">
-          <ac:chgData name="Brayand Javier Gómez Plata" userId="c9c1396e-34a9-4a12-912a-8649ffb9a204" providerId="ADAL" clId="{27F4626A-F3D0-4E6C-A104-AEA19FA55BBA}" dt="2026-07-02T20:16:32.181" v="3063" actId="478"/>
-          <ac:spMkLst>
-            <pc:docMk/>
-            <pc:sldMk cId="3843665657" sldId="283"/>
-            <ac:spMk id="92" creationId="{0EF83D5D-34C3-CAF6-4059-F015A5AC5B2F}"/>
-          </ac:spMkLst>
-        </pc:spChg>
-        <pc:spChg chg="del">
-          <ac:chgData name="Brayand Javier Gómez Plata" userId="c9c1396e-34a9-4a12-912a-8649ffb9a204" providerId="ADAL" clId="{27F4626A-F3D0-4E6C-A104-AEA19FA55BBA}" dt="2026-07-02T20:16:32.181" v="3063" actId="478"/>
-          <ac:spMkLst>
-            <pc:docMk/>
-            <pc:sldMk cId="3843665657" sldId="283"/>
-            <ac:spMk id="106" creationId="{07468EA4-92F7-9F0F-1D1A-F68D70EA14C8}"/>
-          </ac:spMkLst>
-        </pc:spChg>
-        <pc:spChg chg="del">
-          <ac:chgData name="Brayand Javier Gómez Plata" userId="c9c1396e-34a9-4a12-912a-8649ffb9a204" providerId="ADAL" clId="{27F4626A-F3D0-4E6C-A104-AEA19FA55BBA}" dt="2026-07-02T20:16:32.181" v="3063" actId="478"/>
-          <ac:spMkLst>
-            <pc:docMk/>
-            <pc:sldMk cId="3843665657" sldId="283"/>
-            <ac:spMk id="110" creationId="{49F78B2C-A329-B22A-3977-5DD091885552}"/>
-          </ac:spMkLst>
-        </pc:spChg>
         <pc:grpChg chg="add del mod">
-          <ac:chgData name="Brayand Javier Gómez Plata" userId="c9c1396e-34a9-4a12-912a-8649ffb9a204" providerId="ADAL" clId="{27F4626A-F3D0-4E6C-A104-AEA19FA55BBA}" dt="2026-07-02T20:22:47.424" v="3101" actId="478"/>
+          <ac:chgData name="Brayand Javier Gómez Plata" userId="c9c1396e-34a9-4a12-912a-8649ffb9a204" providerId="ADAL" clId="{27F4626A-F3D0-4E6C-A104-AEA19FA55BBA}" dt="2026-07-04T16:24:25.350" v="5310" actId="14100"/>
           <ac:grpSpMkLst>
             <pc:docMk/>
             <pc:sldMk cId="3843665657" sldId="283"/>
             <ac:grpSpMk id="93" creationId="{3F828FAD-9A38-14E1-4306-F72312C2FE20}"/>
           </ac:grpSpMkLst>
         </pc:grpChg>
-        <pc:picChg chg="del">
-          <ac:chgData name="Brayand Javier Gómez Plata" userId="c9c1396e-34a9-4a12-912a-8649ffb9a204" providerId="ADAL" clId="{27F4626A-F3D0-4E6C-A104-AEA19FA55BBA}" dt="2026-07-02T20:40:39.464" v="3248" actId="478"/>
-          <ac:picMkLst>
-            <pc:docMk/>
-            <pc:sldMk cId="3843665657" sldId="283"/>
-            <ac:picMk id="47" creationId="{0505EAC9-3EEB-E71A-DA2E-46A05C97624B}"/>
-          </ac:picMkLst>
-        </pc:picChg>
         <pc:picChg chg="add mod">
           <ac:chgData name="Brayand Javier Gómez Plata" userId="c9c1396e-34a9-4a12-912a-8649ffb9a204" providerId="ADAL" clId="{27F4626A-F3D0-4E6C-A104-AEA19FA55BBA}" dt="2026-07-02T20:40:42.168" v="3250" actId="14100"/>
           <ac:picMkLst>
@@ -3435,14 +2065,6 @@
             <pc:docMk/>
             <pc:sldMk cId="3501139544" sldId="284"/>
             <ac:spMk id="11" creationId="{689E1A56-7283-05DC-EFFC-66B212456E0C}"/>
-          </ac:spMkLst>
-        </pc:spChg>
-        <pc:spChg chg="mod">
-          <ac:chgData name="Brayand Javier Gómez Plata" userId="c9c1396e-34a9-4a12-912a-8649ffb9a204" providerId="ADAL" clId="{27F4626A-F3D0-4E6C-A104-AEA19FA55BBA}" dt="2026-07-02T20:20:11.986" v="3068" actId="6549"/>
-          <ac:spMkLst>
-            <pc:docMk/>
-            <pc:sldMk cId="3501139544" sldId="284"/>
-            <ac:spMk id="13" creationId="{37205FA4-7907-7E5B-4F5D-86C18F327193}"/>
           </ac:spMkLst>
         </pc:spChg>
         <pc:spChg chg="add mod">
@@ -3541,22 +2163,6 @@
             <ac:spMk id="56" creationId="{69ED6FE3-584E-4769-DD30-FF222E2FFB2A}"/>
           </ac:spMkLst>
         </pc:spChg>
-        <pc:grpChg chg="del">
-          <ac:chgData name="Brayand Javier Gómez Plata" userId="c9c1396e-34a9-4a12-912a-8649ffb9a204" providerId="ADAL" clId="{27F4626A-F3D0-4E6C-A104-AEA19FA55BBA}" dt="2026-07-02T20:20:13.954" v="3069" actId="478"/>
-          <ac:grpSpMkLst>
-            <pc:docMk/>
-            <pc:sldMk cId="3501139544" sldId="284"/>
-            <ac:grpSpMk id="93" creationId="{E32924F7-B09A-8851-DB1D-A806065C531E}"/>
-          </ac:grpSpMkLst>
-        </pc:grpChg>
-        <pc:picChg chg="del">
-          <ac:chgData name="Brayand Javier Gómez Plata" userId="c9c1396e-34a9-4a12-912a-8649ffb9a204" providerId="ADAL" clId="{27F4626A-F3D0-4E6C-A104-AEA19FA55BBA}" dt="2026-07-02T20:40:47.559" v="3251" actId="478"/>
-          <ac:picMkLst>
-            <pc:docMk/>
-            <pc:sldMk cId="3501139544" sldId="284"/>
-            <ac:picMk id="47" creationId="{2F0EFEA3-F5F1-A0A7-FF93-2620792BA382}"/>
-          </ac:picMkLst>
-        </pc:picChg>
         <pc:picChg chg="add">
           <ac:chgData name="Brayand Javier Gómez Plata" userId="c9c1396e-34a9-4a12-912a-8649ffb9a204" providerId="ADAL" clId="{27F4626A-F3D0-4E6C-A104-AEA19FA55BBA}" dt="2026-07-02T20:40:47.727" v="3252" actId="22"/>
           <ac:picMkLst>
@@ -3566,19 +2172,20 @@
           </ac:picMkLst>
         </pc:picChg>
       </pc:sldChg>
-      <pc:sldChg chg="add del">
-        <pc:chgData name="Brayand Javier Gómez Plata" userId="c9c1396e-34a9-4a12-912a-8649ffb9a204" providerId="ADAL" clId="{27F4626A-F3D0-4E6C-A104-AEA19FA55BBA}" dt="2026-07-02T20:23:10.466" v="3104" actId="2696"/>
-        <pc:sldMkLst>
-          <pc:docMk/>
-          <pc:sldMk cId="3608745824" sldId="285"/>
-        </pc:sldMkLst>
-      </pc:sldChg>
       <pc:sldChg chg="addSp delSp modSp add mod ord setBg">
-        <pc:chgData name="Brayand Javier Gómez Plata" userId="c9c1396e-34a9-4a12-912a-8649ffb9a204" providerId="ADAL" clId="{27F4626A-F3D0-4E6C-A104-AEA19FA55BBA}" dt="2026-07-03T16:28:10.336" v="5010" actId="790"/>
+        <pc:chgData name="Brayand Javier Gómez Plata" userId="c9c1396e-34a9-4a12-912a-8649ffb9a204" providerId="ADAL" clId="{27F4626A-F3D0-4E6C-A104-AEA19FA55BBA}" dt="2026-07-04T16:24:24.973" v="5308" actId="22"/>
         <pc:sldMkLst>
           <pc:docMk/>
           <pc:sldMk cId="4104171542" sldId="286"/>
         </pc:sldMkLst>
+        <pc:spChg chg="add del">
+          <ac:chgData name="Brayand Javier Gómez Plata" userId="c9c1396e-34a9-4a12-912a-8649ffb9a204" providerId="ADAL" clId="{27F4626A-F3D0-4E6C-A104-AEA19FA55BBA}" dt="2026-07-04T16:24:24.973" v="5308" actId="22"/>
+          <ac:spMkLst>
+            <pc:docMk/>
+            <pc:sldMk cId="4104171542" sldId="286"/>
+            <ac:spMk id="3" creationId="{1854F90B-D77B-7C38-A641-2F33CC1CEC66}"/>
+          </ac:spMkLst>
+        </pc:spChg>
         <pc:spChg chg="mod">
           <ac:chgData name="Brayand Javier Gómez Plata" userId="c9c1396e-34a9-4a12-912a-8649ffb9a204" providerId="ADAL" clId="{27F4626A-F3D0-4E6C-A104-AEA19FA55BBA}" dt="2026-07-02T20:23:30.190" v="3166" actId="20577"/>
           <ac:spMkLst>
@@ -3595,28 +2202,12 @@
             <ac:spMk id="25" creationId="{797AFBE5-8FB0-4B1F-527A-8C5B278EF568}"/>
           </ac:spMkLst>
         </pc:spChg>
-        <pc:spChg chg="del mod">
-          <ac:chgData name="Brayand Javier Gómez Plata" userId="c9c1396e-34a9-4a12-912a-8649ffb9a204" providerId="ADAL" clId="{27F4626A-F3D0-4E6C-A104-AEA19FA55BBA}" dt="2026-07-02T20:24:50.570" v="3169" actId="478"/>
-          <ac:spMkLst>
-            <pc:docMk/>
-            <pc:sldMk cId="4104171542" sldId="286"/>
-            <ac:spMk id="29" creationId="{0EB71B85-8CAE-B437-A345-A4BF955313CA}"/>
-          </ac:spMkLst>
-        </pc:spChg>
         <pc:spChg chg="add mod">
           <ac:chgData name="Brayand Javier Gómez Plata" userId="c9c1396e-34a9-4a12-912a-8649ffb9a204" providerId="ADAL" clId="{27F4626A-F3D0-4E6C-A104-AEA19FA55BBA}" dt="2026-07-02T21:44:10.526" v="4691" actId="2711"/>
           <ac:spMkLst>
             <pc:docMk/>
             <pc:sldMk cId="4104171542" sldId="286"/>
             <ac:spMk id="30" creationId="{9CC46092-0D50-B1CF-FD94-01FB9C099C53}"/>
-          </ac:spMkLst>
-        </pc:spChg>
-        <pc:spChg chg="del">
-          <ac:chgData name="Brayand Javier Gómez Plata" userId="c9c1396e-34a9-4a12-912a-8649ffb9a204" providerId="ADAL" clId="{27F4626A-F3D0-4E6C-A104-AEA19FA55BBA}" dt="2026-07-02T20:24:52.026" v="3170" actId="478"/>
-          <ac:spMkLst>
-            <pc:docMk/>
-            <pc:sldMk cId="4104171542" sldId="286"/>
-            <ac:spMk id="33" creationId="{6C9DA5ED-4038-823C-25EA-93D1C71E3837}"/>
           </ac:spMkLst>
         </pc:spChg>
         <pc:spChg chg="mod">
@@ -3747,36 +2338,28 @@
             <ac:spMk id="79" creationId="{73455D28-498A-8A66-3F70-04E04A954E4A}"/>
           </ac:spMkLst>
         </pc:spChg>
-        <pc:grpChg chg="del">
-          <ac:chgData name="Brayand Javier Gómez Plata" userId="c9c1396e-34a9-4a12-912a-8649ffb9a204" providerId="ADAL" clId="{27F4626A-F3D0-4E6C-A104-AEA19FA55BBA}" dt="2026-07-02T20:24:54.016" v="3171" actId="478"/>
-          <ac:grpSpMkLst>
-            <pc:docMk/>
-            <pc:sldMk cId="4104171542" sldId="286"/>
-            <ac:grpSpMk id="2" creationId="{A42DAE66-26C0-06C2-1401-4002C36B1C2D}"/>
-          </ac:grpSpMkLst>
-        </pc:grpChg>
-        <pc:grpChg chg="del">
-          <ac:chgData name="Brayand Javier Gómez Plata" userId="c9c1396e-34a9-4a12-912a-8649ffb9a204" providerId="ADAL" clId="{27F4626A-F3D0-4E6C-A104-AEA19FA55BBA}" dt="2026-07-02T20:24:47.793" v="3167" actId="478"/>
-          <ac:grpSpMkLst>
-            <pc:docMk/>
-            <pc:sldMk cId="4104171542" sldId="286"/>
-            <ac:grpSpMk id="20" creationId="{61B62CE8-C43B-644B-27F2-81BFC4E40C76}"/>
-          </ac:grpSpMkLst>
-        </pc:grpChg>
         <pc:grpChg chg="mod">
-          <ac:chgData name="Brayand Javier Gómez Plata" userId="c9c1396e-34a9-4a12-912a-8649ffb9a204" providerId="ADAL" clId="{27F4626A-F3D0-4E6C-A104-AEA19FA55BBA}" dt="2026-07-02T20:25:36.187" v="3175" actId="1076"/>
+          <ac:chgData name="Brayand Javier Gómez Plata" userId="c9c1396e-34a9-4a12-912a-8649ffb9a204" providerId="ADAL" clId="{27F4626A-F3D0-4E6C-A104-AEA19FA55BBA}" dt="2026-07-04T16:24:24.806" v="5307" actId="1076"/>
           <ac:grpSpMkLst>
             <pc:docMk/>
             <pc:sldMk cId="4104171542" sldId="286"/>
             <ac:grpSpMk id="88" creationId="{0D760FB9-C060-1FDD-58F5-A1897B96448B}"/>
           </ac:grpSpMkLst>
         </pc:grpChg>
-        <pc:picChg chg="del">
-          <ac:chgData name="Brayand Javier Gómez Plata" userId="c9c1396e-34a9-4a12-912a-8649ffb9a204" providerId="ADAL" clId="{27F4626A-F3D0-4E6C-A104-AEA19FA55BBA}" dt="2026-07-02T20:40:53.440" v="3253" actId="478"/>
+        <pc:picChg chg="add del ord">
+          <ac:chgData name="Brayand Javier Gómez Plata" userId="c9c1396e-34a9-4a12-912a-8649ffb9a204" providerId="ADAL" clId="{27F4626A-F3D0-4E6C-A104-AEA19FA55BBA}" dt="2026-07-04T16:24:24.478" v="5305" actId="22"/>
           <ac:picMkLst>
             <pc:docMk/>
             <pc:sldMk cId="4104171542" sldId="286"/>
-            <ac:picMk id="18" creationId="{2A89EB55-0137-F490-9AB4-01B4C2737713}"/>
+            <ac:picMk id="6" creationId="{2EF3EB88-1959-6C2F-0BD6-0C2CF97FC446}"/>
+          </ac:picMkLst>
+        </pc:picChg>
+        <pc:picChg chg="add del">
+          <ac:chgData name="Brayand Javier Gómez Plata" userId="c9c1396e-34a9-4a12-912a-8649ffb9a204" providerId="ADAL" clId="{27F4626A-F3D0-4E6C-A104-AEA19FA55BBA}" dt="2026-07-04T16:24:24.655" v="5306" actId="478"/>
+          <ac:picMkLst>
+            <pc:docMk/>
+            <pc:sldMk cId="4104171542" sldId="286"/>
+            <ac:picMk id="19" creationId="{3CFBAF56-6F6C-2632-7782-BD69CA383A3B}"/>
           </ac:picMkLst>
         </pc:picChg>
         <pc:picChg chg="add mod">
@@ -3810,38 +2393,6 @@
             <ac:spMk id="7" creationId="{F28309C7-E567-C6B8-CD11-A3344CCD4F13}"/>
           </ac:spMkLst>
         </pc:spChg>
-        <pc:spChg chg="add del mod">
-          <ac:chgData name="Brayand Javier Gómez Plata" userId="c9c1396e-34a9-4a12-912a-8649ffb9a204" providerId="ADAL" clId="{27F4626A-F3D0-4E6C-A104-AEA19FA55BBA}" dt="2026-07-02T21:38:47.730" v="4679" actId="478"/>
-          <ac:spMkLst>
-            <pc:docMk/>
-            <pc:sldMk cId="3989857744" sldId="287"/>
-            <ac:spMk id="9" creationId="{B82E6CE2-9CB3-3D0B-0A52-445B5434113E}"/>
-          </ac:spMkLst>
-        </pc:spChg>
-        <pc:spChg chg="add del mod">
-          <ac:chgData name="Brayand Javier Gómez Plata" userId="c9c1396e-34a9-4a12-912a-8649ffb9a204" providerId="ADAL" clId="{27F4626A-F3D0-4E6C-A104-AEA19FA55BBA}" dt="2026-07-02T21:10:55.667" v="4500" actId="478"/>
-          <ac:spMkLst>
-            <pc:docMk/>
-            <pc:sldMk cId="3989857744" sldId="287"/>
-            <ac:spMk id="11" creationId="{F13CA39D-0BA9-08C4-AB6C-49748EEAA799}"/>
-          </ac:spMkLst>
-        </pc:spChg>
-        <pc:spChg chg="add del mod">
-          <ac:chgData name="Brayand Javier Gómez Plata" userId="c9c1396e-34a9-4a12-912a-8649ffb9a204" providerId="ADAL" clId="{27F4626A-F3D0-4E6C-A104-AEA19FA55BBA}" dt="2026-07-02T21:38:46.450" v="4678" actId="478"/>
-          <ac:spMkLst>
-            <pc:docMk/>
-            <pc:sldMk cId="3989857744" sldId="287"/>
-            <ac:spMk id="13" creationId="{23DA3B75-9CA2-2946-2422-09EB2B2B5BE0}"/>
-          </ac:spMkLst>
-        </pc:spChg>
-        <pc:grpChg chg="del">
-          <ac:chgData name="Brayand Javier Gómez Plata" userId="c9c1396e-34a9-4a12-912a-8649ffb9a204" providerId="ADAL" clId="{27F4626A-F3D0-4E6C-A104-AEA19FA55BBA}" dt="2026-07-02T20:55:23.941" v="3974" actId="478"/>
-          <ac:grpSpMkLst>
-            <pc:docMk/>
-            <pc:sldMk cId="3989857744" sldId="287"/>
-            <ac:grpSpMk id="88" creationId="{828D915A-0D40-C73D-776B-D2469670773F}"/>
-          </ac:grpSpMkLst>
-        </pc:grpChg>
         <pc:graphicFrameChg chg="add mod modGraphic">
           <ac:chgData name="Brayand Javier Gómez Plata" userId="c9c1396e-34a9-4a12-912a-8649ffb9a204" providerId="ADAL" clId="{27F4626A-F3D0-4E6C-A104-AEA19FA55BBA}" dt="2026-07-03T16:28:10.336" v="5010" actId="790"/>
           <ac:graphicFrameMkLst>
@@ -3850,44 +2401,12 @@
             <ac:graphicFrameMk id="6" creationId="{F3083A3E-B717-A265-08D1-0D568E512EBC}"/>
           </ac:graphicFrameMkLst>
         </pc:graphicFrameChg>
-        <pc:graphicFrameChg chg="add del mod">
-          <ac:chgData name="Brayand Javier Gómez Plata" userId="c9c1396e-34a9-4a12-912a-8649ffb9a204" providerId="ADAL" clId="{27F4626A-F3D0-4E6C-A104-AEA19FA55BBA}" dt="2026-07-02T21:11:42.892" v="4534" actId="478"/>
-          <ac:graphicFrameMkLst>
-            <pc:docMk/>
-            <pc:sldMk cId="3989857744" sldId="287"/>
-            <ac:graphicFrameMk id="14" creationId="{5578E5E4-57A4-F4A2-4621-05E68406F5D8}"/>
-          </ac:graphicFrameMkLst>
-        </pc:graphicFrameChg>
-        <pc:graphicFrameChg chg="add del mod modGraphic">
-          <ac:chgData name="Brayand Javier Gómez Plata" userId="c9c1396e-34a9-4a12-912a-8649ffb9a204" providerId="ADAL" clId="{27F4626A-F3D0-4E6C-A104-AEA19FA55BBA}" dt="2026-07-02T21:18:11.143" v="4575" actId="478"/>
-          <ac:graphicFrameMkLst>
-            <pc:docMk/>
-            <pc:sldMk cId="3989857744" sldId="287"/>
-            <ac:graphicFrameMk id="15" creationId="{6AB8C8C6-24CE-10A9-6AA2-1A359E018823}"/>
-          </ac:graphicFrameMkLst>
-        </pc:graphicFrameChg>
-        <pc:graphicFrameChg chg="add del modGraphic">
-          <ac:chgData name="Brayand Javier Gómez Plata" userId="c9c1396e-34a9-4a12-912a-8649ffb9a204" providerId="ADAL" clId="{27F4626A-F3D0-4E6C-A104-AEA19FA55BBA}" dt="2026-07-02T21:36:12.045" v="4658" actId="21"/>
-          <ac:graphicFrameMkLst>
-            <pc:docMk/>
-            <pc:sldMk cId="3989857744" sldId="287"/>
-            <ac:graphicFrameMk id="17" creationId="{F03B6BCF-FE65-B310-B0F1-7B53DB2BBDB7}"/>
-          </ac:graphicFrameMkLst>
-        </pc:graphicFrameChg>
         <pc:picChg chg="add">
           <ac:chgData name="Brayand Javier Gómez Plata" userId="c9c1396e-34a9-4a12-912a-8649ffb9a204" providerId="ADAL" clId="{27F4626A-F3D0-4E6C-A104-AEA19FA55BBA}" dt="2026-07-02T20:55:03.003" v="3913" actId="22"/>
           <ac:picMkLst>
             <pc:docMk/>
             <pc:sldMk cId="3989857744" sldId="287"/>
             <ac:picMk id="3" creationId="{A72055E2-9C08-A4FA-CB0F-FFF272365D34}"/>
-          </ac:picMkLst>
-        </pc:picChg>
-        <pc:picChg chg="del">
-          <ac:chgData name="Brayand Javier Gómez Plata" userId="c9c1396e-34a9-4a12-912a-8649ffb9a204" providerId="ADAL" clId="{27F4626A-F3D0-4E6C-A104-AEA19FA55BBA}" dt="2026-07-02T20:55:02.836" v="3912" actId="478"/>
-          <ac:picMkLst>
-            <pc:docMk/>
-            <pc:sldMk cId="3989857744" sldId="287"/>
-            <ac:picMk id="18" creationId="{4BCDDD15-64D1-34C1-E303-87590E075D9F}"/>
           </ac:picMkLst>
         </pc:picChg>
         <pc:picChg chg="mod">
@@ -3899,12 +2418,20 @@
           </ac:picMkLst>
         </pc:picChg>
       </pc:sldChg>
-      <pc:sldChg chg="modSp add mod">
-        <pc:chgData name="Brayand Javier Gómez Plata" userId="c9c1396e-34a9-4a12-912a-8649ffb9a204" providerId="ADAL" clId="{27F4626A-F3D0-4E6C-A104-AEA19FA55BBA}" dt="2026-07-03T16:28:10.336" v="5010" actId="790"/>
+      <pc:sldChg chg="addSp delSp modSp add mod">
+        <pc:chgData name="Brayand Javier Gómez Plata" userId="c9c1396e-34a9-4a12-912a-8649ffb9a204" providerId="ADAL" clId="{27F4626A-F3D0-4E6C-A104-AEA19FA55BBA}" dt="2026-07-04T16:24:23.783" v="5301" actId="22"/>
         <pc:sldMkLst>
           <pc:docMk/>
           <pc:sldMk cId="699721734" sldId="288"/>
         </pc:sldMkLst>
+        <pc:spChg chg="add del">
+          <ac:chgData name="Brayand Javier Gómez Plata" userId="c9c1396e-34a9-4a12-912a-8649ffb9a204" providerId="ADAL" clId="{27F4626A-F3D0-4E6C-A104-AEA19FA55BBA}" dt="2026-07-04T16:24:23.783" v="5301" actId="22"/>
+          <ac:spMkLst>
+            <pc:docMk/>
+            <pc:sldMk cId="699721734" sldId="288"/>
+            <ac:spMk id="4" creationId="{F35C461F-39E4-D2E3-B203-F2BE93189F3E}"/>
+          </ac:spMkLst>
+        </pc:spChg>
         <pc:spChg chg="mod">
           <ac:chgData name="Brayand Javier Gómez Plata" userId="c9c1396e-34a9-4a12-912a-8649ffb9a204" providerId="ADAL" clId="{27F4626A-F3D0-4E6C-A104-AEA19FA55BBA}" dt="2026-07-02T21:33:44.108" v="4643" actId="790"/>
           <ac:spMkLst>
@@ -4030,102 +2557,6 @@
             <pc:docMk/>
             <pc:sldMk cId="3625557299" sldId="289"/>
             <ac:spMk id="4" creationId="{B3863969-D805-49DA-352B-9F0C47509FBC}"/>
-          </ac:spMkLst>
-        </pc:spChg>
-        <pc:spChg chg="del mod topLvl">
-          <ac:chgData name="Brayand Javier Gómez Plata" userId="c9c1396e-34a9-4a12-912a-8649ffb9a204" providerId="ADAL" clId="{27F4626A-F3D0-4E6C-A104-AEA19FA55BBA}" dt="2026-07-02T21:17:44.868" v="4572" actId="478"/>
-          <ac:spMkLst>
-            <pc:docMk/>
-            <pc:sldMk cId="3625557299" sldId="289"/>
-            <ac:spMk id="9" creationId="{E3A8C55E-3ED0-907E-C833-802CAD16BCCC}"/>
-          </ac:spMkLst>
-        </pc:spChg>
-        <pc:spChg chg="del mod topLvl">
-          <ac:chgData name="Brayand Javier Gómez Plata" userId="c9c1396e-34a9-4a12-912a-8649ffb9a204" providerId="ADAL" clId="{27F4626A-F3D0-4E6C-A104-AEA19FA55BBA}" dt="2026-07-02T21:29:22.149" v="4608" actId="478"/>
-          <ac:spMkLst>
-            <pc:docMk/>
-            <pc:sldMk cId="3625557299" sldId="289"/>
-            <ac:spMk id="13" creationId="{FF3784A2-BD1F-8A8F-B66A-4130663BEBA4}"/>
-          </ac:spMkLst>
-        </pc:spChg>
-        <pc:spChg chg="add del mod">
-          <ac:chgData name="Brayand Javier Gómez Plata" userId="c9c1396e-34a9-4a12-912a-8649ffb9a204" providerId="ADAL" clId="{27F4626A-F3D0-4E6C-A104-AEA19FA55BBA}" dt="2026-07-02T21:28:57.048" v="4603" actId="22"/>
-          <ac:spMkLst>
-            <pc:docMk/>
-            <pc:sldMk cId="3625557299" sldId="289"/>
-            <ac:spMk id="31" creationId="{B5A9DF86-85FC-C56F-D901-422895FF8C74}"/>
-          </ac:spMkLst>
-        </pc:spChg>
-        <pc:spChg chg="add del mod">
-          <ac:chgData name="Brayand Javier Gómez Plata" userId="c9c1396e-34a9-4a12-912a-8649ffb9a204" providerId="ADAL" clId="{27F4626A-F3D0-4E6C-A104-AEA19FA55BBA}" dt="2026-07-02T21:28:57.048" v="4603" actId="22"/>
-          <ac:spMkLst>
-            <pc:docMk/>
-            <pc:sldMk cId="3625557299" sldId="289"/>
-            <ac:spMk id="49" creationId="{76D5F5FB-00BE-EE59-C352-F9E3E2B3293C}"/>
-          </ac:spMkLst>
-        </pc:spChg>
-        <pc:spChg chg="add del mod">
-          <ac:chgData name="Brayand Javier Gómez Plata" userId="c9c1396e-34a9-4a12-912a-8649ffb9a204" providerId="ADAL" clId="{27F4626A-F3D0-4E6C-A104-AEA19FA55BBA}" dt="2026-07-02T21:28:57.048" v="4603" actId="22"/>
-          <ac:spMkLst>
-            <pc:docMk/>
-            <pc:sldMk cId="3625557299" sldId="289"/>
-            <ac:spMk id="113" creationId="{2F7C5BDB-DCF0-3292-6B15-30B7174A4012}"/>
-          </ac:spMkLst>
-        </pc:spChg>
-        <pc:spChg chg="add del mod">
-          <ac:chgData name="Brayand Javier Gómez Plata" userId="c9c1396e-34a9-4a12-912a-8649ffb9a204" providerId="ADAL" clId="{27F4626A-F3D0-4E6C-A104-AEA19FA55BBA}" dt="2026-07-02T21:28:57.048" v="4603" actId="22"/>
-          <ac:spMkLst>
-            <pc:docMk/>
-            <pc:sldMk cId="3625557299" sldId="289"/>
-            <ac:spMk id="163" creationId="{FB363732-38A5-74B5-EF05-CA92CC09B51E}"/>
-          </ac:spMkLst>
-        </pc:spChg>
-        <pc:spChg chg="add del mod">
-          <ac:chgData name="Brayand Javier Gómez Plata" userId="c9c1396e-34a9-4a12-912a-8649ffb9a204" providerId="ADAL" clId="{27F4626A-F3D0-4E6C-A104-AEA19FA55BBA}" dt="2026-07-02T21:28:57.048" v="4603" actId="22"/>
-          <ac:spMkLst>
-            <pc:docMk/>
-            <pc:sldMk cId="3625557299" sldId="289"/>
-            <ac:spMk id="203" creationId="{12DD7FAE-A27D-E06B-80A7-C45E0572E813}"/>
-          </ac:spMkLst>
-        </pc:spChg>
-        <pc:spChg chg="add del mod">
-          <ac:chgData name="Brayand Javier Gómez Plata" userId="c9c1396e-34a9-4a12-912a-8649ffb9a204" providerId="ADAL" clId="{27F4626A-F3D0-4E6C-A104-AEA19FA55BBA}" dt="2026-07-02T21:28:57.048" v="4603" actId="22"/>
-          <ac:spMkLst>
-            <pc:docMk/>
-            <pc:sldMk cId="3625557299" sldId="289"/>
-            <ac:spMk id="235" creationId="{5E02D005-6300-2ABC-3AAC-421682D89241}"/>
-          </ac:spMkLst>
-        </pc:spChg>
-        <pc:spChg chg="add del mod">
-          <ac:chgData name="Brayand Javier Gómez Plata" userId="c9c1396e-34a9-4a12-912a-8649ffb9a204" providerId="ADAL" clId="{27F4626A-F3D0-4E6C-A104-AEA19FA55BBA}" dt="2026-07-02T21:28:57.048" v="4603" actId="22"/>
-          <ac:spMkLst>
-            <pc:docMk/>
-            <pc:sldMk cId="3625557299" sldId="289"/>
-            <ac:spMk id="247" creationId="{E88266E9-857A-5809-30A2-198EFEC7D0A3}"/>
-          </ac:spMkLst>
-        </pc:spChg>
-        <pc:spChg chg="add del mod">
-          <ac:chgData name="Brayand Javier Gómez Plata" userId="c9c1396e-34a9-4a12-912a-8649ffb9a204" providerId="ADAL" clId="{27F4626A-F3D0-4E6C-A104-AEA19FA55BBA}" dt="2026-07-02T21:28:57.048" v="4603" actId="22"/>
-          <ac:spMkLst>
-            <pc:docMk/>
-            <pc:sldMk cId="3625557299" sldId="289"/>
-            <ac:spMk id="277" creationId="{F9EFD6CD-6996-77A9-A7AE-7B60C9196ABD}"/>
-          </ac:spMkLst>
-        </pc:spChg>
-        <pc:spChg chg="add del mod">
-          <ac:chgData name="Brayand Javier Gómez Plata" userId="c9c1396e-34a9-4a12-912a-8649ffb9a204" providerId="ADAL" clId="{27F4626A-F3D0-4E6C-A104-AEA19FA55BBA}" dt="2026-07-02T21:28:57.048" v="4603" actId="22"/>
-          <ac:spMkLst>
-            <pc:docMk/>
-            <pc:sldMk cId="3625557299" sldId="289"/>
-            <ac:spMk id="295" creationId="{3B1EFA0E-5184-BC92-85BB-3FEB34FDBED5}"/>
-          </ac:spMkLst>
-        </pc:spChg>
-        <pc:spChg chg="add del mod">
-          <ac:chgData name="Brayand Javier Gómez Plata" userId="c9c1396e-34a9-4a12-912a-8649ffb9a204" providerId="ADAL" clId="{27F4626A-F3D0-4E6C-A104-AEA19FA55BBA}" dt="2026-07-02T21:28:57.048" v="4603" actId="22"/>
-          <ac:spMkLst>
-            <pc:docMk/>
-            <pc:sldMk cId="3625557299" sldId="289"/>
-            <ac:spMk id="325" creationId="{580A2725-9406-3613-44EB-EFC9ACF68EDF}"/>
           </ac:spMkLst>
         </pc:spChg>
         <pc:spChg chg="mod">
@@ -4320,70 +2751,6 @@
             <ac:spMk id="650" creationId="{8AB5D41A-7894-A6ED-EB8A-4125864F005E}"/>
           </ac:spMkLst>
         </pc:spChg>
-        <pc:grpChg chg="add del mod">
-          <ac:chgData name="Brayand Javier Gómez Plata" userId="c9c1396e-34a9-4a12-912a-8649ffb9a204" providerId="ADAL" clId="{27F4626A-F3D0-4E6C-A104-AEA19FA55BBA}" dt="2026-07-02T21:17:42.474" v="4571" actId="165"/>
-          <ac:grpSpMkLst>
-            <pc:docMk/>
-            <pc:sldMk cId="3625557299" sldId="289"/>
-            <ac:grpSpMk id="2" creationId="{E3839D44-9928-B388-EEA4-FF7DEA8BBFB0}"/>
-          </ac:grpSpMkLst>
-        </pc:grpChg>
-        <pc:grpChg chg="mod">
-          <ac:chgData name="Brayand Javier Gómez Plata" userId="c9c1396e-34a9-4a12-912a-8649ffb9a204" providerId="ADAL" clId="{27F4626A-F3D0-4E6C-A104-AEA19FA55BBA}" dt="2026-07-02T21:28:56.046" v="4601" actId="14100"/>
-          <ac:grpSpMkLst>
-            <pc:docMk/>
-            <pc:sldMk cId="3625557299" sldId="289"/>
-            <ac:grpSpMk id="330" creationId="{35A5067C-B3A1-2925-A2D8-052BFD5AD75E}"/>
-          </ac:grpSpMkLst>
-        </pc:grpChg>
-        <pc:grpChg chg="mod">
-          <ac:chgData name="Brayand Javier Gómez Plata" userId="c9c1396e-34a9-4a12-912a-8649ffb9a204" providerId="ADAL" clId="{27F4626A-F3D0-4E6C-A104-AEA19FA55BBA}" dt="2026-07-02T21:33:34.372" v="4641" actId="1076"/>
-          <ac:grpSpMkLst>
-            <pc:docMk/>
-            <pc:sldMk cId="3625557299" sldId="289"/>
-            <ac:grpSpMk id="655" creationId="{FA0FA458-39EF-2522-19A3-0EF49FF4872D}"/>
-          </ac:grpSpMkLst>
-        </pc:grpChg>
-        <pc:graphicFrameChg chg="add del mod modGraphic">
-          <ac:chgData name="Brayand Javier Gómez Plata" userId="c9c1396e-34a9-4a12-912a-8649ffb9a204" providerId="ADAL" clId="{27F4626A-F3D0-4E6C-A104-AEA19FA55BBA}" dt="2026-07-02T21:22:33.693" v="4585" actId="478"/>
-          <ac:graphicFrameMkLst>
-            <pc:docMk/>
-            <pc:sldMk cId="3625557299" sldId="289"/>
-            <ac:graphicFrameMk id="5" creationId="{E193C539-4302-6A86-0560-EB957AAAA830}"/>
-          </ac:graphicFrameMkLst>
-        </pc:graphicFrameChg>
-        <pc:graphicFrameChg chg="del">
-          <ac:chgData name="Brayand Javier Gómez Plata" userId="c9c1396e-34a9-4a12-912a-8649ffb9a204" providerId="ADAL" clId="{27F4626A-F3D0-4E6C-A104-AEA19FA55BBA}" dt="2026-07-02T21:15:28.835" v="4566" actId="478"/>
-          <ac:graphicFrameMkLst>
-            <pc:docMk/>
-            <pc:sldMk cId="3625557299" sldId="289"/>
-            <ac:graphicFrameMk id="6" creationId="{5E9163E7-9E4A-D756-61EF-0ACCE721BA12}"/>
-          </ac:graphicFrameMkLst>
-        </pc:graphicFrameChg>
-        <pc:graphicFrameChg chg="add del mod">
-          <ac:chgData name="Brayand Javier Gómez Plata" userId="c9c1396e-34a9-4a12-912a-8649ffb9a204" providerId="ADAL" clId="{27F4626A-F3D0-4E6C-A104-AEA19FA55BBA}" dt="2026-07-02T21:23:30.681" v="4588" actId="478"/>
-          <ac:graphicFrameMkLst>
-            <pc:docMk/>
-            <pc:sldMk cId="3625557299" sldId="289"/>
-            <ac:graphicFrameMk id="8" creationId="{905A8C9E-BFB6-0538-77F1-3A526B59AF33}"/>
-          </ac:graphicFrameMkLst>
-        </pc:graphicFrameChg>
-        <pc:graphicFrameChg chg="add del mod">
-          <ac:chgData name="Brayand Javier Gómez Plata" userId="c9c1396e-34a9-4a12-912a-8649ffb9a204" providerId="ADAL" clId="{27F4626A-F3D0-4E6C-A104-AEA19FA55BBA}" dt="2026-07-02T21:24:19.990" v="4595" actId="478"/>
-          <ac:graphicFrameMkLst>
-            <pc:docMk/>
-            <pc:sldMk cId="3625557299" sldId="289"/>
-            <ac:graphicFrameMk id="10" creationId="{1617F9C9-9734-3EDF-6A31-D7212E9B7C23}"/>
-          </ac:graphicFrameMkLst>
-        </pc:graphicFrameChg>
-        <pc:graphicFrameChg chg="del mod">
-          <ac:chgData name="Brayand Javier Gómez Plata" userId="c9c1396e-34a9-4a12-912a-8649ffb9a204" providerId="ADAL" clId="{27F4626A-F3D0-4E6C-A104-AEA19FA55BBA}" dt="2026-07-02T21:24:04.329" v="4592" actId="21"/>
-          <ac:graphicFrameMkLst>
-            <pc:docMk/>
-            <pc:sldMk cId="3625557299" sldId="289"/>
-            <ac:graphicFrameMk id="15" creationId="{8949F3E5-AB4A-BB64-6D39-06B6F46EAAE6}"/>
-          </ac:graphicFrameMkLst>
-        </pc:graphicFrameChg>
         <pc:picChg chg="mod">
           <ac:chgData name="Brayand Javier Gómez Plata" userId="c9c1396e-34a9-4a12-912a-8649ffb9a204" providerId="ADAL" clId="{27F4626A-F3D0-4E6C-A104-AEA19FA55BBA}" dt="2026-07-02T21:15:34.147" v="4568" actId="1076"/>
           <ac:picMkLst>
@@ -4407,132 +2774,12 @@
             <ac:spMk id="4" creationId="{21DEE12E-5B38-E4F9-A5E3-1B6840AFDDC0}"/>
           </ac:spMkLst>
         </pc:spChg>
-        <pc:spChg chg="add mod">
-          <ac:chgData name="Brayand Javier Gómez Plata" userId="c9c1396e-34a9-4a12-912a-8649ffb9a204" providerId="ADAL" clId="{27F4626A-F3D0-4E6C-A104-AEA19FA55BBA}" dt="2026-07-02T21:31:36.441" v="4623" actId="207"/>
-          <ac:spMkLst>
-            <pc:docMk/>
-            <pc:sldMk cId="4026648288" sldId="290"/>
-            <ac:spMk id="5" creationId="{14070E28-D28B-FCAF-BB5C-50857A949D67}"/>
-          </ac:spMkLst>
-        </pc:spChg>
         <pc:spChg chg="mod">
           <ac:chgData name="Brayand Javier Gómez Plata" userId="c9c1396e-34a9-4a12-912a-8649ffb9a204" providerId="ADAL" clId="{27F4626A-F3D0-4E6C-A104-AEA19FA55BBA}" dt="2026-07-03T16:28:10.336" v="5010" actId="790"/>
           <ac:spMkLst>
             <pc:docMk/>
             <pc:sldMk cId="4026648288" sldId="290"/>
             <ac:spMk id="7" creationId="{537E6E86-5CC4-702F-55A6-6B728217776E}"/>
-          </ac:spMkLst>
-        </pc:spChg>
-        <pc:spChg chg="add mod">
-          <ac:chgData name="Brayand Javier Gómez Plata" userId="c9c1396e-34a9-4a12-912a-8649ffb9a204" providerId="ADAL" clId="{27F4626A-F3D0-4E6C-A104-AEA19FA55BBA}" dt="2026-07-02T21:31:13.680" v="4618" actId="164"/>
-          <ac:spMkLst>
-            <pc:docMk/>
-            <pc:sldMk cId="4026648288" sldId="290"/>
-            <ac:spMk id="10" creationId="{E45B79DD-98BA-C13D-1999-9B3F79F13987}"/>
-          </ac:spMkLst>
-        </pc:spChg>
-        <pc:spChg chg="mod">
-          <ac:chgData name="Brayand Javier Gómez Plata" userId="c9c1396e-34a9-4a12-912a-8649ffb9a204" providerId="ADAL" clId="{27F4626A-F3D0-4E6C-A104-AEA19FA55BBA}" dt="2026-07-02T21:31:57.338" v="4626" actId="20577"/>
-          <ac:spMkLst>
-            <pc:docMk/>
-            <pc:sldMk cId="4026648288" sldId="290"/>
-            <ac:spMk id="14" creationId="{ED010011-FA6A-5ED7-717C-67DBB59541F5}"/>
-          </ac:spMkLst>
-        </pc:spChg>
-        <pc:spChg chg="add mod">
-          <ac:chgData name="Brayand Javier Gómez Plata" userId="c9c1396e-34a9-4a12-912a-8649ffb9a204" providerId="ADAL" clId="{27F4626A-F3D0-4E6C-A104-AEA19FA55BBA}" dt="2026-07-02T21:31:13.680" v="4618" actId="164"/>
-          <ac:spMkLst>
-            <pc:docMk/>
-            <pc:sldMk cId="4026648288" sldId="290"/>
-            <ac:spMk id="16" creationId="{8C2C2989-8132-58B6-AB91-039C31F93F7E}"/>
-          </ac:spMkLst>
-        </pc:spChg>
-        <pc:spChg chg="mod">
-          <ac:chgData name="Brayand Javier Gómez Plata" userId="c9c1396e-34a9-4a12-912a-8649ffb9a204" providerId="ADAL" clId="{27F4626A-F3D0-4E6C-A104-AEA19FA55BBA}" dt="2026-07-02T21:31:33.304" v="4622" actId="207"/>
-          <ac:spMkLst>
-            <pc:docMk/>
-            <pc:sldMk cId="4026648288" sldId="290"/>
-            <ac:spMk id="18" creationId="{E46C2BB9-1A4B-C3A4-766E-0F307870D88A}"/>
-          </ac:spMkLst>
-        </pc:spChg>
-        <pc:spChg chg="add mod">
-          <ac:chgData name="Brayand Javier Gómez Plata" userId="c9c1396e-34a9-4a12-912a-8649ffb9a204" providerId="ADAL" clId="{27F4626A-F3D0-4E6C-A104-AEA19FA55BBA}" dt="2026-07-02T21:31:13.680" v="4618" actId="164"/>
-          <ac:spMkLst>
-            <pc:docMk/>
-            <pc:sldMk cId="4026648288" sldId="290"/>
-            <ac:spMk id="21" creationId="{6854FFA2-4558-1986-51B2-4343F5177E99}"/>
-          </ac:spMkLst>
-        </pc:spChg>
-        <pc:spChg chg="add mod">
-          <ac:chgData name="Brayand Javier Gómez Plata" userId="c9c1396e-34a9-4a12-912a-8649ffb9a204" providerId="ADAL" clId="{27F4626A-F3D0-4E6C-A104-AEA19FA55BBA}" dt="2026-07-02T21:32:23.497" v="4631" actId="20577"/>
-          <ac:spMkLst>
-            <pc:docMk/>
-            <pc:sldMk cId="4026648288" sldId="290"/>
-            <ac:spMk id="27" creationId="{CAB8BCE4-6858-2D82-A17E-1C92FEDF7C84}"/>
-          </ac:spMkLst>
-        </pc:spChg>
-        <pc:spChg chg="mod">
-          <ac:chgData name="Brayand Javier Gómez Plata" userId="c9c1396e-34a9-4a12-912a-8649ffb9a204" providerId="ADAL" clId="{27F4626A-F3D0-4E6C-A104-AEA19FA55BBA}" dt="2026-07-02T21:31:38.937" v="4624" actId="207"/>
-          <ac:spMkLst>
-            <pc:docMk/>
-            <pc:sldMk cId="4026648288" sldId="290"/>
-            <ac:spMk id="31" creationId="{DFFBA8E9-91E5-26F3-6DEB-EB9E0CBF3E5E}"/>
-          </ac:spMkLst>
-        </pc:spChg>
-        <pc:spChg chg="add mod">
-          <ac:chgData name="Brayand Javier Gómez Plata" userId="c9c1396e-34a9-4a12-912a-8649ffb9a204" providerId="ADAL" clId="{27F4626A-F3D0-4E6C-A104-AEA19FA55BBA}" dt="2026-07-02T21:31:13.680" v="4618" actId="164"/>
-          <ac:spMkLst>
-            <pc:docMk/>
-            <pc:sldMk cId="4026648288" sldId="290"/>
-            <ac:spMk id="35" creationId="{3F7B030C-A47F-57CB-4540-A070F0FFF720}"/>
-          </ac:spMkLst>
-        </pc:spChg>
-        <pc:spChg chg="add mod">
-          <ac:chgData name="Brayand Javier Gómez Plata" userId="c9c1396e-34a9-4a12-912a-8649ffb9a204" providerId="ADAL" clId="{27F4626A-F3D0-4E6C-A104-AEA19FA55BBA}" dt="2026-07-02T21:31:13.680" v="4618" actId="164"/>
-          <ac:spMkLst>
-            <pc:docMk/>
-            <pc:sldMk cId="4026648288" sldId="290"/>
-            <ac:spMk id="37" creationId="{7EAB018C-2D6B-8D7D-15DA-F8E3AC2CF7DF}"/>
-          </ac:spMkLst>
-        </pc:spChg>
-        <pc:spChg chg="add mod">
-          <ac:chgData name="Brayand Javier Gómez Plata" userId="c9c1396e-34a9-4a12-912a-8649ffb9a204" providerId="ADAL" clId="{27F4626A-F3D0-4E6C-A104-AEA19FA55BBA}" dt="2026-07-02T21:31:13.680" v="4618" actId="164"/>
-          <ac:spMkLst>
-            <pc:docMk/>
-            <pc:sldMk cId="4026648288" sldId="290"/>
-            <ac:spMk id="39" creationId="{544AA01E-F846-B108-80A3-B29A87B159D3}"/>
-          </ac:spMkLst>
-        </pc:spChg>
-        <pc:spChg chg="add mod">
-          <ac:chgData name="Brayand Javier Gómez Plata" userId="c9c1396e-34a9-4a12-912a-8649ffb9a204" providerId="ADAL" clId="{27F4626A-F3D0-4E6C-A104-AEA19FA55BBA}" dt="2026-07-02T21:31:13.680" v="4618" actId="164"/>
-          <ac:spMkLst>
-            <pc:docMk/>
-            <pc:sldMk cId="4026648288" sldId="290"/>
-            <ac:spMk id="43" creationId="{512A4659-AEA0-D037-87B5-A82B3CE98693}"/>
-          </ac:spMkLst>
-        </pc:spChg>
-        <pc:spChg chg="mod">
-          <ac:chgData name="Brayand Javier Gómez Plata" userId="c9c1396e-34a9-4a12-912a-8649ffb9a204" providerId="ADAL" clId="{27F4626A-F3D0-4E6C-A104-AEA19FA55BBA}" dt="2026-07-02T21:31:41.065" v="4625" actId="207"/>
-          <ac:spMkLst>
-            <pc:docMk/>
-            <pc:sldMk cId="4026648288" sldId="290"/>
-            <ac:spMk id="47" creationId="{B937E3BA-6427-83D0-8112-A9278A63FEAC}"/>
-          </ac:spMkLst>
-        </pc:spChg>
-        <pc:spChg chg="add mod">
-          <ac:chgData name="Brayand Javier Gómez Plata" userId="c9c1396e-34a9-4a12-912a-8649ffb9a204" providerId="ADAL" clId="{27F4626A-F3D0-4E6C-A104-AEA19FA55BBA}" dt="2026-07-02T21:31:13.680" v="4618" actId="164"/>
-          <ac:spMkLst>
-            <pc:docMk/>
-            <pc:sldMk cId="4026648288" sldId="290"/>
-            <ac:spMk id="51" creationId="{9D3A5D56-EC22-D7FC-5422-47A0324F2645}"/>
-          </ac:spMkLst>
-        </pc:spChg>
-        <pc:spChg chg="add del">
-          <ac:chgData name="Brayand Javier Gómez Plata" userId="c9c1396e-34a9-4a12-912a-8649ffb9a204" providerId="ADAL" clId="{27F4626A-F3D0-4E6C-A104-AEA19FA55BBA}" dt="2026-07-02T21:37:10.435" v="4665" actId="22"/>
-          <ac:spMkLst>
-            <pc:docMk/>
-            <pc:sldMk cId="4026648288" sldId="290"/>
-            <ac:spMk id="59" creationId="{4A8FD895-C4EB-D668-EB3E-07952092499B}"/>
           </ac:spMkLst>
         </pc:spChg>
         <pc:spChg chg="add mod">
@@ -4567,22 +2814,6 @@
             <ac:spMk id="455" creationId="{80E595F9-157E-BE15-048B-388A0CECD543}"/>
           </ac:spMkLst>
         </pc:spChg>
-        <pc:grpChg chg="del mod">
-          <ac:chgData name="Brayand Javier Gómez Plata" userId="c9c1396e-34a9-4a12-912a-8649ffb9a204" providerId="ADAL" clId="{27F4626A-F3D0-4E6C-A104-AEA19FA55BBA}" dt="2026-07-02T21:32:50.642" v="4632" actId="478"/>
-          <ac:grpSpMkLst>
-            <pc:docMk/>
-            <pc:sldMk cId="4026648288" sldId="290"/>
-            <ac:grpSpMk id="54" creationId="{28687A4C-18FD-1026-213C-A499720C005C}"/>
-          </ac:grpSpMkLst>
-        </pc:grpChg>
-        <pc:grpChg chg="del">
-          <ac:chgData name="Brayand Javier Gómez Plata" userId="c9c1396e-34a9-4a12-912a-8649ffb9a204" providerId="ADAL" clId="{27F4626A-F3D0-4E6C-A104-AEA19FA55BBA}" dt="2026-07-02T21:31:07.608" v="4616" actId="478"/>
-          <ac:grpSpMkLst>
-            <pc:docMk/>
-            <pc:sldMk cId="4026648288" sldId="290"/>
-            <ac:grpSpMk id="655" creationId="{01007FEE-63A4-15C2-AE45-867F067CF816}"/>
-          </ac:grpSpMkLst>
-        </pc:grpChg>
         <pc:graphicFrameChg chg="add mod modGraphic">
           <ac:chgData name="Brayand Javier Gómez Plata" userId="c9c1396e-34a9-4a12-912a-8649ffb9a204" providerId="ADAL" clId="{27F4626A-F3D0-4E6C-A104-AEA19FA55BBA}" dt="2026-07-03T16:28:10.336" v="5010" actId="790"/>
           <ac:graphicFrameMkLst>
@@ -26853,7 +25084,7 @@
         </p:nvGrpSpPr>
         <p:grpSpPr>
           <a:xfrm>
-            <a:off x="2062004" y="2394992"/>
+            <a:off x="1898191" y="2319062"/>
             <a:ext cx="6106635" cy="2161768"/>
             <a:chOff x="347472" y="1371600"/>
             <a:chExt cx="8284464" cy="2651760"/>
@@ -28550,7 +26781,7 @@
         </p:nvGrpSpPr>
         <p:grpSpPr>
           <a:xfrm>
-            <a:off x="2186940" y="1732604"/>
+            <a:off x="1987329" y="1664985"/>
             <a:ext cx="5928360" cy="2644140"/>
             <a:chOff x="457200" y="1325880"/>
             <a:chExt cx="8321040" cy="3383280"/>
@@ -29432,7 +27663,7 @@
         </p:nvGrpSpPr>
         <p:grpSpPr>
           <a:xfrm>
-            <a:off x="349133" y="868679"/>
+            <a:off x="499916" y="939800"/>
             <a:ext cx="7772401" cy="3629822"/>
             <a:chOff x="274320" y="822960"/>
             <a:chExt cx="8549640" cy="4005072"/>
@@ -31394,7 +29625,7 @@
         </p:nvGrpSpPr>
         <p:grpSpPr>
           <a:xfrm>
-            <a:off x="411480" y="822960"/>
+            <a:off x="499918" y="886331"/>
             <a:ext cx="7772400" cy="3675541"/>
             <a:chOff x="411480" y="822960"/>
             <a:chExt cx="8439912" cy="3977640"/>

</xml_diff>